<commit_message>
Version 3.0 en fait
</commit_message>
<xml_diff>
--- a/Fiches de personnage.pptx
+++ b/Fiches de personnage.pptx
@@ -139,7 +139,7 @@
       </p:grpSpPr>
       <p:sp>
         <p:nvSpPr>
-          <p:cNvPr id="1882178426" name="Espace réservé d'en-tête 1"/>
+          <p:cNvPr id="2040666693" name="Espace réservé d'en-tête 1"/>
           <p:cNvSpPr>
             <a:spLocks noGrp="1"/>
           </p:cNvSpPr>
@@ -173,7 +173,7 @@
       </p:sp>
       <p:sp>
         <p:nvSpPr>
-          <p:cNvPr id="1178178499" name="Espace réservé pour la date 2"/>
+          <p:cNvPr id="1572029216" name="Espace réservé pour la date 2"/>
           <p:cNvSpPr>
             <a:spLocks noGrp="1"/>
           </p:cNvSpPr>
@@ -211,7 +211,7 @@
       </p:sp>
       <p:sp>
         <p:nvSpPr>
-          <p:cNvPr id="2044345824" name="Espace réservé pour l'image de la diapositive 3"/>
+          <p:cNvPr id="462002510" name="Espace réservé pour l'image de la diapositive 3"/>
           <p:cNvSpPr>
             <a:spLocks noChangeAspect="1" noGrp="1" noRot="1"/>
           </p:cNvSpPr>
@@ -247,7 +247,7 @@
       </p:sp>
       <p:sp>
         <p:nvSpPr>
-          <p:cNvPr id="1156600170" name="Remarques Espace réservé 4"/>
+          <p:cNvPr id="890498024" name="Remarques Espace réservé 4"/>
           <p:cNvSpPr>
             <a:spLocks noGrp="1"/>
           </p:cNvSpPr>
@@ -321,7 +321,7 @@
       </p:sp>
       <p:sp>
         <p:nvSpPr>
-          <p:cNvPr id="2045142639" name="Espace réservé du pied de page 5"/>
+          <p:cNvPr id="1196606101" name="Espace réservé du pied de page 5"/>
           <p:cNvSpPr>
             <a:spLocks noGrp="1"/>
           </p:cNvSpPr>
@@ -355,7 +355,7 @@
       </p:sp>
       <p:sp>
         <p:nvSpPr>
-          <p:cNvPr id="910667669" name="Espace réservé du numéro de diapositive 6"/>
+          <p:cNvPr id="1602332169" name="Espace réservé du numéro de diapositive 6"/>
           <p:cNvSpPr>
             <a:spLocks noGrp="1"/>
           </p:cNvSpPr>
@@ -508,7 +508,7 @@
       </p:grpSpPr>
       <p:sp>
         <p:nvSpPr>
-          <p:cNvPr id="1678985713" name="Espace réservé pour l'image de la diapositive 1"/>
+          <p:cNvPr id="747912810" name="Espace réservé pour l'image de la diapositive 1"/>
           <p:cNvSpPr>
             <a:spLocks noChangeAspect="1" noGrp="1" noRot="1"/>
           </p:cNvSpPr>
@@ -525,7 +525,7 @@
       </p:sp>
       <p:sp>
         <p:nvSpPr>
-          <p:cNvPr id="785086760" name="Remarques Espace réservé 2"/>
+          <p:cNvPr id="1125423406" name="Remarques Espace réservé 2"/>
           <p:cNvSpPr>
             <a:spLocks noGrp="1"/>
           </p:cNvSpPr>
@@ -550,7 +550,7 @@
       </p:sp>
       <p:sp>
         <p:nvSpPr>
-          <p:cNvPr id="287783116" name="Espace réservé pour le numéro de diapositive 3"/>
+          <p:cNvPr id="743289646" name="Espace réservé pour le numéro de diapositive 3"/>
           <p:cNvSpPr>
             <a:spLocks noGrp="1"/>
           </p:cNvSpPr>
@@ -601,7 +601,7 @@
       </p:grpSpPr>
       <p:sp>
         <p:nvSpPr>
-          <p:cNvPr id="760282113" name="Espace réservé pour l'image de la diapositive 1"/>
+          <p:cNvPr id="1390273845" name="Espace réservé pour l'image de la diapositive 1"/>
           <p:cNvSpPr>
             <a:spLocks noChangeAspect="1" noGrp="1" noRot="1"/>
           </p:cNvSpPr>
@@ -618,7 +618,7 @@
       </p:sp>
       <p:sp>
         <p:nvSpPr>
-          <p:cNvPr id="1373085923" name="Remarques Espace réservé 2"/>
+          <p:cNvPr id="1907755220" name="Remarques Espace réservé 2"/>
           <p:cNvSpPr>
             <a:spLocks noGrp="1"/>
           </p:cNvSpPr>
@@ -643,7 +643,7 @@
       </p:sp>
       <p:sp>
         <p:nvSpPr>
-          <p:cNvPr id="487089650" name="Espace réservé pour le numéro de diapositive 3"/>
+          <p:cNvPr id="391906385" name="Espace réservé pour le numéro de diapositive 3"/>
           <p:cNvSpPr>
             <a:spLocks noGrp="1"/>
           </p:cNvSpPr>
@@ -694,7 +694,7 @@
       </p:grpSpPr>
       <p:sp>
         <p:nvSpPr>
-          <p:cNvPr id="474132245" name="Espace réservé pour l'image de la diapositive 1"/>
+          <p:cNvPr id="1130117418" name="Espace réservé pour l'image de la diapositive 1"/>
           <p:cNvSpPr>
             <a:spLocks noChangeAspect="1" noGrp="1" noRot="1"/>
           </p:cNvSpPr>
@@ -711,7 +711,7 @@
       </p:sp>
       <p:sp>
         <p:nvSpPr>
-          <p:cNvPr id="1722381857" name="Remarques Espace réservé 2"/>
+          <p:cNvPr id="1547802792" name="Remarques Espace réservé 2"/>
           <p:cNvSpPr>
             <a:spLocks noGrp="1"/>
           </p:cNvSpPr>
@@ -736,7 +736,7 @@
       </p:sp>
       <p:sp>
         <p:nvSpPr>
-          <p:cNvPr id="2105043950" name="Espace réservé pour le numéro de diapositive 3"/>
+          <p:cNvPr id="368834759" name="Espace réservé pour le numéro de diapositive 3"/>
           <p:cNvSpPr>
             <a:spLocks noGrp="1"/>
           </p:cNvSpPr>
@@ -787,7 +787,7 @@
       </p:grpSpPr>
       <p:sp>
         <p:nvSpPr>
-          <p:cNvPr id="1394914919" name="Espace réservé pour l'image de la diapositive 1"/>
+          <p:cNvPr id="681177182" name="Espace réservé pour l'image de la diapositive 1"/>
           <p:cNvSpPr>
             <a:spLocks noChangeAspect="1" noGrp="1" noRot="1"/>
           </p:cNvSpPr>
@@ -804,7 +804,7 @@
       </p:sp>
       <p:sp>
         <p:nvSpPr>
-          <p:cNvPr id="1831331311" name="Remarques Espace réservé 2"/>
+          <p:cNvPr id="638498131" name="Remarques Espace réservé 2"/>
           <p:cNvSpPr>
             <a:spLocks noGrp="1"/>
           </p:cNvSpPr>
@@ -829,7 +829,7 @@
       </p:sp>
       <p:sp>
         <p:nvSpPr>
-          <p:cNvPr id="1829595989" name="Espace réservé pour le numéro de diapositive 3"/>
+          <p:cNvPr id="1036385960" name="Espace réservé pour le numéro de diapositive 3"/>
           <p:cNvSpPr>
             <a:spLocks noGrp="1"/>
           </p:cNvSpPr>
@@ -880,7 +880,7 @@
       </p:grpSpPr>
       <p:sp>
         <p:nvSpPr>
-          <p:cNvPr id="738808738" name="Espace réservé pour l'image de la diapositive 1"/>
+          <p:cNvPr id="1377271674" name="Espace réservé pour l'image de la diapositive 1"/>
           <p:cNvSpPr>
             <a:spLocks noChangeAspect="1" noGrp="1" noRot="1"/>
           </p:cNvSpPr>
@@ -897,7 +897,7 @@
       </p:sp>
       <p:sp>
         <p:nvSpPr>
-          <p:cNvPr id="735544349" name="Remarques Espace réservé 2"/>
+          <p:cNvPr id="2043678491" name="Remarques Espace réservé 2"/>
           <p:cNvSpPr>
             <a:spLocks noGrp="1"/>
           </p:cNvSpPr>
@@ -922,7 +922,7 @@
       </p:sp>
       <p:sp>
         <p:nvSpPr>
-          <p:cNvPr id="18655242" name="Espace réservé pour le numéro de diapositive 3"/>
+          <p:cNvPr id="1515951974" name="Espace réservé pour le numéro de diapositive 3"/>
           <p:cNvSpPr>
             <a:spLocks noGrp="1"/>
           </p:cNvSpPr>
@@ -973,7 +973,7 @@
       </p:grpSpPr>
       <p:sp>
         <p:nvSpPr>
-          <p:cNvPr id="310474032" name="Espace réservé pour l'image de la diapositive 1"/>
+          <p:cNvPr id="790150836" name="Espace réservé pour l'image de la diapositive 1"/>
           <p:cNvSpPr>
             <a:spLocks noChangeAspect="1" noGrp="1" noRot="1"/>
           </p:cNvSpPr>
@@ -990,7 +990,7 @@
       </p:sp>
       <p:sp>
         <p:nvSpPr>
-          <p:cNvPr id="202671637" name="Remarques Espace réservé 2"/>
+          <p:cNvPr id="354425994" name="Remarques Espace réservé 2"/>
           <p:cNvSpPr>
             <a:spLocks noGrp="1"/>
           </p:cNvSpPr>
@@ -1015,7 +1015,7 @@
       </p:sp>
       <p:sp>
         <p:nvSpPr>
-          <p:cNvPr id="996940566" name="Espace réservé pour le numéro de diapositive 3"/>
+          <p:cNvPr id="511401180" name="Espace réservé pour le numéro de diapositive 3"/>
           <p:cNvSpPr>
             <a:spLocks noGrp="1"/>
           </p:cNvSpPr>
@@ -1066,7 +1066,7 @@
       </p:grpSpPr>
       <p:sp>
         <p:nvSpPr>
-          <p:cNvPr id="558189616" name="Titre 1"/>
+          <p:cNvPr id="314970116" name="Titre 1"/>
           <p:cNvSpPr>
             <a:spLocks noGrp="1"/>
           </p:cNvSpPr>
@@ -1101,7 +1101,7 @@
       </p:sp>
       <p:sp>
         <p:nvSpPr>
-          <p:cNvPr id="414177799" name="Sous-titre 2"/>
+          <p:cNvPr id="144678903" name="Sous-titre 2"/>
           <p:cNvSpPr>
             <a:spLocks noGrp="1"/>
           </p:cNvSpPr>
@@ -1169,7 +1169,7 @@
       </p:sp>
       <p:sp>
         <p:nvSpPr>
-          <p:cNvPr id="251713442" name="Espace réservé de la date 3"/>
+          <p:cNvPr id="1932473164" name="Espace réservé de la date 3"/>
           <p:cNvSpPr>
             <a:spLocks noGrp="1"/>
           </p:cNvSpPr>
@@ -1195,7 +1195,7 @@
       </p:sp>
       <p:sp>
         <p:nvSpPr>
-          <p:cNvPr id="416733969" name="Espace réservé du pied de page 4"/>
+          <p:cNvPr id="1398734857" name="Espace réservé du pied de page 4"/>
           <p:cNvSpPr>
             <a:spLocks noGrp="1"/>
           </p:cNvSpPr>
@@ -1217,7 +1217,7 @@
       </p:sp>
       <p:sp>
         <p:nvSpPr>
-          <p:cNvPr id="985561519" name="Espace réservé du numéro de diapositive 5"/>
+          <p:cNvPr id="1614580790" name="Espace réservé du numéro de diapositive 5"/>
           <p:cNvSpPr>
             <a:spLocks noGrp="1"/>
           </p:cNvSpPr>
@@ -1268,7 +1268,7 @@
       </p:grpSpPr>
       <p:sp>
         <p:nvSpPr>
-          <p:cNvPr id="1687982084" name="Titre 1"/>
+          <p:cNvPr id="198483966" name="Titre 1"/>
           <p:cNvSpPr>
             <a:spLocks noGrp="1"/>
           </p:cNvSpPr>
@@ -1294,7 +1294,7 @@
       </p:sp>
       <p:sp>
         <p:nvSpPr>
-          <p:cNvPr id="106436850" name="Espace réservé du texte vertical 2"/>
+          <p:cNvPr id="1303095560" name="Espace réservé du texte vertical 2"/>
           <p:cNvSpPr>
             <a:spLocks noGrp="1"/>
           </p:cNvSpPr>
@@ -1360,7 +1360,7 @@
       </p:sp>
       <p:sp>
         <p:nvSpPr>
-          <p:cNvPr id="49072126" name="Espace réservé de la date 3"/>
+          <p:cNvPr id="680300301" name="Espace réservé de la date 3"/>
           <p:cNvSpPr>
             <a:spLocks noGrp="1"/>
           </p:cNvSpPr>
@@ -1386,7 +1386,7 @@
       </p:sp>
       <p:sp>
         <p:nvSpPr>
-          <p:cNvPr id="279924206" name="Espace réservé du pied de page 4"/>
+          <p:cNvPr id="477322645" name="Espace réservé du pied de page 4"/>
           <p:cNvSpPr>
             <a:spLocks noGrp="1"/>
           </p:cNvSpPr>
@@ -1408,7 +1408,7 @@
       </p:sp>
       <p:sp>
         <p:nvSpPr>
-          <p:cNvPr id="1850354030" name="Espace réservé du numéro de diapositive 5"/>
+          <p:cNvPr id="569026755" name="Espace réservé du numéro de diapositive 5"/>
           <p:cNvSpPr>
             <a:spLocks noGrp="1"/>
           </p:cNvSpPr>
@@ -1459,7 +1459,7 @@
       </p:grpSpPr>
       <p:sp>
         <p:nvSpPr>
-          <p:cNvPr id="1904798361" name="Titre vertical 1"/>
+          <p:cNvPr id="188799116" name="Titre vertical 1"/>
           <p:cNvSpPr>
             <a:spLocks noGrp="1"/>
           </p:cNvSpPr>
@@ -1490,7 +1490,7 @@
       </p:sp>
       <p:sp>
         <p:nvSpPr>
-          <p:cNvPr id="1313611520" name="Espace réservé du texte vertical 2"/>
+          <p:cNvPr id="1831909756" name="Espace réservé du texte vertical 2"/>
           <p:cNvSpPr>
             <a:spLocks noGrp="1"/>
           </p:cNvSpPr>
@@ -1561,7 +1561,7 @@
       </p:sp>
       <p:sp>
         <p:nvSpPr>
-          <p:cNvPr id="1387792319" name="Espace réservé de la date 3"/>
+          <p:cNvPr id="1087312334" name="Espace réservé de la date 3"/>
           <p:cNvSpPr>
             <a:spLocks noGrp="1"/>
           </p:cNvSpPr>
@@ -1587,7 +1587,7 @@
       </p:sp>
       <p:sp>
         <p:nvSpPr>
-          <p:cNvPr id="593748649" name="Espace réservé du pied de page 4"/>
+          <p:cNvPr id="1571959307" name="Espace réservé du pied de page 4"/>
           <p:cNvSpPr>
             <a:spLocks noGrp="1"/>
           </p:cNvSpPr>
@@ -1609,7 +1609,7 @@
       </p:sp>
       <p:sp>
         <p:nvSpPr>
-          <p:cNvPr id="1982763948" name="Espace réservé du numéro de diapositive 5"/>
+          <p:cNvPr id="573739372" name="Espace réservé du numéro de diapositive 5"/>
           <p:cNvSpPr>
             <a:spLocks noGrp="1"/>
           </p:cNvSpPr>
@@ -1660,7 +1660,7 @@
       </p:grpSpPr>
       <p:sp>
         <p:nvSpPr>
-          <p:cNvPr id="1385489598" name="Titre 1"/>
+          <p:cNvPr id="510780619" name="Titre 1"/>
           <p:cNvSpPr>
             <a:spLocks noGrp="1"/>
           </p:cNvSpPr>
@@ -1686,7 +1686,7 @@
       </p:sp>
       <p:sp>
         <p:nvSpPr>
-          <p:cNvPr id="1649293310" name="Espace réservé du contenu 2"/>
+          <p:cNvPr id="1788805616" name="Espace réservé du contenu 2"/>
           <p:cNvSpPr>
             <a:spLocks noGrp="1"/>
           </p:cNvSpPr>
@@ -1752,7 +1752,7 @@
       </p:sp>
       <p:sp>
         <p:nvSpPr>
-          <p:cNvPr id="907960888" name="Espace réservé de la date 3"/>
+          <p:cNvPr id="900364658" name="Espace réservé de la date 3"/>
           <p:cNvSpPr>
             <a:spLocks noGrp="1"/>
           </p:cNvSpPr>
@@ -1778,7 +1778,7 @@
       </p:sp>
       <p:sp>
         <p:nvSpPr>
-          <p:cNvPr id="843242738" name="Espace réservé du pied de page 4"/>
+          <p:cNvPr id="1654042181" name="Espace réservé du pied de page 4"/>
           <p:cNvSpPr>
             <a:spLocks noGrp="1"/>
           </p:cNvSpPr>
@@ -1800,7 +1800,7 @@
       </p:sp>
       <p:sp>
         <p:nvSpPr>
-          <p:cNvPr id="674920304" name="Espace réservé du numéro de diapositive 5"/>
+          <p:cNvPr id="2057026300" name="Espace réservé du numéro de diapositive 5"/>
           <p:cNvSpPr>
             <a:spLocks noGrp="1"/>
           </p:cNvSpPr>
@@ -1851,7 +1851,7 @@
       </p:grpSpPr>
       <p:sp>
         <p:nvSpPr>
-          <p:cNvPr id="1947220028" name="Titre 1"/>
+          <p:cNvPr id="979374322" name="Titre 1"/>
           <p:cNvSpPr>
             <a:spLocks noGrp="1"/>
           </p:cNvSpPr>
@@ -1886,7 +1886,7 @@
       </p:sp>
       <p:sp>
         <p:nvSpPr>
-          <p:cNvPr id="1471853232" name="Espace réservé du texte 2"/>
+          <p:cNvPr id="1152925210" name="Espace réservé du texte 2"/>
           <p:cNvSpPr>
             <a:spLocks noGrp="1"/>
           </p:cNvSpPr>
@@ -2008,7 +2008,7 @@
       </p:sp>
       <p:sp>
         <p:nvSpPr>
-          <p:cNvPr id="2024152615" name="Espace réservé de la date 3"/>
+          <p:cNvPr id="361113608" name="Espace réservé de la date 3"/>
           <p:cNvSpPr>
             <a:spLocks noGrp="1"/>
           </p:cNvSpPr>
@@ -2034,7 +2034,7 @@
       </p:sp>
       <p:sp>
         <p:nvSpPr>
-          <p:cNvPr id="76345141" name="Espace réservé du pied de page 4"/>
+          <p:cNvPr id="1991613578" name="Espace réservé du pied de page 4"/>
           <p:cNvSpPr>
             <a:spLocks noGrp="1"/>
           </p:cNvSpPr>
@@ -2056,7 +2056,7 @@
       </p:sp>
       <p:sp>
         <p:nvSpPr>
-          <p:cNvPr id="931831762" name="Espace réservé du numéro de diapositive 5"/>
+          <p:cNvPr id="2090687442" name="Espace réservé du numéro de diapositive 5"/>
           <p:cNvSpPr>
             <a:spLocks noGrp="1"/>
           </p:cNvSpPr>
@@ -2107,7 +2107,7 @@
       </p:grpSpPr>
       <p:sp>
         <p:nvSpPr>
-          <p:cNvPr id="1883880562" name="Titre 1"/>
+          <p:cNvPr id="1399988215" name="Titre 1"/>
           <p:cNvSpPr>
             <a:spLocks noGrp="1"/>
           </p:cNvSpPr>
@@ -2133,7 +2133,7 @@
       </p:sp>
       <p:sp>
         <p:nvSpPr>
-          <p:cNvPr id="1745825645" name="Espace réservé du contenu 2"/>
+          <p:cNvPr id="1817419386" name="Espace réservé du contenu 2"/>
           <p:cNvSpPr>
             <a:spLocks noGrp="1"/>
           </p:cNvSpPr>
@@ -2204,7 +2204,7 @@
       </p:sp>
       <p:sp>
         <p:nvSpPr>
-          <p:cNvPr id="2140528698" name="Espace réservé du contenu 3"/>
+          <p:cNvPr id="2003741434" name="Espace réservé du contenu 3"/>
           <p:cNvSpPr>
             <a:spLocks noGrp="1"/>
           </p:cNvSpPr>
@@ -2275,7 +2275,7 @@
       </p:sp>
       <p:sp>
         <p:nvSpPr>
-          <p:cNvPr id="1113313262" name="Espace réservé de la date 4"/>
+          <p:cNvPr id="875739953" name="Espace réservé de la date 4"/>
           <p:cNvSpPr>
             <a:spLocks noGrp="1"/>
           </p:cNvSpPr>
@@ -2301,7 +2301,7 @@
       </p:sp>
       <p:sp>
         <p:nvSpPr>
-          <p:cNvPr id="628715013" name="Espace réservé du pied de page 5"/>
+          <p:cNvPr id="1022071695" name="Espace réservé du pied de page 5"/>
           <p:cNvSpPr>
             <a:spLocks noGrp="1"/>
           </p:cNvSpPr>
@@ -2323,7 +2323,7 @@
       </p:sp>
       <p:sp>
         <p:nvSpPr>
-          <p:cNvPr id="904081603" name="Espace réservé du numéro de diapositive 6"/>
+          <p:cNvPr id="1055233315" name="Espace réservé du numéro de diapositive 6"/>
           <p:cNvSpPr>
             <a:spLocks noGrp="1"/>
           </p:cNvSpPr>
@@ -2374,7 +2374,7 @@
       </p:grpSpPr>
       <p:sp>
         <p:nvSpPr>
-          <p:cNvPr id="501653835" name="Titre 1"/>
+          <p:cNvPr id="110596012" name="Titre 1"/>
           <p:cNvSpPr>
             <a:spLocks noGrp="1"/>
           </p:cNvSpPr>
@@ -2405,7 +2405,7 @@
       </p:sp>
       <p:sp>
         <p:nvSpPr>
-          <p:cNvPr id="738729152" name="Espace réservé du texte 2"/>
+          <p:cNvPr id="1088804505" name="Espace réservé du texte 2"/>
           <p:cNvSpPr>
             <a:spLocks noGrp="1"/>
           </p:cNvSpPr>
@@ -2473,7 +2473,7 @@
       </p:sp>
       <p:sp>
         <p:nvSpPr>
-          <p:cNvPr id="1575257793" name="Espace réservé du contenu 3"/>
+          <p:cNvPr id="1186543842" name="Espace réservé du contenu 3"/>
           <p:cNvSpPr>
             <a:spLocks noGrp="1"/>
           </p:cNvSpPr>
@@ -2544,7 +2544,7 @@
       </p:sp>
       <p:sp>
         <p:nvSpPr>
-          <p:cNvPr id="1760239665" name="Espace réservé du texte 4"/>
+          <p:cNvPr id="1026937471" name="Espace réservé du texte 4"/>
           <p:cNvSpPr>
             <a:spLocks noGrp="1"/>
           </p:cNvSpPr>
@@ -2612,7 +2612,7 @@
       </p:sp>
       <p:sp>
         <p:nvSpPr>
-          <p:cNvPr id="372917692" name="Espace réservé du contenu 5"/>
+          <p:cNvPr id="466270696" name="Espace réservé du contenu 5"/>
           <p:cNvSpPr>
             <a:spLocks noGrp="1"/>
           </p:cNvSpPr>
@@ -2683,7 +2683,7 @@
       </p:sp>
       <p:sp>
         <p:nvSpPr>
-          <p:cNvPr id="1939686315" name="Espace réservé de la date 6"/>
+          <p:cNvPr id="1946345847" name="Espace réservé de la date 6"/>
           <p:cNvSpPr>
             <a:spLocks noGrp="1"/>
           </p:cNvSpPr>
@@ -2709,7 +2709,7 @@
       </p:sp>
       <p:sp>
         <p:nvSpPr>
-          <p:cNvPr id="1752389350" name="Espace réservé du pied de page 7"/>
+          <p:cNvPr id="944280402" name="Espace réservé du pied de page 7"/>
           <p:cNvSpPr>
             <a:spLocks noGrp="1"/>
           </p:cNvSpPr>
@@ -2731,7 +2731,7 @@
       </p:sp>
       <p:sp>
         <p:nvSpPr>
-          <p:cNvPr id="944197296" name="Espace réservé du numéro de diapositive 8"/>
+          <p:cNvPr id="1476641285" name="Espace réservé du numéro de diapositive 8"/>
           <p:cNvSpPr>
             <a:spLocks noGrp="1"/>
           </p:cNvSpPr>
@@ -2782,7 +2782,7 @@
       </p:grpSpPr>
       <p:sp>
         <p:nvSpPr>
-          <p:cNvPr id="1703684044" name="Titre 1"/>
+          <p:cNvPr id="364799974" name="Titre 1"/>
           <p:cNvSpPr>
             <a:spLocks noGrp="1"/>
           </p:cNvSpPr>
@@ -2808,7 +2808,7 @@
       </p:sp>
       <p:sp>
         <p:nvSpPr>
-          <p:cNvPr id="362334234" name="Espace réservé de la date 2"/>
+          <p:cNvPr id="680378980" name="Espace réservé de la date 2"/>
           <p:cNvSpPr>
             <a:spLocks noGrp="1"/>
           </p:cNvSpPr>
@@ -2834,7 +2834,7 @@
       </p:sp>
       <p:sp>
         <p:nvSpPr>
-          <p:cNvPr id="731021578" name="Espace réservé du pied de page 3"/>
+          <p:cNvPr id="863415358" name="Espace réservé du pied de page 3"/>
           <p:cNvSpPr>
             <a:spLocks noGrp="1"/>
           </p:cNvSpPr>
@@ -2856,7 +2856,7 @@
       </p:sp>
       <p:sp>
         <p:nvSpPr>
-          <p:cNvPr id="844324523" name="Espace réservé du numéro de diapositive 4"/>
+          <p:cNvPr id="545835428" name="Espace réservé du numéro de diapositive 4"/>
           <p:cNvSpPr>
             <a:spLocks noGrp="1"/>
           </p:cNvSpPr>
@@ -2907,7 +2907,7 @@
       </p:grpSpPr>
       <p:sp>
         <p:nvSpPr>
-          <p:cNvPr id="929309128" name="Espace réservé de la date 1"/>
+          <p:cNvPr id="248482896" name="Espace réservé de la date 1"/>
           <p:cNvSpPr>
             <a:spLocks noGrp="1"/>
           </p:cNvSpPr>
@@ -2933,7 +2933,7 @@
       </p:sp>
       <p:sp>
         <p:nvSpPr>
-          <p:cNvPr id="1789839483" name="Espace réservé du pied de page 2"/>
+          <p:cNvPr id="1753976020" name="Espace réservé du pied de page 2"/>
           <p:cNvSpPr>
             <a:spLocks noGrp="1"/>
           </p:cNvSpPr>
@@ -2955,7 +2955,7 @@
       </p:sp>
       <p:sp>
         <p:nvSpPr>
-          <p:cNvPr id="1766040998" name="Espace réservé du numéro de diapositive 3"/>
+          <p:cNvPr id="957574731" name="Espace réservé du numéro de diapositive 3"/>
           <p:cNvSpPr>
             <a:spLocks noGrp="1"/>
           </p:cNvSpPr>
@@ -3006,7 +3006,7 @@
       </p:grpSpPr>
       <p:sp>
         <p:nvSpPr>
-          <p:cNvPr id="425663145" name="Titre 1"/>
+          <p:cNvPr id="2017085882" name="Titre 1"/>
           <p:cNvSpPr>
             <a:spLocks noGrp="1"/>
           </p:cNvSpPr>
@@ -3041,7 +3041,7 @@
       </p:sp>
       <p:sp>
         <p:nvSpPr>
-          <p:cNvPr id="1578457474" name="Espace réservé du contenu 2"/>
+          <p:cNvPr id="258380514" name="Espace réservé du contenu 2"/>
           <p:cNvSpPr>
             <a:spLocks noGrp="1"/>
           </p:cNvSpPr>
@@ -3140,7 +3140,7 @@
       </p:sp>
       <p:sp>
         <p:nvSpPr>
-          <p:cNvPr id="858983078" name="Espace réservé du texte 3"/>
+          <p:cNvPr id="2057236931" name="Espace réservé du texte 3"/>
           <p:cNvSpPr>
             <a:spLocks noGrp="1"/>
           </p:cNvSpPr>
@@ -3208,7 +3208,7 @@
       </p:sp>
       <p:sp>
         <p:nvSpPr>
-          <p:cNvPr id="372892862" name="Espace réservé de la date 4"/>
+          <p:cNvPr id="347406851" name="Espace réservé de la date 4"/>
           <p:cNvSpPr>
             <a:spLocks noGrp="1"/>
           </p:cNvSpPr>
@@ -3234,7 +3234,7 @@
       </p:sp>
       <p:sp>
         <p:nvSpPr>
-          <p:cNvPr id="326343801" name="Espace réservé du pied de page 5"/>
+          <p:cNvPr id="217652191" name="Espace réservé du pied de page 5"/>
           <p:cNvSpPr>
             <a:spLocks noGrp="1"/>
           </p:cNvSpPr>
@@ -3256,7 +3256,7 @@
       </p:sp>
       <p:sp>
         <p:nvSpPr>
-          <p:cNvPr id="545950065" name="Espace réservé du numéro de diapositive 6"/>
+          <p:cNvPr id="1700504212" name="Espace réservé du numéro de diapositive 6"/>
           <p:cNvSpPr>
             <a:spLocks noGrp="1"/>
           </p:cNvSpPr>
@@ -3307,7 +3307,7 @@
       </p:grpSpPr>
       <p:sp>
         <p:nvSpPr>
-          <p:cNvPr id="1727352917" name="Titre 1"/>
+          <p:cNvPr id="1506912933" name="Titre 1"/>
           <p:cNvSpPr>
             <a:spLocks noGrp="1"/>
           </p:cNvSpPr>
@@ -3342,7 +3342,7 @@
       </p:sp>
       <p:sp>
         <p:nvSpPr>
-          <p:cNvPr id="1935476158" name="Espace réservé pour une image 2"/>
+          <p:cNvPr id="505272274" name="Espace réservé pour une image 2"/>
           <p:cNvSpPr>
             <a:spLocks noChangeAspect="1" noGrp="1"/>
           </p:cNvSpPr>
@@ -3410,7 +3410,7 @@
       </p:sp>
       <p:sp>
         <p:nvSpPr>
-          <p:cNvPr id="1358227892" name="Espace réservé du texte 3"/>
+          <p:cNvPr id="200777869" name="Espace réservé du texte 3"/>
           <p:cNvSpPr>
             <a:spLocks noGrp="1"/>
           </p:cNvSpPr>
@@ -3478,7 +3478,7 @@
       </p:sp>
       <p:sp>
         <p:nvSpPr>
-          <p:cNvPr id="808179552" name="Espace réservé de la date 4"/>
+          <p:cNvPr id="1369608143" name="Espace réservé de la date 4"/>
           <p:cNvSpPr>
             <a:spLocks noGrp="1"/>
           </p:cNvSpPr>
@@ -3504,7 +3504,7 @@
       </p:sp>
       <p:sp>
         <p:nvSpPr>
-          <p:cNvPr id="1680068817" name="Espace réservé du pied de page 5"/>
+          <p:cNvPr id="1425883107" name="Espace réservé du pied de page 5"/>
           <p:cNvSpPr>
             <a:spLocks noGrp="1"/>
           </p:cNvSpPr>
@@ -3526,7 +3526,7 @@
       </p:sp>
       <p:sp>
         <p:nvSpPr>
-          <p:cNvPr id="599591034" name="Espace réservé du numéro de diapositive 6"/>
+          <p:cNvPr id="1446276006" name="Espace réservé du numéro de diapositive 6"/>
           <p:cNvSpPr>
             <a:spLocks noGrp="1"/>
           </p:cNvSpPr>
@@ -3582,7 +3582,7 @@
       </p:grpSpPr>
       <p:sp>
         <p:nvSpPr>
-          <p:cNvPr id="719571281" name="Espace réservé du titre 1"/>
+          <p:cNvPr id="678136126" name="Espace réservé du titre 1"/>
           <p:cNvSpPr>
             <a:spLocks noGrp="1"/>
           </p:cNvSpPr>
@@ -3618,7 +3618,7 @@
       </p:sp>
       <p:sp>
         <p:nvSpPr>
-          <p:cNvPr id="1489779153" name="Espace réservé du texte 2"/>
+          <p:cNvPr id="1287926911" name="Espace réservé du texte 2"/>
           <p:cNvSpPr>
             <a:spLocks noGrp="1"/>
           </p:cNvSpPr>
@@ -3694,7 +3694,7 @@
       </p:sp>
       <p:sp>
         <p:nvSpPr>
-          <p:cNvPr id="1966787215" name="Espace réservé de la date 3"/>
+          <p:cNvPr id="1182210001" name="Espace réservé de la date 3"/>
           <p:cNvSpPr>
             <a:spLocks noGrp="1"/>
           </p:cNvSpPr>
@@ -3738,7 +3738,7 @@
       </p:sp>
       <p:sp>
         <p:nvSpPr>
-          <p:cNvPr id="1485288775" name="Espace réservé du pied de page 4"/>
+          <p:cNvPr id="672993085" name="Espace réservé du pied de page 4"/>
           <p:cNvSpPr>
             <a:spLocks noGrp="1"/>
           </p:cNvSpPr>
@@ -3778,7 +3778,7 @@
       </p:sp>
       <p:sp>
         <p:nvSpPr>
-          <p:cNvPr id="1117715197" name="Espace réservé du numéro de diapositive 5"/>
+          <p:cNvPr id="443715021" name="Espace réservé du numéro de diapositive 5"/>
           <p:cNvSpPr>
             <a:spLocks noGrp="1"/>
           </p:cNvSpPr>
@@ -4138,7 +4138,7 @@
       </p:grpSpPr>
       <p:cxnSp>
         <p:nvCxnSpPr>
-          <p:cNvPr id="507409488" name="Connecteur droit 1568760680"/>
+          <p:cNvPr id="1532741522" name="Connecteur droit 1568760680"/>
           <p:cNvCxnSpPr/>
           <p:nvPr/>
         </p:nvCxnSpPr>
@@ -4180,7 +4180,7 @@
       </p:cxnSp>
       <p:sp>
         <p:nvSpPr>
-          <p:cNvPr id="1224542497" name="ZoneTexte 1868728971"/>
+          <p:cNvPr id="593838180" name="ZoneTexte 1868728971"/>
           <p:cNvSpPr txBox="1"/>
           <p:nvPr/>
         </p:nvSpPr>
@@ -4220,7 +4220,7 @@
       </p:sp>
       <p:cxnSp>
         <p:nvCxnSpPr>
-          <p:cNvPr id="1678038039" name="Connecteur droit 806540798"/>
+          <p:cNvPr id="1303461049" name="Connecteur droit 806540798"/>
           <p:cNvCxnSpPr/>
           <p:nvPr/>
         </p:nvCxnSpPr>
@@ -4262,7 +4262,7 @@
       </p:cxnSp>
       <p:sp>
         <p:nvSpPr>
-          <p:cNvPr id="1375667479" name="ZoneTexte 406616703"/>
+          <p:cNvPr id="1309950420" name="ZoneTexte 406616703"/>
           <p:cNvSpPr txBox="1"/>
           <p:nvPr/>
         </p:nvSpPr>
@@ -4302,7 +4302,7 @@
       </p:sp>
       <p:cxnSp>
         <p:nvCxnSpPr>
-          <p:cNvPr id="690848301" name="Connecteur droit 858914340"/>
+          <p:cNvPr id="856027309" name="Connecteur droit 858914340"/>
           <p:cNvCxnSpPr/>
           <p:nvPr/>
         </p:nvCxnSpPr>
@@ -4344,7 +4344,7 @@
       </p:cxnSp>
       <p:sp>
         <p:nvSpPr>
-          <p:cNvPr id="2006009998" name="ZoneTexte 2018177722"/>
+          <p:cNvPr id="861197053" name="ZoneTexte 2018177722"/>
           <p:cNvSpPr txBox="1"/>
           <p:nvPr/>
         </p:nvSpPr>
@@ -4391,7 +4391,7 @@
       </p:sp>
       <p:sp>
         <p:nvSpPr>
-          <p:cNvPr id="1455414506" name="ZoneTexte 519900862"/>
+          <p:cNvPr id="661093404" name="ZoneTexte 519900862"/>
           <p:cNvSpPr txBox="1"/>
           <p:nvPr/>
         </p:nvSpPr>
@@ -4653,7 +4653,7 @@
       </p:sp>
       <p:sp>
         <p:nvSpPr>
-          <p:cNvPr id="768021577" name="Rectangle : avec coins arrondis en haut 838565229"/>
+          <p:cNvPr id="345396503" name="Rectangle : avec coins arrondis en haut 838565229"/>
           <p:cNvSpPr/>
           <p:nvPr/>
         </p:nvSpPr>
@@ -4699,7 +4699,7 @@
       </p:sp>
       <p:sp>
         <p:nvSpPr>
-          <p:cNvPr id="1434167112" name="ZoneTexte 448541368"/>
+          <p:cNvPr id="896533933" name="ZoneTexte 448541368"/>
           <p:cNvSpPr txBox="1"/>
           <p:nvPr/>
         </p:nvSpPr>
@@ -4780,7 +4780,7 @@
       </p:sp>
       <p:sp>
         <p:nvSpPr>
-          <p:cNvPr id="1872558063" name="Rectangle : avec coins arrondis en haut 1165584529"/>
+          <p:cNvPr id="2139699756" name="Rectangle : avec coins arrondis en haut 1165584529"/>
           <p:cNvSpPr/>
           <p:nvPr/>
         </p:nvSpPr>
@@ -4826,7 +4826,7 @@
       </p:sp>
       <p:sp>
         <p:nvSpPr>
-          <p:cNvPr id="1049701009" name="Flèche : pentagone 1880610112"/>
+          <p:cNvPr id="667599793" name="Flèche : pentagone 1880610112"/>
           <p:cNvSpPr/>
           <p:nvPr/>
         </p:nvSpPr>
@@ -4871,7 +4871,7 @@
       </p:sp>
       <p:sp>
         <p:nvSpPr>
-          <p:cNvPr id="1418313625" name="Flèche : pentagone 446859139"/>
+          <p:cNvPr id="2086776254" name="Flèche : pentagone 446859139"/>
           <p:cNvSpPr/>
           <p:nvPr/>
         </p:nvSpPr>
@@ -4916,7 +4916,7 @@
       </p:sp>
       <p:sp>
         <p:nvSpPr>
-          <p:cNvPr id="847990409" name="Flèche : pentagone 2055848356"/>
+          <p:cNvPr id="608899272" name="Flèche : pentagone 2055848356"/>
           <p:cNvSpPr/>
           <p:nvPr/>
         </p:nvSpPr>
@@ -4961,7 +4961,7 @@
       </p:sp>
       <p:sp>
         <p:nvSpPr>
-          <p:cNvPr id="1261605472" name="Flèche : pentagone 1980093981"/>
+          <p:cNvPr id="1109948262" name="Flèche : pentagone 1980093981"/>
           <p:cNvSpPr/>
           <p:nvPr/>
         </p:nvSpPr>
@@ -5006,7 +5006,7 @@
       </p:sp>
       <p:sp>
         <p:nvSpPr>
-          <p:cNvPr id="1275476913" name="Flèche : pentagone 905284374"/>
+          <p:cNvPr id="243960226" name="Flèche : pentagone 905284374"/>
           <p:cNvSpPr/>
           <p:nvPr/>
         </p:nvSpPr>
@@ -5051,14 +5051,14 @@
       </p:sp>
       <p:sp>
         <p:nvSpPr>
-          <p:cNvPr id="218561115" name="ZoneTexte 880464430"/>
+          <p:cNvPr id="2121608420" name="ZoneTexte 880464430"/>
           <p:cNvSpPr txBox="1"/>
           <p:nvPr/>
         </p:nvSpPr>
         <p:spPr bwMode="auto">
           <a:xfrm flipH="0" flipV="0">
-            <a:off x="3019131" y="8033529"/>
-            <a:ext cx="3864879" cy="579479"/>
+            <a:off x="3170222" y="8017653"/>
+            <a:ext cx="3685709" cy="579479"/>
           </a:xfrm>
           <a:prstGeom prst="rect">
             <a:avLst/>
@@ -5071,7 +5071,7 @@
           </a:bodyPr>
           <a:lstStyle/>
           <a:p>
-            <a:pPr algn="r">
+            <a:pPr algn="l">
               <a:defRPr/>
             </a:pPr>
             <a:r>
@@ -5125,29 +5125,18 @@
                   </a:schemeClr>
                 </a:solidFill>
               </a:rPr>
-              <a:t>Après un test de résistance réussi le MJ peut vous faire cocher une case de stress. </a:t>
-            </a:r>
-            <a:r>
-              <a:rPr sz="800">
-                <a:solidFill>
-                  <a:schemeClr val="tx1">
-                    <a:lumMod val="50000"/>
-                    <a:lumOff val="50000"/>
-                  </a:schemeClr>
-                </a:solidFill>
-              </a:rPr>
-              <a:t>Si vous </a:t>
-            </a:r>
-            <a:r>
-              <a:rPr sz="800">
-                <a:solidFill>
-                  <a:schemeClr val="tx1">
-                    <a:lumMod val="50000"/>
-                    <a:lumOff val="50000"/>
-                  </a:schemeClr>
-                </a:solidFill>
-              </a:rPr>
-              <a:t>échouez</a:t>
+              <a:t>Si vous échouez à un test d’</a:t>
+            </a:r>
+            <a:r>
+              <a:rPr lang="fr-FR" sz="800" b="1">
+                <a:solidFill>
+                  <a:schemeClr val="tx1">
+                    <a:lumMod val="50000"/>
+                    <a:lumOff val="50000"/>
+                  </a:schemeClr>
+                </a:solidFill>
+              </a:rPr>
+              <a:t>épreuve</a:t>
             </a:r>
             <a:r>
               <a:rPr lang="fr-FR" sz="800">
@@ -5158,18 +5147,18 @@
                   </a:schemeClr>
                 </a:solidFill>
               </a:rPr>
-              <a:t> à un test de résistance</a:t>
-            </a:r>
-            <a:r>
-              <a:rPr sz="800">
-                <a:solidFill>
-                  <a:schemeClr val="tx1">
-                    <a:lumMod val="50000"/>
-                    <a:lumOff val="50000"/>
-                  </a:schemeClr>
-                </a:solidFill>
-              </a:rPr>
-              <a:t>, </a:t>
+              <a:t>, cochez une case de stress. Si vous réussissez à un test de </a:t>
+            </a:r>
+            <a:r>
+              <a:rPr lang="fr-FR" sz="800" b="1">
+                <a:solidFill>
+                  <a:schemeClr val="tx1">
+                    <a:lumMod val="50000"/>
+                    <a:lumOff val="50000"/>
+                  </a:schemeClr>
+                </a:solidFill>
+              </a:rPr>
+              <a:t>choc</a:t>
             </a:r>
             <a:r>
               <a:rPr lang="fr-FR" sz="800">
@@ -5180,40 +5169,29 @@
                   </a:schemeClr>
                 </a:solidFill>
               </a:rPr>
-              <a:t>vous en </a:t>
-            </a:r>
-            <a:r>
-              <a:rPr sz="800">
-                <a:solidFill>
-                  <a:schemeClr val="tx1">
-                    <a:lumMod val="50000"/>
-                    <a:lumOff val="50000"/>
-                  </a:schemeClr>
-                </a:solidFill>
-              </a:rPr>
-              <a:t>subissez</a:t>
-            </a:r>
-            <a:r>
-              <a:rPr sz="800">
-                <a:solidFill>
-                  <a:schemeClr val="tx1">
-                    <a:lumMod val="50000"/>
-                    <a:lumOff val="50000"/>
-                  </a:schemeClr>
-                </a:solidFill>
-              </a:rPr>
-              <a:t> les </a:t>
-            </a:r>
-            <a:r>
-              <a:rPr sz="800">
-                <a:solidFill>
-                  <a:schemeClr val="tx1">
-                    <a:lumMod val="50000"/>
-                    <a:lumOff val="50000"/>
-                  </a:schemeClr>
-                </a:solidFill>
-              </a:rPr>
-              <a:t>conséquences et le MJ peut vous faire cocher une case de trauma</a:t>
+              <a:t>, cochez une case de stress ; si vous échouez à un test de </a:t>
+            </a:r>
+            <a:r>
+              <a:rPr lang="fr-FR" sz="800" b="1">
+                <a:solidFill>
+                  <a:schemeClr val="tx1">
+                    <a:lumMod val="50000"/>
+                    <a:lumOff val="50000"/>
+                  </a:schemeClr>
+                </a:solidFill>
+              </a:rPr>
+              <a:t>choc</a:t>
+            </a:r>
+            <a:r>
+              <a:rPr lang="fr-FR" sz="800">
+                <a:solidFill>
+                  <a:schemeClr val="tx1">
+                    <a:lumMod val="50000"/>
+                    <a:lumOff val="50000"/>
+                  </a:schemeClr>
+                </a:solidFill>
+              </a:rPr>
+              <a:t>, cochez une case de trauma.</a:t>
             </a:r>
             <a:r>
               <a:rPr sz="800">
@@ -5232,7 +5210,7 @@
       </p:sp>
       <p:sp>
         <p:nvSpPr>
-          <p:cNvPr id="100417881" name="ZoneTexte 1302587497"/>
+          <p:cNvPr id="82992999" name="ZoneTexte 1302587497"/>
           <p:cNvSpPr txBox="1"/>
           <p:nvPr/>
         </p:nvSpPr>
@@ -5530,7 +5508,7 @@
       </p:sp>
       <p:cxnSp>
         <p:nvCxnSpPr>
-          <p:cNvPr id="464449333" name="Connecteur droit 342798987"/>
+          <p:cNvPr id="2080080959" name="Connecteur droit 342798987"/>
           <p:cNvCxnSpPr/>
           <p:nvPr/>
         </p:nvCxnSpPr>
@@ -5572,7 +5550,7 @@
       </p:cxnSp>
       <p:sp>
         <p:nvSpPr>
-          <p:cNvPr id="1591983656" name="ZoneTexte 966486802"/>
+          <p:cNvPr id="525502652" name="ZoneTexte 966486802"/>
           <p:cNvSpPr txBox="1"/>
           <p:nvPr/>
         </p:nvSpPr>
@@ -5612,7 +5590,7 @@
       </p:sp>
       <p:sp>
         <p:nvSpPr>
-          <p:cNvPr id="1400307141" name="Rectangle 38344096"/>
+          <p:cNvPr id="445801858" name="Rectangle 38344096"/>
           <p:cNvSpPr/>
           <p:nvPr/>
         </p:nvSpPr>
@@ -5652,7 +5630,7 @@
       </p:sp>
       <p:sp>
         <p:nvSpPr>
-          <p:cNvPr id="1250646240" name="Rectangle 954364527"/>
+          <p:cNvPr id="550201533" name="Rectangle 954364527"/>
           <p:cNvSpPr/>
           <p:nvPr/>
         </p:nvSpPr>
@@ -5692,7 +5670,7 @@
       </p:sp>
       <p:sp>
         <p:nvSpPr>
-          <p:cNvPr id="1452331357" name="ZoneTexte 1527388901"/>
+          <p:cNvPr id="2004992052" name="ZoneTexte 1527388901"/>
           <p:cNvSpPr txBox="1"/>
           <p:nvPr/>
         </p:nvSpPr>
@@ -5914,7 +5892,7 @@
       </p:sp>
       <p:sp>
         <p:nvSpPr>
-          <p:cNvPr id="1382511241" name="ZoneTexte 1440859034"/>
+          <p:cNvPr id="900174181" name="ZoneTexte 1440859034"/>
           <p:cNvSpPr txBox="1"/>
           <p:nvPr/>
         </p:nvSpPr>
@@ -5965,7 +5943,7 @@
       </p:sp>
       <p:cxnSp>
         <p:nvCxnSpPr>
-          <p:cNvPr id="1727206409" name="Connecteur droit 858914340"/>
+          <p:cNvPr id="1510938914" name="Connecteur droit 858914340"/>
           <p:cNvCxnSpPr/>
           <p:nvPr/>
         </p:nvCxnSpPr>
@@ -6007,7 +5985,7 @@
       </p:cxnSp>
       <p:sp>
         <p:nvSpPr>
-          <p:cNvPr id="1192019932" name="ZoneTexte 2018177722"/>
+          <p:cNvPr id="660126262" name="ZoneTexte 2018177722"/>
           <p:cNvSpPr txBox="1"/>
           <p:nvPr/>
         </p:nvSpPr>
@@ -6054,7 +6032,7 @@
       </p:sp>
       <p:sp>
         <p:nvSpPr>
-          <p:cNvPr id="1677388360" name=""/>
+          <p:cNvPr id="1579775185" name=""/>
           <p:cNvSpPr txBox="1"/>
           <p:nvPr/>
         </p:nvSpPr>
@@ -6156,7 +6134,7 @@
       </p:sp>
       <p:cxnSp>
         <p:nvCxnSpPr>
-          <p:cNvPr id="25789445" name="Connecteur droit 858914340"/>
+          <p:cNvPr id="323845804" name="Connecteur droit 858914340"/>
           <p:cNvCxnSpPr/>
           <p:nvPr/>
         </p:nvCxnSpPr>
@@ -6198,7 +6176,7 @@
       </p:cxnSp>
       <p:sp>
         <p:nvSpPr>
-          <p:cNvPr id="1476156191" name="ZoneTexte 2018177722"/>
+          <p:cNvPr id="277397206" name="ZoneTexte 2018177722"/>
           <p:cNvSpPr txBox="1"/>
           <p:nvPr/>
         </p:nvSpPr>
@@ -6256,7 +6234,7 @@
       </p:sp>
       <p:sp>
         <p:nvSpPr>
-          <p:cNvPr id="324108197" name=""/>
+          <p:cNvPr id="1071139541" name=""/>
           <p:cNvSpPr txBox="1"/>
           <p:nvPr/>
         </p:nvSpPr>
@@ -6707,7 +6685,7 @@
       </p:sp>
       <p:sp>
         <p:nvSpPr>
-          <p:cNvPr id="586684640" name="ZoneTexte 2021443538"/>
+          <p:cNvPr id="1409849097" name="ZoneTexte 2021443538"/>
           <p:cNvSpPr txBox="1"/>
           <p:nvPr/>
         </p:nvSpPr>
@@ -6791,7 +6769,7 @@
       </p:sp>
       <p:sp>
         <p:nvSpPr>
-          <p:cNvPr id="469094918" name="ZoneTexte 1075280509"/>
+          <p:cNvPr id="1010453911" name="ZoneTexte 1075280509"/>
           <p:cNvSpPr txBox="1"/>
           <p:nvPr/>
         </p:nvSpPr>
@@ -6875,7 +6853,7 @@
       </p:sp>
       <p:sp>
         <p:nvSpPr>
-          <p:cNvPr id="586342179" name="ZoneTexte 824413856"/>
+          <p:cNvPr id="817834899" name="ZoneTexte 824413856"/>
           <p:cNvSpPr txBox="1"/>
           <p:nvPr/>
         </p:nvSpPr>
@@ -6959,7 +6937,7 @@
       </p:sp>
       <p:sp>
         <p:nvSpPr>
-          <p:cNvPr id="1603150477" name="ZoneTexte 1036656844"/>
+          <p:cNvPr id="847148624" name="ZoneTexte 1036656844"/>
           <p:cNvSpPr txBox="1"/>
           <p:nvPr/>
         </p:nvSpPr>
@@ -7043,7 +7021,7 @@
       </p:sp>
       <p:sp>
         <p:nvSpPr>
-          <p:cNvPr id="82058722" name="ZoneTexte 226284734"/>
+          <p:cNvPr id="778881228" name="ZoneTexte 226284734"/>
           <p:cNvSpPr txBox="1"/>
           <p:nvPr/>
         </p:nvSpPr>
@@ -7127,7 +7105,7 @@
       </p:sp>
       <p:sp>
         <p:nvSpPr>
-          <p:cNvPr id="1462733146" name="ZoneTexte 162158187"/>
+          <p:cNvPr id="1850804362" name="ZoneTexte 162158187"/>
           <p:cNvSpPr txBox="1"/>
           <p:nvPr/>
         </p:nvSpPr>
@@ -7191,7 +7169,7 @@
       </p:sp>
       <p:sp>
         <p:nvSpPr>
-          <p:cNvPr id="1718820745" name="ZoneTexte 1063440096"/>
+          <p:cNvPr id="1231872024" name="ZoneTexte 1063440096"/>
           <p:cNvSpPr txBox="1"/>
           <p:nvPr/>
         </p:nvSpPr>
@@ -7275,7 +7253,7 @@
       </p:sp>
       <p:sp>
         <p:nvSpPr>
-          <p:cNvPr id="1369343456" name="ZoneTexte 1564072661"/>
+          <p:cNvPr id="157697195" name="ZoneTexte 1564072661"/>
           <p:cNvSpPr txBox="1"/>
           <p:nvPr/>
         </p:nvSpPr>
@@ -7359,7 +7337,7 @@
       </p:sp>
       <p:sp>
         <p:nvSpPr>
-          <p:cNvPr id="1953860243" name="ZoneTexte 2102805411"/>
+          <p:cNvPr id="345336653" name="ZoneTexte 2102805411"/>
           <p:cNvSpPr txBox="1"/>
           <p:nvPr/>
         </p:nvSpPr>
@@ -7443,7 +7421,7 @@
       </p:sp>
       <p:sp>
         <p:nvSpPr>
-          <p:cNvPr id="1806342990" name="ZoneTexte 1094420572"/>
+          <p:cNvPr id="1666533552" name="ZoneTexte 1094420572"/>
           <p:cNvSpPr txBox="1"/>
           <p:nvPr/>
         </p:nvSpPr>
@@ -7527,7 +7505,7 @@
       </p:sp>
       <p:sp>
         <p:nvSpPr>
-          <p:cNvPr id="714334013" name="ZoneTexte 1337742717"/>
+          <p:cNvPr id="1746955738" name="ZoneTexte 1337742717"/>
           <p:cNvSpPr txBox="1"/>
           <p:nvPr/>
         </p:nvSpPr>
@@ -7591,7 +7569,7 @@
       </p:sp>
       <p:sp>
         <p:nvSpPr>
-          <p:cNvPr id="1195545713" name="ZoneTexte 1188730172"/>
+          <p:cNvPr id="400750683" name="ZoneTexte 1188730172"/>
           <p:cNvSpPr txBox="1"/>
           <p:nvPr/>
         </p:nvSpPr>
@@ -7655,7 +7633,7 @@
       </p:sp>
       <p:sp>
         <p:nvSpPr>
-          <p:cNvPr id="1446167710" name="Rectangle : avec coins arrondis en haut 1452601499"/>
+          <p:cNvPr id="332568858" name="Rectangle : avec coins arrondis en haut 1452601499"/>
           <p:cNvSpPr/>
           <p:nvPr/>
         </p:nvSpPr>
@@ -7701,7 +7679,7 @@
       </p:sp>
       <p:sp>
         <p:nvSpPr>
-          <p:cNvPr id="634058292" name="Rectangle : avec coins arrondis en haut 1782110635"/>
+          <p:cNvPr id="130513037" name="Rectangle : avec coins arrondis en haut 1782110635"/>
           <p:cNvSpPr/>
           <p:nvPr/>
         </p:nvSpPr>
@@ -7747,7 +7725,7 @@
       </p:sp>
       <p:sp>
         <p:nvSpPr>
-          <p:cNvPr id="1056872102" name="Rectangle : avec coins arrondis en haut 945118596"/>
+          <p:cNvPr id="607345861" name="Rectangle : avec coins arrondis en haut 945118596"/>
           <p:cNvSpPr/>
           <p:nvPr/>
         </p:nvSpPr>
@@ -7793,7 +7771,7 @@
       </p:sp>
       <p:sp>
         <p:nvSpPr>
-          <p:cNvPr id="247414251" name="Rectangle : avec coins arrondis en haut 500951796"/>
+          <p:cNvPr id="126291578" name="Rectangle : avec coins arrondis en haut 500951796"/>
           <p:cNvSpPr/>
           <p:nvPr/>
         </p:nvSpPr>
@@ -7839,7 +7817,7 @@
       </p:sp>
       <p:sp>
         <p:nvSpPr>
-          <p:cNvPr id="1661661777" name="Rectangle : avec coins arrondis en haut 203047490"/>
+          <p:cNvPr id="1543224370" name="Rectangle : avec coins arrondis en haut 203047490"/>
           <p:cNvSpPr/>
           <p:nvPr/>
         </p:nvSpPr>
@@ -7885,7 +7863,7 @@
       </p:sp>
       <p:sp>
         <p:nvSpPr>
-          <p:cNvPr id="350126673" name="Rectangle : avec coins arrondis en haut 818083012"/>
+          <p:cNvPr id="193046829" name="Rectangle : avec coins arrondis en haut 818083012"/>
           <p:cNvSpPr/>
           <p:nvPr/>
         </p:nvSpPr>
@@ -7931,7 +7909,7 @@
       </p:sp>
       <p:sp>
         <p:nvSpPr>
-          <p:cNvPr id="524954427" name="Rectangle : avec coins arrondis en haut 310539005"/>
+          <p:cNvPr id="1578835917" name="Rectangle : avec coins arrondis en haut 310539005"/>
           <p:cNvSpPr/>
           <p:nvPr/>
         </p:nvSpPr>
@@ -7977,7 +7955,7 @@
       </p:sp>
       <p:sp>
         <p:nvSpPr>
-          <p:cNvPr id="1159525531" name="Rectangle : avec coins arrondis en haut 844307487"/>
+          <p:cNvPr id="1152120255" name="Rectangle : avec coins arrondis en haut 844307487"/>
           <p:cNvSpPr/>
           <p:nvPr/>
         </p:nvSpPr>
@@ -8023,7 +8001,7 @@
       </p:sp>
       <p:sp>
         <p:nvSpPr>
-          <p:cNvPr id="1550854231" name="Rectangle : avec coins arrondis en haut 1616510051"/>
+          <p:cNvPr id="1578508363" name="Rectangle : avec coins arrondis en haut 1616510051"/>
           <p:cNvSpPr/>
           <p:nvPr/>
         </p:nvSpPr>
@@ -8069,7 +8047,7 @@
       </p:sp>
       <p:sp>
         <p:nvSpPr>
-          <p:cNvPr id="480347884" name="Rectangle : avec coins arrondis en haut 1451691637"/>
+          <p:cNvPr id="569585095" name="Rectangle : avec coins arrondis en haut 1451691637"/>
           <p:cNvSpPr/>
           <p:nvPr/>
         </p:nvSpPr>
@@ -8115,7 +8093,7 @@
       </p:sp>
       <p:sp>
         <p:nvSpPr>
-          <p:cNvPr id="922129415" name="Rectangle : avec coins arrondis en haut 260383743"/>
+          <p:cNvPr id="170192750" name="Rectangle : avec coins arrondis en haut 260383743"/>
           <p:cNvSpPr/>
           <p:nvPr/>
         </p:nvSpPr>
@@ -8161,7 +8139,7 @@
       </p:sp>
       <p:sp>
         <p:nvSpPr>
-          <p:cNvPr id="229002386" name="Rectangle : avec coins arrondis en haut 1280344391"/>
+          <p:cNvPr id="1015394765" name="Rectangle : avec coins arrondis en haut 1280344391"/>
           <p:cNvSpPr/>
           <p:nvPr/>
         </p:nvSpPr>
@@ -8207,7 +8185,7 @@
       </p:sp>
       <p:sp>
         <p:nvSpPr>
-          <p:cNvPr id="239542065" name=""/>
+          <p:cNvPr id="2129365332" name=""/>
           <p:cNvSpPr txBox="1"/>
           <p:nvPr/>
         </p:nvSpPr>
@@ -8331,7 +8309,7 @@
       </p:sp>
       <p:sp>
         <p:nvSpPr>
-          <p:cNvPr id="1096037567" name="ZoneTexte 1440859034"/>
+          <p:cNvPr id="1040366270" name="ZoneTexte 1440859034"/>
           <p:cNvSpPr txBox="1"/>
           <p:nvPr/>
         </p:nvSpPr>
@@ -8373,7 +8351,7 @@
       </p:sp>
       <p:sp>
         <p:nvSpPr>
-          <p:cNvPr id="1197677637" name="ZoneTexte 1440859034"/>
+          <p:cNvPr id="1652128631" name="ZoneTexte 1440859034"/>
           <p:cNvSpPr txBox="1"/>
           <p:nvPr/>
         </p:nvSpPr>
@@ -8412,7 +8390,7 @@
       </p:sp>
       <p:cxnSp>
         <p:nvCxnSpPr>
-          <p:cNvPr id="400569307" name=""/>
+          <p:cNvPr id="20986284" name=""/>
           <p:cNvCxnSpPr/>
           <p:nvPr/>
         </p:nvCxnSpPr>
@@ -8451,7 +8429,7 @@
       </p:cxnSp>
       <p:sp>
         <p:nvSpPr>
-          <p:cNvPr id="788523408" name=""/>
+          <p:cNvPr id="2044373370" name=""/>
           <p:cNvSpPr txBox="1"/>
           <p:nvPr/>
         </p:nvSpPr>
@@ -8615,7 +8593,7 @@
       </p:sp>
       <p:sp>
         <p:nvSpPr>
-          <p:cNvPr id="1664968998" name="Rectangle 954364527"/>
+          <p:cNvPr id="1151424050" name="Rectangle 954364527"/>
           <p:cNvSpPr/>
           <p:nvPr/>
         </p:nvSpPr>
@@ -8655,7 +8633,7 @@
       </p:sp>
       <p:sp>
         <p:nvSpPr>
-          <p:cNvPr id="1008907928" name="ZoneTexte 1527388901"/>
+          <p:cNvPr id="634541515" name="ZoneTexte 1527388901"/>
           <p:cNvSpPr txBox="1"/>
           <p:nvPr/>
         </p:nvSpPr>
@@ -8815,7 +8793,7 @@
       </p:sp>
       <p:sp>
         <p:nvSpPr>
-          <p:cNvPr id="2011187832" name="Rectangle 38344096"/>
+          <p:cNvPr id="937330216" name="Rectangle 38344096"/>
           <p:cNvSpPr/>
           <p:nvPr/>
         </p:nvSpPr>
@@ -8855,7 +8833,7 @@
       </p:sp>
       <p:sp>
         <p:nvSpPr>
-          <p:cNvPr id="174437826" name=""/>
+          <p:cNvPr id="1095452117" name=""/>
           <p:cNvSpPr/>
           <p:nvPr/>
         </p:nvSpPr>
@@ -8926,7 +8904,7 @@
       </p:sp>
       <p:sp>
         <p:nvSpPr>
-          <p:cNvPr id="924026724" name="Flèche : pentagone 2055848356"/>
+          <p:cNvPr id="1887674137" name="Flèche : pentagone 2055848356"/>
           <p:cNvSpPr/>
           <p:nvPr/>
         </p:nvSpPr>
@@ -8971,7 +8949,7 @@
       </p:sp>
       <p:sp>
         <p:nvSpPr>
-          <p:cNvPr id="1836875480" name="Flèche : pentagone 1980093981"/>
+          <p:cNvPr id="1470337902" name="Flèche : pentagone 1980093981"/>
           <p:cNvSpPr/>
           <p:nvPr/>
         </p:nvSpPr>
@@ -9016,7 +8994,7 @@
       </p:sp>
       <p:sp>
         <p:nvSpPr>
-          <p:cNvPr id="1031703884" name="Flèche : pentagone 905284374"/>
+          <p:cNvPr id="1912628321" name="Flèche : pentagone 905284374"/>
           <p:cNvSpPr/>
           <p:nvPr/>
         </p:nvSpPr>
@@ -9061,7 +9039,7 @@
       </p:sp>
       <p:sp>
         <p:nvSpPr>
-          <p:cNvPr id="632836252" name="ZoneTexte 1440859034"/>
+          <p:cNvPr id="601131564" name="ZoneTexte 1440859034"/>
           <p:cNvSpPr txBox="1"/>
           <p:nvPr/>
         </p:nvSpPr>
@@ -9100,7 +9078,7 @@
       </p:sp>
       <p:sp>
         <p:nvSpPr>
-          <p:cNvPr id="12174300" name="Flèche : pentagone 1880610112"/>
+          <p:cNvPr id="1077154462" name="Flèche : pentagone 1880610112"/>
           <p:cNvSpPr/>
           <p:nvPr/>
         </p:nvSpPr>
@@ -9145,7 +9123,7 @@
       </p:sp>
       <p:sp>
         <p:nvSpPr>
-          <p:cNvPr id="888026582" name="Flèche : pentagone 446859139"/>
+          <p:cNvPr id="1038363559" name="Flèche : pentagone 446859139"/>
           <p:cNvSpPr/>
           <p:nvPr/>
         </p:nvSpPr>
@@ -9190,7 +9168,7 @@
       </p:sp>
       <p:sp>
         <p:nvSpPr>
-          <p:cNvPr id="866979880" name="Flèche : pentagone 2055848356"/>
+          <p:cNvPr id="1940043257" name="Flèche : pentagone 2055848356"/>
           <p:cNvSpPr/>
           <p:nvPr/>
         </p:nvSpPr>
@@ -9235,7 +9213,7 @@
       </p:sp>
       <p:sp>
         <p:nvSpPr>
-          <p:cNvPr id="393676056" name="Flèche : pentagone 1980093981"/>
+          <p:cNvPr id="1333161651" name="Flèche : pentagone 1980093981"/>
           <p:cNvSpPr/>
           <p:nvPr/>
         </p:nvSpPr>
@@ -9280,7 +9258,7 @@
       </p:sp>
       <p:sp>
         <p:nvSpPr>
-          <p:cNvPr id="138251967" name="Flèche : pentagone 905284374"/>
+          <p:cNvPr id="1492564396" name="Flèche : pentagone 905284374"/>
           <p:cNvSpPr/>
           <p:nvPr/>
         </p:nvSpPr>
@@ -9325,7 +9303,7 @@
       </p:sp>
       <p:sp>
         <p:nvSpPr>
-          <p:cNvPr id="1745635626" name="ZoneTexte 1440859034"/>
+          <p:cNvPr id="1160487741" name="ZoneTexte 1440859034"/>
           <p:cNvSpPr txBox="1"/>
           <p:nvPr/>
         </p:nvSpPr>
@@ -9364,7 +9342,7 @@
       </p:sp>
       <p:sp>
         <p:nvSpPr>
-          <p:cNvPr id="1677523332" name="Flèche : pentagone 2055848356"/>
+          <p:cNvPr id="977833722" name="Flèche : pentagone 2055848356"/>
           <p:cNvSpPr/>
           <p:nvPr/>
         </p:nvSpPr>
@@ -9409,7 +9387,7 @@
       </p:sp>
       <p:sp>
         <p:nvSpPr>
-          <p:cNvPr id="1455415556" name="Flèche : pentagone 1980093981"/>
+          <p:cNvPr id="1900194777" name="Flèche : pentagone 1980093981"/>
           <p:cNvSpPr/>
           <p:nvPr/>
         </p:nvSpPr>
@@ -9454,7 +9432,7 @@
       </p:sp>
       <p:sp>
         <p:nvSpPr>
-          <p:cNvPr id="2068665878" name="Flèche : pentagone 905284374"/>
+          <p:cNvPr id="1817866907" name="Flèche : pentagone 905284374"/>
           <p:cNvSpPr/>
           <p:nvPr/>
         </p:nvSpPr>
@@ -9499,7 +9477,7 @@
       </p:sp>
       <p:sp>
         <p:nvSpPr>
-          <p:cNvPr id="1632807343" name="ZoneTexte 1440859034"/>
+          <p:cNvPr id="1660188788" name="ZoneTexte 1440859034"/>
           <p:cNvSpPr txBox="1"/>
           <p:nvPr/>
         </p:nvSpPr>
@@ -9538,7 +9516,7 @@
       </p:sp>
       <p:sp>
         <p:nvSpPr>
-          <p:cNvPr id="1143695030" name=""/>
+          <p:cNvPr id="894474244" name=""/>
           <p:cNvSpPr txBox="1"/>
           <p:nvPr/>
         </p:nvSpPr>
@@ -9702,7 +9680,7 @@
       </p:sp>
       <p:sp>
         <p:nvSpPr>
-          <p:cNvPr id="360959361" name=""/>
+          <p:cNvPr id="973291325" name=""/>
           <p:cNvSpPr txBox="1"/>
           <p:nvPr/>
         </p:nvSpPr>
@@ -9866,7 +9844,7 @@
       </p:sp>
       <p:sp>
         <p:nvSpPr>
-          <p:cNvPr id="1655146142" name=""/>
+          <p:cNvPr id="1051435069" name=""/>
           <p:cNvSpPr txBox="1"/>
           <p:nvPr/>
         </p:nvSpPr>
@@ -10063,7 +10041,7 @@
       </p:grpSpPr>
       <p:sp>
         <p:nvSpPr>
-          <p:cNvPr id="38997469" name=""/>
+          <p:cNvPr id="591387563" name=""/>
           <p:cNvSpPr/>
           <p:nvPr/>
         </p:nvSpPr>
@@ -10106,7 +10084,7 @@
       </p:sp>
       <p:sp>
         <p:nvSpPr>
-          <p:cNvPr id="593595920" name=""/>
+          <p:cNvPr id="2077322176" name=""/>
           <p:cNvSpPr txBox="1"/>
           <p:nvPr/>
         </p:nvSpPr>
@@ -10172,7 +10150,7 @@
       </p:sp>
       <p:cxnSp>
         <p:nvCxnSpPr>
-          <p:cNvPr id="250524992" name="Connecteur droit 1568760680"/>
+          <p:cNvPr id="1299865765" name="Connecteur droit 1568760680"/>
           <p:cNvCxnSpPr/>
           <p:nvPr/>
         </p:nvCxnSpPr>
@@ -10214,7 +10192,7 @@
       </p:cxnSp>
       <p:sp>
         <p:nvSpPr>
-          <p:cNvPr id="1853304664" name="ZoneTexte 1868728971"/>
+          <p:cNvPr id="556345685" name="ZoneTexte 1868728971"/>
           <p:cNvSpPr txBox="1"/>
           <p:nvPr/>
         </p:nvSpPr>
@@ -10254,7 +10232,7 @@
       </p:sp>
       <p:cxnSp>
         <p:nvCxnSpPr>
-          <p:cNvPr id="928638840" name="Connecteur droit 806540798"/>
+          <p:cNvPr id="828269592" name="Connecteur droit 806540798"/>
           <p:cNvCxnSpPr/>
           <p:nvPr/>
         </p:nvCxnSpPr>
@@ -10296,7 +10274,7 @@
       </p:cxnSp>
       <p:sp>
         <p:nvSpPr>
-          <p:cNvPr id="243505817" name="ZoneTexte 406616703"/>
+          <p:cNvPr id="86531202" name="ZoneTexte 406616703"/>
           <p:cNvSpPr txBox="1"/>
           <p:nvPr/>
         </p:nvSpPr>
@@ -10336,7 +10314,7 @@
       </p:sp>
       <p:sp>
         <p:nvSpPr>
-          <p:cNvPr id="2074964307" name="ZoneTexte 1302587497"/>
+          <p:cNvPr id="1003509021" name="ZoneTexte 1302587497"/>
           <p:cNvSpPr txBox="1"/>
           <p:nvPr/>
         </p:nvSpPr>
@@ -10540,7 +10518,7 @@
       </p:sp>
       <p:sp>
         <p:nvSpPr>
-          <p:cNvPr id="1478011223" name="Rectangle 38344096"/>
+          <p:cNvPr id="374080768" name="Rectangle 38344096"/>
           <p:cNvSpPr/>
           <p:nvPr/>
         </p:nvSpPr>
@@ -10580,7 +10558,7 @@
       </p:sp>
       <p:sp>
         <p:nvSpPr>
-          <p:cNvPr id="723718965" name="ZoneTexte 1075280509"/>
+          <p:cNvPr id="133886075" name="ZoneTexte 1075280509"/>
           <p:cNvSpPr txBox="1"/>
           <p:nvPr/>
         </p:nvSpPr>
@@ -10653,7 +10631,7 @@
       </p:sp>
       <p:sp>
         <p:nvSpPr>
-          <p:cNvPr id="1070291821" name="ZoneTexte 226284734"/>
+          <p:cNvPr id="1942043863" name="ZoneTexte 226284734"/>
           <p:cNvSpPr txBox="1"/>
           <p:nvPr/>
         </p:nvSpPr>
@@ -10726,7 +10704,7 @@
       </p:sp>
       <p:sp>
         <p:nvSpPr>
-          <p:cNvPr id="697341943" name="ZoneTexte 162158187"/>
+          <p:cNvPr id="1018123804" name="ZoneTexte 162158187"/>
           <p:cNvSpPr txBox="1"/>
           <p:nvPr/>
         </p:nvSpPr>
@@ -10776,7 +10754,7 @@
       </p:sp>
       <p:sp>
         <p:nvSpPr>
-          <p:cNvPr id="156812537" name="Rectangle : avec coins arrondis en haut 1452601499"/>
+          <p:cNvPr id="1761064515" name="Rectangle : avec coins arrondis en haut 1452601499"/>
           <p:cNvSpPr/>
           <p:nvPr/>
         </p:nvSpPr>
@@ -10819,7 +10797,7 @@
       </p:sp>
       <p:sp>
         <p:nvSpPr>
-          <p:cNvPr id="1773797890" name="Rectangle : avec coins arrondis en haut 1782110635"/>
+          <p:cNvPr id="325763081" name="Rectangle : avec coins arrondis en haut 1782110635"/>
           <p:cNvSpPr/>
           <p:nvPr/>
         </p:nvSpPr>
@@ -10865,7 +10843,7 @@
       </p:sp>
       <p:sp>
         <p:nvSpPr>
-          <p:cNvPr id="272423393" name="Rectangle : avec coins arrondis en haut 945118596"/>
+          <p:cNvPr id="854606838" name="Rectangle : avec coins arrondis en haut 945118596"/>
           <p:cNvSpPr/>
           <p:nvPr/>
         </p:nvSpPr>
@@ -10911,7 +10889,7 @@
       </p:sp>
       <p:sp>
         <p:nvSpPr>
-          <p:cNvPr id="930212870" name=""/>
+          <p:cNvPr id="632961650" name=""/>
           <p:cNvSpPr/>
           <p:nvPr/>
         </p:nvSpPr>
@@ -10953,7 +10931,7 @@
       </p:sp>
       <p:sp>
         <p:nvSpPr>
-          <p:cNvPr id="2061323065" name=""/>
+          <p:cNvPr id="2049584505" name=""/>
           <p:cNvSpPr txBox="1"/>
           <p:nvPr/>
         </p:nvSpPr>
@@ -10993,7 +10971,7 @@
       </p:sp>
       <p:sp>
         <p:nvSpPr>
-          <p:cNvPr id="1765827829" name=""/>
+          <p:cNvPr id="1326703020" name=""/>
           <p:cNvSpPr/>
           <p:nvPr/>
         </p:nvSpPr>
@@ -11064,7 +11042,7 @@
       </p:sp>
       <p:sp>
         <p:nvSpPr>
-          <p:cNvPr id="1800266668" name=""/>
+          <p:cNvPr id="1475935701" name=""/>
           <p:cNvSpPr txBox="1"/>
           <p:nvPr/>
         </p:nvSpPr>
@@ -11101,7 +11079,7 @@
       </p:sp>
       <p:sp>
         <p:nvSpPr>
-          <p:cNvPr id="980531447" name=""/>
+          <p:cNvPr id="2117444558" name=""/>
           <p:cNvSpPr txBox="1"/>
           <p:nvPr/>
         </p:nvSpPr>
@@ -11335,7 +11313,7 @@
       </p:sp>
       <p:sp>
         <p:nvSpPr>
-          <p:cNvPr id="770633209" name=""/>
+          <p:cNvPr id="1302113014" name=""/>
           <p:cNvSpPr txBox="1"/>
           <p:nvPr/>
         </p:nvSpPr>
@@ -11614,7 +11592,7 @@
       </p:sp>
       <p:sp>
         <p:nvSpPr>
-          <p:cNvPr id="1505881002" name=""/>
+          <p:cNvPr id="1964273091" name=""/>
           <p:cNvSpPr txBox="1"/>
           <p:nvPr/>
         </p:nvSpPr>
@@ -12005,7 +11983,7 @@
       </p:sp>
       <p:sp>
         <p:nvSpPr>
-          <p:cNvPr id="519004949" name=""/>
+          <p:cNvPr id="2008820004" name=""/>
           <p:cNvSpPr txBox="1"/>
           <p:nvPr/>
         </p:nvSpPr>
@@ -12396,7 +12374,7 @@
       </p:sp>
       <p:sp>
         <p:nvSpPr>
-          <p:cNvPr id="495674657" name=""/>
+          <p:cNvPr id="1436579179" name=""/>
           <p:cNvSpPr txBox="1"/>
           <p:nvPr/>
         </p:nvSpPr>
@@ -12787,7 +12765,7 @@
       </p:sp>
       <p:sp>
         <p:nvSpPr>
-          <p:cNvPr id="2132386061" name=""/>
+          <p:cNvPr id="201230791" name=""/>
           <p:cNvSpPr txBox="1"/>
           <p:nvPr/>
         </p:nvSpPr>
@@ -13178,7 +13156,7 @@
       </p:sp>
       <p:sp>
         <p:nvSpPr>
-          <p:cNvPr id="1386806432" name=""/>
+          <p:cNvPr id="152823308" name=""/>
           <p:cNvSpPr txBox="1"/>
           <p:nvPr/>
         </p:nvSpPr>
@@ -13569,7 +13547,7 @@
       </p:sp>
       <p:sp>
         <p:nvSpPr>
-          <p:cNvPr id="413998984" name=""/>
+          <p:cNvPr id="489985910" name=""/>
           <p:cNvSpPr txBox="1"/>
           <p:nvPr/>
         </p:nvSpPr>
@@ -13960,7 +13938,7 @@
       </p:sp>
       <p:sp>
         <p:nvSpPr>
-          <p:cNvPr id="352832646" name=""/>
+          <p:cNvPr id="516138876" name=""/>
           <p:cNvSpPr txBox="1"/>
           <p:nvPr/>
         </p:nvSpPr>
@@ -14351,7 +14329,7 @@
       </p:sp>
       <p:sp>
         <p:nvSpPr>
-          <p:cNvPr id="1678378542" name=""/>
+          <p:cNvPr id="882747423" name=""/>
           <p:cNvSpPr txBox="1"/>
           <p:nvPr/>
         </p:nvSpPr>
@@ -14742,7 +14720,7 @@
       </p:sp>
       <p:sp>
         <p:nvSpPr>
-          <p:cNvPr id="1414613981" name=""/>
+          <p:cNvPr id="733840457" name=""/>
           <p:cNvSpPr txBox="1"/>
           <p:nvPr/>
         </p:nvSpPr>
@@ -15133,7 +15111,7 @@
       </p:sp>
       <p:sp>
         <p:nvSpPr>
-          <p:cNvPr id="1740224451" name=""/>
+          <p:cNvPr id="1725048076" name=""/>
           <p:cNvSpPr txBox="1"/>
           <p:nvPr/>
         </p:nvSpPr>
@@ -15524,7 +15502,7 @@
       </p:sp>
       <p:sp>
         <p:nvSpPr>
-          <p:cNvPr id="1260203910" name=""/>
+          <p:cNvPr id="519257650" name=""/>
           <p:cNvSpPr txBox="1"/>
           <p:nvPr/>
         </p:nvSpPr>
@@ -15915,7 +15893,7 @@
       </p:sp>
       <p:sp>
         <p:nvSpPr>
-          <p:cNvPr id="2141500198" name=""/>
+          <p:cNvPr id="335385134" name=""/>
           <p:cNvSpPr txBox="1"/>
           <p:nvPr/>
         </p:nvSpPr>
@@ -16306,7 +16284,7 @@
       </p:sp>
       <p:sp>
         <p:nvSpPr>
-          <p:cNvPr id="351757380" name=""/>
+          <p:cNvPr id="116187254" name=""/>
           <p:cNvSpPr txBox="1"/>
           <p:nvPr/>
         </p:nvSpPr>
@@ -16697,7 +16675,7 @@
       </p:sp>
       <p:sp>
         <p:nvSpPr>
-          <p:cNvPr id="1745774310" name=""/>
+          <p:cNvPr id="11058899" name=""/>
           <p:cNvSpPr txBox="1"/>
           <p:nvPr/>
         </p:nvSpPr>
@@ -17088,14 +17066,14 @@
       </p:sp>
       <p:sp>
         <p:nvSpPr>
-          <p:cNvPr id="1201286088" name=""/>
+          <p:cNvPr id="2101764948" name=""/>
           <p:cNvSpPr txBox="1"/>
           <p:nvPr/>
         </p:nvSpPr>
         <p:spPr bwMode="auto">
           <a:xfrm rot="0" flipH="0" flipV="0">
-            <a:off x="58494" y="7297017"/>
-            <a:ext cx="6779315" cy="829180"/>
+            <a:off x="58493" y="7297016"/>
+            <a:ext cx="6787234" cy="829180"/>
           </a:xfrm>
           <a:prstGeom prst="rect">
             <a:avLst/>
@@ -17205,7 +17183,7 @@
                 <a:ea typeface="Arial"/>
                 <a:cs typeface="Arial"/>
               </a:rPr>
-              <a:t>Accorder de l’attention au personnage</a:t>
+              <a:t>Partager son activité</a:t>
             </a:r>
             <a:r>
               <a:rPr lang="fr-FR" sz="800" b="0" i="0" u="none" strike="noStrike" cap="none" spc="0">
@@ -17296,7 +17274,7 @@
       </p:sp>
       <p:cxnSp>
         <p:nvCxnSpPr>
-          <p:cNvPr id="76463490" name="Connecteur droit 806540798"/>
+          <p:cNvPr id="2081557740" name="Connecteur droit 806540798"/>
           <p:cNvCxnSpPr/>
           <p:nvPr/>
         </p:nvCxnSpPr>
@@ -17338,7 +17316,7 @@
       </p:cxnSp>
       <p:sp>
         <p:nvSpPr>
-          <p:cNvPr id="1609198624" name="ZoneTexte 406616703"/>
+          <p:cNvPr id="579160766" name="ZoneTexte 406616703"/>
           <p:cNvSpPr txBox="1"/>
           <p:nvPr/>
         </p:nvSpPr>
@@ -17378,7 +17356,7 @@
       </p:sp>
       <p:sp>
         <p:nvSpPr>
-          <p:cNvPr id="704265852" name=""/>
+          <p:cNvPr id="1307579552" name=""/>
           <p:cNvSpPr txBox="1"/>
           <p:nvPr/>
         </p:nvSpPr>
@@ -17477,7 +17455,7 @@
       </p:grpSpPr>
       <p:cxnSp>
         <p:nvCxnSpPr>
-          <p:cNvPr id="856193300" name="Connecteur droit 266926011"/>
+          <p:cNvPr id="852453575" name="Connecteur droit 266926011"/>
           <p:cNvCxnSpPr/>
           <p:nvPr/>
         </p:nvCxnSpPr>
@@ -17519,7 +17497,7 @@
       </p:cxnSp>
       <p:sp>
         <p:nvSpPr>
-          <p:cNvPr id="1628026633" name="ZoneTexte 1043763612"/>
+          <p:cNvPr id="978918710" name="ZoneTexte 1043763612"/>
           <p:cNvSpPr txBox="1"/>
           <p:nvPr/>
         </p:nvSpPr>
@@ -17559,7 +17537,7 @@
       </p:sp>
       <p:cxnSp>
         <p:nvCxnSpPr>
-          <p:cNvPr id="857961706" name="Connecteur droit 1586327141"/>
+          <p:cNvPr id="1844698844" name="Connecteur droit 1586327141"/>
           <p:cNvCxnSpPr/>
           <p:nvPr/>
         </p:nvCxnSpPr>
@@ -17602,7 +17580,7 @@
       </p:cxnSp>
       <p:sp>
         <p:nvSpPr>
-          <p:cNvPr id="1672004710" name="ZoneTexte 1691387439"/>
+          <p:cNvPr id="164244367" name="ZoneTexte 1691387439"/>
           <p:cNvSpPr txBox="1"/>
           <p:nvPr/>
         </p:nvSpPr>
@@ -17642,7 +17620,7 @@
       </p:sp>
       <p:cxnSp>
         <p:nvCxnSpPr>
-          <p:cNvPr id="1978691096" name="Connecteur droit 1743707585"/>
+          <p:cNvPr id="1813051427" name="Connecteur droit 1743707585"/>
           <p:cNvCxnSpPr/>
           <p:nvPr/>
         </p:nvCxnSpPr>
@@ -17685,7 +17663,7 @@
       </p:cxnSp>
       <p:sp>
         <p:nvSpPr>
-          <p:cNvPr id="530358375" name="ZoneTexte 1503300725"/>
+          <p:cNvPr id="1955254136" name="ZoneTexte 1503300725"/>
           <p:cNvSpPr txBox="1"/>
           <p:nvPr/>
         </p:nvSpPr>
@@ -17767,7 +17745,7 @@
       </p:sp>
       <p:sp>
         <p:nvSpPr>
-          <p:cNvPr id="335176745" name="Rectangle : avec coins arrondis en haut 1151560973"/>
+          <p:cNvPr id="858693496" name="Rectangle : avec coins arrondis en haut 1151560973"/>
           <p:cNvSpPr/>
           <p:nvPr/>
         </p:nvSpPr>
@@ -17813,7 +17791,7 @@
       </p:sp>
       <p:sp>
         <p:nvSpPr>
-          <p:cNvPr id="1263464841" name="Flèche : pentagone 1610574377"/>
+          <p:cNvPr id="2015265541" name="Flèche : pentagone 1610574377"/>
           <p:cNvSpPr/>
           <p:nvPr/>
         </p:nvSpPr>
@@ -17858,7 +17836,7 @@
       </p:sp>
       <p:sp>
         <p:nvSpPr>
-          <p:cNvPr id="2095902457" name="Flèche : pentagone 463861063"/>
+          <p:cNvPr id="529512172" name="Flèche : pentagone 463861063"/>
           <p:cNvSpPr/>
           <p:nvPr/>
         </p:nvSpPr>
@@ -17903,7 +17881,7 @@
       </p:sp>
       <p:sp>
         <p:nvSpPr>
-          <p:cNvPr id="235177083" name="Flèche : pentagone 272004907"/>
+          <p:cNvPr id="606492989" name="Flèche : pentagone 272004907"/>
           <p:cNvSpPr/>
           <p:nvPr/>
         </p:nvSpPr>
@@ -17948,7 +17926,7 @@
       </p:sp>
       <p:sp>
         <p:nvSpPr>
-          <p:cNvPr id="1056720817" name="Flèche : pentagone 28174069"/>
+          <p:cNvPr id="972714653" name="Flèche : pentagone 28174069"/>
           <p:cNvSpPr/>
           <p:nvPr/>
         </p:nvSpPr>
@@ -17993,7 +17971,7 @@
       </p:sp>
       <p:sp>
         <p:nvSpPr>
-          <p:cNvPr id="556320636" name="Flèche : pentagone 978127220"/>
+          <p:cNvPr id="241482915" name="Flèche : pentagone 978127220"/>
           <p:cNvSpPr/>
           <p:nvPr/>
         </p:nvSpPr>
@@ -18038,14 +18016,14 @@
       </p:sp>
       <p:sp>
         <p:nvSpPr>
-          <p:cNvPr id="239309316" name="ZoneTexte 1693594013"/>
+          <p:cNvPr id="1388904870" name="ZoneTexte 1693594013"/>
           <p:cNvSpPr txBox="1"/>
           <p:nvPr/>
         </p:nvSpPr>
         <p:spPr bwMode="auto">
           <a:xfrm flipH="0" flipV="0">
-            <a:off x="3252186" y="6489750"/>
-            <a:ext cx="3613866" cy="3139799"/>
+            <a:off x="3252185" y="6489749"/>
+            <a:ext cx="3594425" cy="3261719"/>
           </a:xfrm>
           <a:prstGeom prst="rect">
             <a:avLst/>
@@ -18117,7 +18095,7 @@
                 <a:ea typeface="+mn-ea"/>
                 <a:cs typeface="+mn-cs"/>
               </a:rPr>
-              <a:t>Après un test de maîtrise de soi réussi, cochez une case de faim.</a:t>
+              <a:t>Après une épreuve de maîtrise de soi échouée, cochez une case de faim.</a:t>
             </a:r>
             <a:r>
               <a:rPr lang="fr-FR" sz="800" b="0" i="0" u="none" strike="noStrike" cap="none" spc="0">
@@ -18131,7 +18109,21 @@
                 <a:ea typeface="+mn-ea"/>
                 <a:cs typeface="+mn-cs"/>
               </a:rPr>
-              <a:t> Vous pouvez diminuer votre faim en vous laissant aller à celle-ci au cours d’une scène. Si vous échouez à votre test de maîtrise de soi, cochez une case de rage.</a:t>
+              <a:t> Si vous réussissez un choc de maîtrise de soi, cochez une case de faim. Si vous échouez à un choc de maîtrise de soi, cochez une case de rage. </a:t>
+            </a:r>
+            <a:r>
+              <a:rPr lang="fr-FR" sz="800" b="0" i="0" u="none" strike="noStrike" cap="none" spc="0">
+                <a:solidFill>
+                  <a:schemeClr val="tx1">
+                    <a:lumMod val="50000"/>
+                    <a:lumOff val="50000"/>
+                  </a:schemeClr>
+                </a:solidFill>
+                <a:latin typeface="Arial"/>
+                <a:ea typeface="Arial"/>
+                <a:cs typeface="Arial"/>
+              </a:rPr>
+              <a:t>Vous pouvez diminuer votre faim en vous laissant aller à celle-ci au cours d’une scène.</a:t>
             </a:r>
             <a:endParaRPr sz="800">
               <a:solidFill>
@@ -18389,7 +18381,7 @@
       </p:sp>
       <p:sp>
         <p:nvSpPr>
-          <p:cNvPr id="1817830570" name="ZoneTexte 1975797288"/>
+          <p:cNvPr id="679686526" name="ZoneTexte 1975797288"/>
           <p:cNvSpPr txBox="1"/>
           <p:nvPr/>
         </p:nvSpPr>
@@ -18429,7 +18421,7 @@
       </p:sp>
       <p:sp>
         <p:nvSpPr>
-          <p:cNvPr id="1971585763" name="ZoneTexte 2064865984"/>
+          <p:cNvPr id="1080242708" name="ZoneTexte 2064865984"/>
           <p:cNvSpPr txBox="1"/>
           <p:nvPr/>
         </p:nvSpPr>
@@ -18694,7 +18686,7 @@
       </p:sp>
       <p:sp>
         <p:nvSpPr>
-          <p:cNvPr id="397506746" name="ZoneTexte 1387173154"/>
+          <p:cNvPr id="768979426" name="ZoneTexte 1387173154"/>
           <p:cNvSpPr txBox="1"/>
           <p:nvPr/>
         </p:nvSpPr>
@@ -19074,7 +19066,7 @@
       </p:sp>
       <p:sp>
         <p:nvSpPr>
-          <p:cNvPr id="56001036" name="ZoneTexte 523755832"/>
+          <p:cNvPr id="701627336" name="ZoneTexte 523755832"/>
           <p:cNvSpPr txBox="1"/>
           <p:nvPr/>
         </p:nvSpPr>
@@ -19570,7 +19562,7 @@
       </p:sp>
       <p:cxnSp>
         <p:nvCxnSpPr>
-          <p:cNvPr id="1442167181" name="Connecteur droit 2085669542"/>
+          <p:cNvPr id="469805259" name="Connecteur droit 2085669542"/>
           <p:cNvCxnSpPr/>
           <p:nvPr/>
         </p:nvCxnSpPr>
@@ -19613,7 +19605,7 @@
       </p:cxnSp>
       <p:sp>
         <p:nvSpPr>
-          <p:cNvPr id="1198983638" name="ZoneTexte 34398067"/>
+          <p:cNvPr id="1295948456" name="ZoneTexte 34398067"/>
           <p:cNvSpPr txBox="1"/>
           <p:nvPr/>
         </p:nvSpPr>
@@ -19656,7 +19648,7 @@
       </p:sp>
       <p:sp>
         <p:nvSpPr>
-          <p:cNvPr id="978608668" name="ZoneTexte 273581705"/>
+          <p:cNvPr id="461347571" name="ZoneTexte 273581705"/>
           <p:cNvSpPr txBox="1"/>
           <p:nvPr/>
         </p:nvSpPr>
@@ -19954,7 +19946,7 @@
       </p:sp>
       <p:sp>
         <p:nvSpPr>
-          <p:cNvPr id="954761481" name="ZoneTexte 1727393832"/>
+          <p:cNvPr id="1739647728" name="ZoneTexte 1727393832"/>
           <p:cNvSpPr txBox="1"/>
           <p:nvPr/>
         </p:nvSpPr>
@@ -19996,7 +19988,7 @@
       </p:sp>
       <p:sp>
         <p:nvSpPr>
-          <p:cNvPr id="982535305" name="ZoneTexte 504516740"/>
+          <p:cNvPr id="409147043" name="ZoneTexte 504516740"/>
           <p:cNvSpPr txBox="1"/>
           <p:nvPr/>
         </p:nvSpPr>
@@ -20038,7 +20030,7 @@
       </p:sp>
       <p:sp>
         <p:nvSpPr>
-          <p:cNvPr id="746831229" name="ZoneTexte 1"/>
+          <p:cNvPr id="254907847" name="ZoneTexte 1"/>
           <p:cNvSpPr txBox="1"/>
           <p:nvPr/>
         </p:nvSpPr>
@@ -21501,7 +21493,7 @@
       </p:sp>
       <p:sp>
         <p:nvSpPr>
-          <p:cNvPr id="1377223522" name="ZoneTexte 2"/>
+          <p:cNvPr id="854874084" name="ZoneTexte 2"/>
           <p:cNvSpPr txBox="1"/>
           <p:nvPr/>
         </p:nvSpPr>
@@ -22039,7 +22031,7 @@
       </p:sp>
       <p:sp>
         <p:nvSpPr>
-          <p:cNvPr id="991754872" name=""/>
+          <p:cNvPr id="1602303910" name=""/>
           <p:cNvSpPr/>
           <p:nvPr/>
         </p:nvSpPr>
@@ -22079,7 +22071,7 @@
       </p:sp>
       <p:sp>
         <p:nvSpPr>
-          <p:cNvPr id="1568185821" name="Rectangle : avec coins arrondis en haut 1151560973"/>
+          <p:cNvPr id="1322435642" name="Rectangle : avec coins arrondis en haut 1151560973"/>
           <p:cNvSpPr/>
           <p:nvPr/>
         </p:nvSpPr>
@@ -22127,7 +22119,7 @@
       </p:sp>
       <p:sp>
         <p:nvSpPr>
-          <p:cNvPr id="798272772" name=""/>
+          <p:cNvPr id="1100762921" name=""/>
           <p:cNvSpPr/>
           <p:nvPr/>
         </p:nvSpPr>
@@ -22167,7 +22159,7 @@
       </p:sp>
       <p:sp>
         <p:nvSpPr>
-          <p:cNvPr id="1753183782" name="Rectangle : avec coins arrondis en haut 1151560973"/>
+          <p:cNvPr id="1667960735" name="Rectangle : avec coins arrondis en haut 1151560973"/>
           <p:cNvSpPr/>
           <p:nvPr/>
         </p:nvSpPr>
@@ -22215,7 +22207,7 @@
       </p:sp>
       <p:sp>
         <p:nvSpPr>
-          <p:cNvPr id="1791999018" name=""/>
+          <p:cNvPr id="1149175492" name=""/>
           <p:cNvSpPr/>
           <p:nvPr/>
         </p:nvSpPr>
@@ -22255,7 +22247,7 @@
       </p:sp>
       <p:sp>
         <p:nvSpPr>
-          <p:cNvPr id="707347440" name="Rectangle : avec coins arrondis en haut 1151560973"/>
+          <p:cNvPr id="225730948" name="Rectangle : avec coins arrondis en haut 1151560973"/>
           <p:cNvSpPr/>
           <p:nvPr/>
         </p:nvSpPr>
@@ -22303,7 +22295,7 @@
       </p:sp>
       <p:sp>
         <p:nvSpPr>
-          <p:cNvPr id="1694039779" name=""/>
+          <p:cNvPr id="930305326" name=""/>
           <p:cNvSpPr txBox="1"/>
           <p:nvPr/>
         </p:nvSpPr>
@@ -22368,7 +22360,7 @@
       </p:sp>
       <p:sp>
         <p:nvSpPr>
-          <p:cNvPr id="1691187295" name=""/>
+          <p:cNvPr id="996808007" name=""/>
           <p:cNvSpPr txBox="1"/>
           <p:nvPr/>
         </p:nvSpPr>
@@ -22497,7 +22489,7 @@
       </p:sp>
       <p:sp>
         <p:nvSpPr>
-          <p:cNvPr id="1548377374" name=""/>
+          <p:cNvPr id="336631616" name=""/>
           <p:cNvSpPr/>
           <p:nvPr/>
         </p:nvSpPr>
@@ -22568,7 +22560,7 @@
       </p:sp>
       <p:sp>
         <p:nvSpPr>
-          <p:cNvPr id="1552225654" name="Flèche : pentagone 1610574377"/>
+          <p:cNvPr id="1075153033" name="Flèche : pentagone 1610574377"/>
           <p:cNvSpPr/>
           <p:nvPr/>
         </p:nvSpPr>
@@ -22613,7 +22605,7 @@
       </p:sp>
       <p:sp>
         <p:nvSpPr>
-          <p:cNvPr id="1404151983" name="Flèche : pentagone 463861063"/>
+          <p:cNvPr id="850415433" name="Flèche : pentagone 463861063"/>
           <p:cNvSpPr/>
           <p:nvPr/>
         </p:nvSpPr>
@@ -22658,7 +22650,7 @@
       </p:sp>
       <p:sp>
         <p:nvSpPr>
-          <p:cNvPr id="368819361" name="Flèche : pentagone 272004907"/>
+          <p:cNvPr id="1198010113" name="Flèche : pentagone 272004907"/>
           <p:cNvSpPr/>
           <p:nvPr/>
         </p:nvSpPr>
@@ -22736,7 +22728,7 @@
       </p:grpSpPr>
       <p:cxnSp>
         <p:nvCxnSpPr>
-          <p:cNvPr id="1361626944" name="Connecteur droit 1942366049"/>
+          <p:cNvPr id="1484776467" name="Connecteur droit 1942366049"/>
           <p:cNvCxnSpPr/>
           <p:nvPr/>
         </p:nvCxnSpPr>
@@ -22779,7 +22771,7 @@
       </p:cxnSp>
       <p:sp>
         <p:nvSpPr>
-          <p:cNvPr id="323742760" name="ZoneTexte 483029020"/>
+          <p:cNvPr id="1504666801" name="ZoneTexte 483029020"/>
           <p:cNvSpPr txBox="1"/>
           <p:nvPr/>
         </p:nvSpPr>
@@ -22819,7 +22811,7 @@
       </p:sp>
       <p:cxnSp>
         <p:nvCxnSpPr>
-          <p:cNvPr id="223919695" name="Connecteur droit 626166318"/>
+          <p:cNvPr id="1257275958" name="Connecteur droit 626166318"/>
           <p:cNvCxnSpPr/>
           <p:nvPr/>
         </p:nvCxnSpPr>
@@ -22862,7 +22854,7 @@
       </p:cxnSp>
       <p:sp>
         <p:nvSpPr>
-          <p:cNvPr id="353649003" name="ZoneTexte 2021489157"/>
+          <p:cNvPr id="1975798018" name="ZoneTexte 2021489157"/>
           <p:cNvSpPr txBox="1"/>
           <p:nvPr/>
         </p:nvSpPr>
@@ -22902,7 +22894,7 @@
       </p:sp>
       <p:cxnSp>
         <p:nvCxnSpPr>
-          <p:cNvPr id="1929945060" name="Connecteur droit 1991074862"/>
+          <p:cNvPr id="425895818" name="Connecteur droit 1991074862"/>
           <p:cNvCxnSpPr/>
           <p:nvPr/>
         </p:nvCxnSpPr>
@@ -22945,7 +22937,7 @@
       </p:cxnSp>
       <p:sp>
         <p:nvSpPr>
-          <p:cNvPr id="886747521" name="ZoneTexte 1094835336"/>
+          <p:cNvPr id="1360303659" name="ZoneTexte 1094835336"/>
           <p:cNvSpPr txBox="1"/>
           <p:nvPr/>
         </p:nvSpPr>
@@ -23027,7 +23019,7 @@
       </p:sp>
       <p:sp>
         <p:nvSpPr>
-          <p:cNvPr id="884738375" name="Rectangle : avec coins arrondis en haut 1574209032"/>
+          <p:cNvPr id="223471646" name="Rectangle : avec coins arrondis en haut 1574209032"/>
           <p:cNvSpPr/>
           <p:nvPr/>
         </p:nvSpPr>
@@ -23073,7 +23065,7 @@
       </p:sp>
       <p:sp>
         <p:nvSpPr>
-          <p:cNvPr id="1704484196" name="Flèche : pentagone 521086653"/>
+          <p:cNvPr id="1507023305" name="Flèche : pentagone 521086653"/>
           <p:cNvSpPr/>
           <p:nvPr/>
         </p:nvSpPr>
@@ -23118,7 +23110,7 @@
       </p:sp>
       <p:sp>
         <p:nvSpPr>
-          <p:cNvPr id="499481763" name="Flèche : pentagone 1507310733"/>
+          <p:cNvPr id="710745071" name="Flèche : pentagone 1507310733"/>
           <p:cNvSpPr/>
           <p:nvPr/>
         </p:nvSpPr>
@@ -23163,7 +23155,7 @@
       </p:sp>
       <p:sp>
         <p:nvSpPr>
-          <p:cNvPr id="1250211229" name="Flèche : pentagone 732388424"/>
+          <p:cNvPr id="850134923" name="Flèche : pentagone 732388424"/>
           <p:cNvSpPr/>
           <p:nvPr/>
         </p:nvSpPr>
@@ -23208,7 +23200,7 @@
       </p:sp>
       <p:sp>
         <p:nvSpPr>
-          <p:cNvPr id="799554721" name="Flèche : pentagone 326874465"/>
+          <p:cNvPr id="1315492640" name="Flèche : pentagone 326874465"/>
           <p:cNvSpPr/>
           <p:nvPr/>
         </p:nvSpPr>
@@ -23253,7 +23245,7 @@
       </p:sp>
       <p:sp>
         <p:nvSpPr>
-          <p:cNvPr id="1174155179" name="Flèche : pentagone 2090650957"/>
+          <p:cNvPr id="708903371" name="Flèche : pentagone 2090650957"/>
           <p:cNvSpPr/>
           <p:nvPr/>
         </p:nvSpPr>
@@ -23298,14 +23290,14 @@
       </p:sp>
       <p:sp>
         <p:nvSpPr>
-          <p:cNvPr id="640628238" name="ZoneTexte 1374103996"/>
+          <p:cNvPr id="41714026" name="ZoneTexte 1374103996"/>
           <p:cNvSpPr txBox="1"/>
           <p:nvPr/>
         </p:nvSpPr>
         <p:spPr bwMode="auto">
           <a:xfrm flipH="0" flipV="0">
-            <a:off x="3252177" y="7134400"/>
-            <a:ext cx="3639114" cy="2652119"/>
+            <a:off x="3252177" y="7134399"/>
+            <a:ext cx="3602394" cy="2774039"/>
           </a:xfrm>
           <a:prstGeom prst="rect">
             <a:avLst/>
@@ -23330,7 +23322,7 @@
                   </a:schemeClr>
                 </a:solidFill>
               </a:rPr>
-              <a:t>Chaque case d’Hubris cochée entraîne un </a:t>
+              <a:t>Chaque case d’hubris cochée entraîne un </a:t>
             </a:r>
             <a:r>
               <a:rPr sz="800" b="1">
@@ -23366,7 +23358,7 @@
                 <a:ea typeface="+mn-ea"/>
                 <a:cs typeface="+mn-cs"/>
               </a:rPr>
-              <a:t>Après un test de maîtrise de soi réussi, cochez une case d’hubris. Vous pouvez diminuer votre hubris en méditant pour vous reconnecter à votre nature profonde durant une scène et en pratiquant un rituel de purification.</a:t>
+              <a:t>Après une épreuve de maîtrise de soi échouée, cochez une case d’hubris. </a:t>
             </a:r>
             <a:r>
               <a:rPr lang="fr-FR" sz="800" b="0" i="0" u="none" strike="noStrike" cap="none" spc="0">
@@ -23380,7 +23372,21 @@
                 <a:ea typeface="Arial"/>
                 <a:cs typeface="Arial"/>
               </a:rPr>
-              <a:t> Si vous échouez à votre test de maîtrise de soi, cochez une case de corruption.</a:t>
+              <a:t>Si vous réussissez un choc de maîtrise de soi, cochez une case d’hubris. Si vous échouez à un choc de maîtrise de soi, cochez une case de corruption. </a:t>
+            </a:r>
+            <a:r>
+              <a:rPr lang="fr-FR" sz="800" b="0" i="0" u="none" strike="noStrike" cap="none" spc="0">
+                <a:solidFill>
+                  <a:schemeClr val="tx1">
+                    <a:lumMod val="50000"/>
+                    <a:lumOff val="50000"/>
+                  </a:schemeClr>
+                </a:solidFill>
+                <a:latin typeface="Arial"/>
+                <a:ea typeface="Arial"/>
+                <a:cs typeface="Arial"/>
+              </a:rPr>
+              <a:t>Vous pouvez diminuer votre hubris en méditant pour vous reconnecter à votre nature profonde durant une scène et en pratiquant un rituel de purification.</a:t>
             </a:r>
             <a:endParaRPr lang="fr-FR" sz="800" b="0" i="0" u="none" strike="noStrike" cap="none" spc="0">
               <a:solidFill>
@@ -23571,7 +23577,7 @@
       </p:sp>
       <p:sp>
         <p:nvSpPr>
-          <p:cNvPr id="787531564" name="ZoneTexte 1748705365"/>
+          <p:cNvPr id="1708275734" name="ZoneTexte 1748705365"/>
           <p:cNvSpPr txBox="1"/>
           <p:nvPr/>
         </p:nvSpPr>
@@ -23611,7 +23617,7 @@
       </p:sp>
       <p:cxnSp>
         <p:nvCxnSpPr>
-          <p:cNvPr id="478178043" name="Connecteur droit 1556830908"/>
+          <p:cNvPr id="1670723432" name="Connecteur droit 1556830908"/>
           <p:cNvCxnSpPr/>
           <p:nvPr/>
         </p:nvCxnSpPr>
@@ -23654,7 +23660,7 @@
       </p:cxnSp>
       <p:sp>
         <p:nvSpPr>
-          <p:cNvPr id="805618818" name="ZoneTexte 409639257"/>
+          <p:cNvPr id="1298133452" name="ZoneTexte 409639257"/>
           <p:cNvSpPr txBox="1"/>
           <p:nvPr/>
         </p:nvSpPr>
@@ -23704,7 +23710,7 @@
       </p:sp>
       <p:sp>
         <p:nvSpPr>
-          <p:cNvPr id="872464940" name="ZoneTexte 1168472887"/>
+          <p:cNvPr id="1651004070" name="ZoneTexte 1168472887"/>
           <p:cNvSpPr txBox="1"/>
           <p:nvPr/>
         </p:nvSpPr>
@@ -23989,7 +23995,7 @@
       </p:sp>
       <p:sp>
         <p:nvSpPr>
-          <p:cNvPr id="1846095214" name="ZoneTexte 114796530"/>
+          <p:cNvPr id="1596943327" name="ZoneTexte 114796530"/>
           <p:cNvSpPr txBox="1"/>
           <p:nvPr/>
         </p:nvSpPr>
@@ -24367,7 +24373,7 @@
       </p:sp>
       <p:sp>
         <p:nvSpPr>
-          <p:cNvPr id="641833951" name="ZoneTexte 1085068195"/>
+          <p:cNvPr id="489235130" name="ZoneTexte 1085068195"/>
           <p:cNvSpPr txBox="1"/>
           <p:nvPr/>
         </p:nvSpPr>
@@ -25493,7 +25499,7 @@
       </p:sp>
       <p:sp>
         <p:nvSpPr>
-          <p:cNvPr id="313954208" name="Étoile : 5 branches 278736380"/>
+          <p:cNvPr id="909321350" name="Étoile : 5 branches 278736380"/>
           <p:cNvSpPr/>
           <p:nvPr/>
         </p:nvSpPr>
@@ -25540,7 +25546,7 @@
       </p:sp>
       <p:sp>
         <p:nvSpPr>
-          <p:cNvPr id="818346800" name="Étoile : 5 branches 1495350449"/>
+          <p:cNvPr id="690427963" name="Étoile : 5 branches 1495350449"/>
           <p:cNvSpPr/>
           <p:nvPr/>
         </p:nvSpPr>
@@ -25587,7 +25593,7 @@
       </p:sp>
       <p:sp>
         <p:nvSpPr>
-          <p:cNvPr id="1280394579" name="Étoile : 5 branches 79046386"/>
+          <p:cNvPr id="999586084" name="Étoile : 5 branches 79046386"/>
           <p:cNvSpPr/>
           <p:nvPr/>
         </p:nvSpPr>
@@ -25634,7 +25640,7 @@
       </p:sp>
       <p:sp>
         <p:nvSpPr>
-          <p:cNvPr id="1709261930" name="Étoile : 5 branches 749256076"/>
+          <p:cNvPr id="1474669068" name="Étoile : 5 branches 749256076"/>
           <p:cNvSpPr/>
           <p:nvPr/>
         </p:nvSpPr>
@@ -25681,7 +25687,7 @@
       </p:sp>
       <p:sp>
         <p:nvSpPr>
-          <p:cNvPr id="378524086" name="Étoile : 5 branches 411245083"/>
+          <p:cNvPr id="766989575" name="Étoile : 5 branches 411245083"/>
           <p:cNvSpPr/>
           <p:nvPr/>
         </p:nvSpPr>
@@ -25728,7 +25734,7 @@
       </p:sp>
       <p:sp>
         <p:nvSpPr>
-          <p:cNvPr id="587470465" name="ZoneTexte 496444952"/>
+          <p:cNvPr id="1735966127" name="ZoneTexte 496444952"/>
           <p:cNvSpPr txBox="1"/>
           <p:nvPr/>
         </p:nvSpPr>
@@ -25770,7 +25776,7 @@
       </p:sp>
       <p:sp>
         <p:nvSpPr>
-          <p:cNvPr id="1025022191" name="ZoneTexte 474433989"/>
+          <p:cNvPr id="196173645" name="ZoneTexte 474433989"/>
           <p:cNvSpPr txBox="1"/>
           <p:nvPr/>
         </p:nvSpPr>
@@ -25812,7 +25818,7 @@
       </p:sp>
       <p:sp>
         <p:nvSpPr>
-          <p:cNvPr id="794250017" name="ZoneTexte 1"/>
+          <p:cNvPr id="626535147" name="ZoneTexte 1"/>
           <p:cNvSpPr txBox="1"/>
           <p:nvPr/>
         </p:nvSpPr>
@@ -25913,7 +25919,7 @@
       </p:sp>
       <p:sp>
         <p:nvSpPr>
-          <p:cNvPr id="2078935424" name="ZoneTexte 2"/>
+          <p:cNvPr id="1996539142" name="ZoneTexte 2"/>
           <p:cNvSpPr txBox="1"/>
           <p:nvPr/>
         </p:nvSpPr>
@@ -26031,7 +26037,7 @@
       </p:sp>
       <p:sp>
         <p:nvSpPr>
-          <p:cNvPr id="2130877399" name=""/>
+          <p:cNvPr id="1735183187" name=""/>
           <p:cNvSpPr/>
           <p:nvPr/>
         </p:nvSpPr>
@@ -26102,7 +26108,7 @@
       </p:sp>
       <p:sp>
         <p:nvSpPr>
-          <p:cNvPr id="1768233873" name="Flèche : pentagone 1507310733"/>
+          <p:cNvPr id="1993262628" name="Flèche : pentagone 1507310733"/>
           <p:cNvSpPr/>
           <p:nvPr/>
         </p:nvSpPr>
@@ -26147,7 +26153,7 @@
       </p:sp>
       <p:sp>
         <p:nvSpPr>
-          <p:cNvPr id="1794425274" name="Flèche : pentagone 732388424"/>
+          <p:cNvPr id="1519321939" name="Flèche : pentagone 732388424"/>
           <p:cNvSpPr/>
           <p:nvPr/>
         </p:nvSpPr>
@@ -26192,7 +26198,7 @@
       </p:sp>
       <p:sp>
         <p:nvSpPr>
-          <p:cNvPr id="2133463687" name="Flèche : pentagone 326874465"/>
+          <p:cNvPr id="1007289477" name="Flèche : pentagone 326874465"/>
           <p:cNvSpPr/>
           <p:nvPr/>
         </p:nvSpPr>
@@ -26270,7 +26276,7 @@
       </p:grpSpPr>
       <p:sp>
         <p:nvSpPr>
-          <p:cNvPr id="1968950398" name="ZoneTexte 273581705"/>
+          <p:cNvPr id="76367496" name="ZoneTexte 273581705"/>
           <p:cNvSpPr txBox="1"/>
           <p:nvPr/>
         </p:nvSpPr>
@@ -26568,7 +26574,7 @@
       </p:sp>
       <p:cxnSp>
         <p:nvCxnSpPr>
-          <p:cNvPr id="1050238293" name="Connecteur droit 1094832104"/>
+          <p:cNvPr id="819180566" name="Connecteur droit 1094832104"/>
           <p:cNvCxnSpPr/>
           <p:nvPr/>
         </p:nvCxnSpPr>
@@ -26611,7 +26617,7 @@
       </p:cxnSp>
       <p:sp>
         <p:nvSpPr>
-          <p:cNvPr id="684138979" name="ZoneTexte 2078543737"/>
+          <p:cNvPr id="1987112866" name="ZoneTexte 2078543737"/>
           <p:cNvSpPr txBox="1"/>
           <p:nvPr/>
         </p:nvSpPr>
@@ -26651,7 +26657,7 @@
       </p:sp>
       <p:cxnSp>
         <p:nvCxnSpPr>
-          <p:cNvPr id="2020117561" name="Connecteur droit 853743145"/>
+          <p:cNvPr id="240915531" name="Connecteur droit 853743145"/>
           <p:cNvCxnSpPr/>
           <p:nvPr/>
         </p:nvCxnSpPr>
@@ -26694,7 +26700,7 @@
       </p:cxnSp>
       <p:sp>
         <p:nvSpPr>
-          <p:cNvPr id="1624027286" name="ZoneTexte 1473119298"/>
+          <p:cNvPr id="1201220389" name="ZoneTexte 1473119298"/>
           <p:cNvSpPr txBox="1"/>
           <p:nvPr/>
         </p:nvSpPr>
@@ -26734,7 +26740,7 @@
       </p:sp>
       <p:cxnSp>
         <p:nvCxnSpPr>
-          <p:cNvPr id="2078538214" name="Connecteur droit 1727809509"/>
+          <p:cNvPr id="853975640" name="Connecteur droit 1727809509"/>
           <p:cNvCxnSpPr/>
           <p:nvPr/>
         </p:nvCxnSpPr>
@@ -26777,7 +26783,7 @@
       </p:cxnSp>
       <p:sp>
         <p:nvSpPr>
-          <p:cNvPr id="641953977" name="ZoneTexte 759238070"/>
+          <p:cNvPr id="1564390764" name="ZoneTexte 759238070"/>
           <p:cNvSpPr txBox="1"/>
           <p:nvPr/>
         </p:nvSpPr>
@@ -26852,7 +26858,7 @@
       </p:sp>
       <p:sp>
         <p:nvSpPr>
-          <p:cNvPr id="1960519122" name="Rectangle : avec coins arrondis en haut 965147191"/>
+          <p:cNvPr id="1987219180" name="Rectangle : avec coins arrondis en haut 965147191"/>
           <p:cNvSpPr/>
           <p:nvPr/>
         </p:nvSpPr>
@@ -26898,7 +26904,7 @@
       </p:sp>
       <p:sp>
         <p:nvSpPr>
-          <p:cNvPr id="65735639" name="Flèche : pentagone 2070329900"/>
+          <p:cNvPr id="1618510730" name="Flèche : pentagone 2070329900"/>
           <p:cNvSpPr/>
           <p:nvPr/>
         </p:nvSpPr>
@@ -26943,7 +26949,7 @@
       </p:sp>
       <p:sp>
         <p:nvSpPr>
-          <p:cNvPr id="1370491936" name="Flèche : pentagone 1325137089"/>
+          <p:cNvPr id="470940618" name="Flèche : pentagone 1325137089"/>
           <p:cNvSpPr/>
           <p:nvPr/>
         </p:nvSpPr>
@@ -26988,7 +26994,7 @@
       </p:sp>
       <p:sp>
         <p:nvSpPr>
-          <p:cNvPr id="1085323765" name="Flèche : pentagone 295922856"/>
+          <p:cNvPr id="658289539" name="Flèche : pentagone 295922856"/>
           <p:cNvSpPr/>
           <p:nvPr/>
         </p:nvSpPr>
@@ -27033,7 +27039,7 @@
       </p:sp>
       <p:sp>
         <p:nvSpPr>
-          <p:cNvPr id="823918728" name="Flèche : pentagone 1961547672"/>
+          <p:cNvPr id="274052788" name="Flèche : pentagone 1961547672"/>
           <p:cNvSpPr/>
           <p:nvPr/>
         </p:nvSpPr>
@@ -27078,7 +27084,7 @@
       </p:sp>
       <p:sp>
         <p:nvSpPr>
-          <p:cNvPr id="1055890644" name="Flèche : pentagone 1305647833"/>
+          <p:cNvPr id="1157465230" name="Flèche : pentagone 1305647833"/>
           <p:cNvSpPr/>
           <p:nvPr/>
         </p:nvSpPr>
@@ -27123,14 +27129,14 @@
       </p:sp>
       <p:sp>
         <p:nvSpPr>
-          <p:cNvPr id="1125901458" name="ZoneTexte 545814566"/>
+          <p:cNvPr id="353563391" name="ZoneTexte 545814566"/>
           <p:cNvSpPr txBox="1"/>
           <p:nvPr/>
         </p:nvSpPr>
         <p:spPr bwMode="auto">
           <a:xfrm flipH="0" flipV="0">
-            <a:off x="3252178" y="7249356"/>
-            <a:ext cx="3621472" cy="2408279"/>
+            <a:off x="3252177" y="7209668"/>
+            <a:ext cx="3603111" cy="2652119"/>
           </a:xfrm>
           <a:prstGeom prst="rect">
             <a:avLst/>
@@ -27177,7 +27183,7 @@
                   </a:schemeClr>
                 </a:solidFill>
               </a:rPr>
-              <a:t>. Après un test de maîtrise de soi réussi, cochez une case de soif. </a:t>
+              <a:t>. Si vous échouez à une épreuve de maîtrise de soi, cochez une case de soif. </a:t>
             </a:r>
             <a:r>
               <a:rPr lang="fr-FR" sz="800" b="0" i="0" u="none" strike="noStrike" cap="none" spc="0">
@@ -27191,7 +27197,7 @@
                 <a:ea typeface="+mn-ea"/>
                 <a:cs typeface="+mn-cs"/>
               </a:rPr>
-              <a:t>Si vous échouez à un test de maîtrise de soi, cochez une case de perversion. Lorsque vous vous nourrissez de sang, vous pouvez effacer vos cases de soif. </a:t>
+              <a:t>Si vous réussissez à un choc de maîtrise de soi, cochez une case de soif. Si vous échouez à un choc de maîtrise de soi, cochez une case de perversion. Lorsque vous vous nourrissez de sang, vous pouvez effacer vos cases de soif. </a:t>
             </a:r>
             <a:endParaRPr sz="800">
               <a:solidFill>
@@ -27425,7 +27431,7 @@
       </p:sp>
       <p:sp>
         <p:nvSpPr>
-          <p:cNvPr id="1720304327" name="ZoneTexte 671978155"/>
+          <p:cNvPr id="1563888156" name="ZoneTexte 671978155"/>
           <p:cNvSpPr txBox="1"/>
           <p:nvPr/>
         </p:nvSpPr>
@@ -27465,7 +27471,7 @@
       </p:sp>
       <p:cxnSp>
         <p:nvCxnSpPr>
-          <p:cNvPr id="2066098241" name="Connecteur droit 637589304"/>
+          <p:cNvPr id="1770152566" name="Connecteur droit 637589304"/>
           <p:cNvCxnSpPr/>
           <p:nvPr/>
         </p:nvCxnSpPr>
@@ -27508,7 +27514,7 @@
       </p:cxnSp>
       <p:sp>
         <p:nvSpPr>
-          <p:cNvPr id="217350333" name="ZoneTexte 172075623"/>
+          <p:cNvPr id="849397241" name="ZoneTexte 172075623"/>
           <p:cNvSpPr txBox="1"/>
           <p:nvPr/>
         </p:nvSpPr>
@@ -27558,7 +27564,7 @@
       </p:sp>
       <p:sp>
         <p:nvSpPr>
-          <p:cNvPr id="1194353101" name="ZoneTexte 1642812764"/>
+          <p:cNvPr id="1022739783" name="ZoneTexte 1642812764"/>
           <p:cNvSpPr txBox="1"/>
           <p:nvPr/>
         </p:nvSpPr>
@@ -27747,7 +27753,7 @@
       </p:sp>
       <p:sp>
         <p:nvSpPr>
-          <p:cNvPr id="151346959" name="Étoile : 7 branches 1681961038"/>
+          <p:cNvPr id="1357926259" name="Étoile : 7 branches 1681961038"/>
           <p:cNvSpPr/>
           <p:nvPr/>
         </p:nvSpPr>
@@ -27794,7 +27800,7 @@
       </p:sp>
       <p:sp>
         <p:nvSpPr>
-          <p:cNvPr id="78213850" name="Étoile : 7 branches 1476951547"/>
+          <p:cNvPr id="1548474571" name="Étoile : 7 branches 1476951547"/>
           <p:cNvSpPr/>
           <p:nvPr/>
         </p:nvSpPr>
@@ -27841,7 +27847,7 @@
       </p:sp>
       <p:sp>
         <p:nvSpPr>
-          <p:cNvPr id="802274116" name="Étoile : 7 branches 1520826925"/>
+          <p:cNvPr id="980611172" name="Étoile : 7 branches 1520826925"/>
           <p:cNvSpPr/>
           <p:nvPr/>
         </p:nvSpPr>
@@ -27888,7 +27894,7 @@
       </p:sp>
       <p:sp>
         <p:nvSpPr>
-          <p:cNvPr id="927022789" name="ZoneTexte 1219899073"/>
+          <p:cNvPr id="834398221" name="ZoneTexte 1219899073"/>
           <p:cNvSpPr txBox="1"/>
           <p:nvPr/>
         </p:nvSpPr>
@@ -27928,7 +27934,7 @@
       </p:sp>
       <p:sp>
         <p:nvSpPr>
-          <p:cNvPr id="894270370" name="ZoneTexte 1283574123"/>
+          <p:cNvPr id="830181110" name="ZoneTexte 1283574123"/>
           <p:cNvSpPr txBox="1"/>
           <p:nvPr/>
         </p:nvSpPr>
@@ -28911,7 +28917,7 @@
       </p:sp>
       <p:sp>
         <p:nvSpPr>
-          <p:cNvPr id="612114348" name="ZoneTexte 790352176"/>
+          <p:cNvPr id="1740626819" name="ZoneTexte 790352176"/>
           <p:cNvSpPr txBox="1"/>
           <p:nvPr/>
         </p:nvSpPr>
@@ -28953,7 +28959,7 @@
       </p:sp>
       <p:sp>
         <p:nvSpPr>
-          <p:cNvPr id="882678340" name="ZoneTexte 2025740189"/>
+          <p:cNvPr id="1280907199" name="ZoneTexte 2025740189"/>
           <p:cNvSpPr txBox="1"/>
           <p:nvPr/>
         </p:nvSpPr>
@@ -29010,7 +29016,7 @@
       </p:sp>
       <p:sp>
         <p:nvSpPr>
-          <p:cNvPr id="824273109" name=""/>
+          <p:cNvPr id="320926438" name=""/>
           <p:cNvSpPr/>
           <p:nvPr/>
         </p:nvSpPr>
@@ -29050,7 +29056,7 @@
       </p:sp>
       <p:sp>
         <p:nvSpPr>
-          <p:cNvPr id="582113805" name="Rectangle : avec coins arrondis en haut 1151560973"/>
+          <p:cNvPr id="1287122166" name="Rectangle : avec coins arrondis en haut 1151560973"/>
           <p:cNvSpPr/>
           <p:nvPr/>
         </p:nvSpPr>
@@ -29098,7 +29104,7 @@
       </p:sp>
       <p:sp>
         <p:nvSpPr>
-          <p:cNvPr id="1217321013" name=""/>
+          <p:cNvPr id="168376835" name=""/>
           <p:cNvSpPr/>
           <p:nvPr/>
         </p:nvSpPr>
@@ -29138,7 +29144,7 @@
       </p:sp>
       <p:sp>
         <p:nvSpPr>
-          <p:cNvPr id="1593386879" name="Rectangle : avec coins arrondis en haut 1151560973"/>
+          <p:cNvPr id="1314108518" name="Rectangle : avec coins arrondis en haut 1151560973"/>
           <p:cNvSpPr/>
           <p:nvPr/>
         </p:nvSpPr>
@@ -29186,7 +29192,7 @@
       </p:sp>
       <p:sp>
         <p:nvSpPr>
-          <p:cNvPr id="737342628" name=""/>
+          <p:cNvPr id="460959396" name=""/>
           <p:cNvSpPr/>
           <p:nvPr/>
         </p:nvSpPr>
@@ -29226,7 +29232,7 @@
       </p:sp>
       <p:sp>
         <p:nvSpPr>
-          <p:cNvPr id="1839835660" name="Rectangle : avec coins arrondis en haut 1151560973"/>
+          <p:cNvPr id="1813943262" name="Rectangle : avec coins arrondis en haut 1151560973"/>
           <p:cNvSpPr/>
           <p:nvPr/>
         </p:nvSpPr>
@@ -29274,7 +29280,7 @@
       </p:sp>
       <p:sp>
         <p:nvSpPr>
-          <p:cNvPr id="1124911377" name=""/>
+          <p:cNvPr id="1589702726" name=""/>
           <p:cNvSpPr txBox="1"/>
           <p:nvPr/>
         </p:nvSpPr>
@@ -29402,7 +29408,7 @@
       </p:sp>
       <p:sp>
         <p:nvSpPr>
-          <p:cNvPr id="398705570" name=""/>
+          <p:cNvPr id="603214370" name=""/>
           <p:cNvSpPr txBox="1"/>
           <p:nvPr/>
         </p:nvSpPr>
@@ -29525,7 +29531,7 @@
       </p:sp>
       <p:sp>
         <p:nvSpPr>
-          <p:cNvPr id="1634646182" name=""/>
+          <p:cNvPr id="2007710764" name=""/>
           <p:cNvSpPr/>
           <p:nvPr/>
         </p:nvSpPr>
@@ -29596,7 +29602,7 @@
       </p:sp>
       <p:sp>
         <p:nvSpPr>
-          <p:cNvPr id="815866738" name="Flèche : pentagone 1325137089"/>
+          <p:cNvPr id="1059096730" name="Flèche : pentagone 1325137089"/>
           <p:cNvSpPr/>
           <p:nvPr/>
         </p:nvSpPr>
@@ -29641,7 +29647,7 @@
       </p:sp>
       <p:sp>
         <p:nvSpPr>
-          <p:cNvPr id="1604799581" name="Flèche : pentagone 295922856"/>
+          <p:cNvPr id="594854256" name="Flèche : pentagone 295922856"/>
           <p:cNvSpPr/>
           <p:nvPr/>
         </p:nvSpPr>
@@ -29686,7 +29692,7 @@
       </p:sp>
       <p:sp>
         <p:nvSpPr>
-          <p:cNvPr id="1833788049" name="Flèche : pentagone 1961547672"/>
+          <p:cNvPr id="6365743" name="Flèche : pentagone 1961547672"/>
           <p:cNvSpPr/>
           <p:nvPr/>
         </p:nvSpPr>
@@ -29764,7 +29770,7 @@
       </p:grpSpPr>
       <p:cxnSp>
         <p:nvCxnSpPr>
-          <p:cNvPr id="1121445696" name="Connecteur droit 266926011"/>
+          <p:cNvPr id="1753681886" name="Connecteur droit 266926011"/>
           <p:cNvCxnSpPr/>
           <p:nvPr/>
         </p:nvCxnSpPr>
@@ -29807,7 +29813,7 @@
       </p:cxnSp>
       <p:sp>
         <p:nvSpPr>
-          <p:cNvPr id="2127747989" name="ZoneTexte 1043763612"/>
+          <p:cNvPr id="259543649" name="ZoneTexte 1043763612"/>
           <p:cNvSpPr txBox="1"/>
           <p:nvPr/>
         </p:nvSpPr>
@@ -29847,7 +29853,7 @@
       </p:sp>
       <p:cxnSp>
         <p:nvCxnSpPr>
-          <p:cNvPr id="1509716605" name="Connecteur droit 1586327141"/>
+          <p:cNvPr id="820006435" name="Connecteur droit 1586327141"/>
           <p:cNvCxnSpPr/>
           <p:nvPr/>
         </p:nvCxnSpPr>
@@ -29890,7 +29896,7 @@
       </p:cxnSp>
       <p:sp>
         <p:nvSpPr>
-          <p:cNvPr id="920824085" name="ZoneTexte 1691387439"/>
+          <p:cNvPr id="345008247" name="ZoneTexte 1691387439"/>
           <p:cNvSpPr txBox="1"/>
           <p:nvPr/>
         </p:nvSpPr>
@@ -29930,7 +29936,7 @@
       </p:sp>
       <p:cxnSp>
         <p:nvCxnSpPr>
-          <p:cNvPr id="1832300827" name="Connecteur droit 1743707585"/>
+          <p:cNvPr id="1904516477" name="Connecteur droit 1743707585"/>
           <p:cNvCxnSpPr/>
           <p:nvPr/>
         </p:nvCxnSpPr>
@@ -29973,7 +29979,7 @@
       </p:cxnSp>
       <p:sp>
         <p:nvSpPr>
-          <p:cNvPr id="655736038" name="ZoneTexte 1503300725"/>
+          <p:cNvPr id="435482451" name="ZoneTexte 1503300725"/>
           <p:cNvSpPr txBox="1"/>
           <p:nvPr/>
         </p:nvSpPr>
@@ -30055,7 +30061,7 @@
       </p:sp>
       <p:sp>
         <p:nvSpPr>
-          <p:cNvPr id="865874376" name="Rectangle : avec coins arrondis en haut 1151560973"/>
+          <p:cNvPr id="220385855" name="Rectangle : avec coins arrondis en haut 1151560973"/>
           <p:cNvSpPr/>
           <p:nvPr/>
         </p:nvSpPr>
@@ -30101,7 +30107,7 @@
       </p:sp>
       <p:sp>
         <p:nvSpPr>
-          <p:cNvPr id="1096912003" name="Flèche : pentagone 1610574377"/>
+          <p:cNvPr id="856706994" name="Flèche : pentagone 1610574377"/>
           <p:cNvSpPr/>
           <p:nvPr/>
         </p:nvSpPr>
@@ -30146,7 +30152,7 @@
       </p:sp>
       <p:sp>
         <p:nvSpPr>
-          <p:cNvPr id="472406102" name="Flèche : pentagone 463861063"/>
+          <p:cNvPr id="75443619" name="Flèche : pentagone 463861063"/>
           <p:cNvSpPr/>
           <p:nvPr/>
         </p:nvSpPr>
@@ -30191,7 +30197,7 @@
       </p:sp>
       <p:sp>
         <p:nvSpPr>
-          <p:cNvPr id="854035438" name="Flèche : pentagone 272004907"/>
+          <p:cNvPr id="2091102768" name="Flèche : pentagone 272004907"/>
           <p:cNvSpPr/>
           <p:nvPr/>
         </p:nvSpPr>
@@ -30236,7 +30242,7 @@
       </p:sp>
       <p:sp>
         <p:nvSpPr>
-          <p:cNvPr id="541023008" name="Flèche : pentagone 28174069"/>
+          <p:cNvPr id="89635411" name="Flèche : pentagone 28174069"/>
           <p:cNvSpPr/>
           <p:nvPr/>
         </p:nvSpPr>
@@ -30281,7 +30287,7 @@
       </p:sp>
       <p:sp>
         <p:nvSpPr>
-          <p:cNvPr id="634634263" name="Flèche : pentagone 978127220"/>
+          <p:cNvPr id="777402171" name="Flèche : pentagone 978127220"/>
           <p:cNvSpPr/>
           <p:nvPr/>
         </p:nvSpPr>
@@ -30326,14 +30332,14 @@
       </p:sp>
       <p:sp>
         <p:nvSpPr>
-          <p:cNvPr id="1061747482" name="ZoneTexte 1693594013"/>
+          <p:cNvPr id="1109355734" name="ZoneTexte 1693594013"/>
           <p:cNvSpPr txBox="1"/>
           <p:nvPr/>
         </p:nvSpPr>
         <p:spPr bwMode="auto">
           <a:xfrm flipH="0" flipV="0">
-            <a:off x="3252178" y="6794593"/>
-            <a:ext cx="3604192" cy="2895959"/>
+            <a:off x="3252177" y="6794592"/>
+            <a:ext cx="3613194" cy="3017880"/>
           </a:xfrm>
           <a:prstGeom prst="rect">
             <a:avLst/>
@@ -30391,7 +30397,7 @@
                   </a:schemeClr>
                 </a:solidFill>
               </a:rPr>
-              <a:t> </a:t>
+              <a:t> Si vous échouez une épreuve </a:t>
             </a:r>
             <a:r>
               <a:rPr lang="fr-FR" sz="800" b="0" i="0" u="none" strike="noStrike" cap="none" spc="0">
@@ -30405,7 +30411,7 @@
                 <a:ea typeface="Arial"/>
                 <a:cs typeface="Arial"/>
               </a:rPr>
-              <a:t>Après un test de maîtrise de soi réussi, cochez une case de pulsation. Si vous échouez à votre test de maîtrise de soi, cochez une case de colère.</a:t>
+              <a:t>de maîtrise de soi, cochez une case de pulsation. Si vous réussissez un choc de maîtrise de soi, cochez une case de pulsation. Si vous échouez à un choc de maîtrise de soi, cochez une case de colère.</a:t>
             </a:r>
             <a:r>
               <a:rPr lang="fr-FR" sz="800" b="0" i="0" u="none" strike="noStrike" cap="none" spc="0">
@@ -30419,7 +30425,7 @@
                 <a:ea typeface="Arial"/>
                 <a:cs typeface="Arial"/>
               </a:rPr>
-              <a:t> Vous pouvez diminuer votre pulsation en vous harmonisant à la nature.</a:t>
+              <a:t> Vous pouvez effacer une case de pulsation en vous harmonisant à la nature.</a:t>
             </a:r>
             <a:endParaRPr sz="800">
               <a:solidFill>
@@ -30677,7 +30683,7 @@
       </p:sp>
       <p:sp>
         <p:nvSpPr>
-          <p:cNvPr id="72887749" name="ZoneTexte 1975797288"/>
+          <p:cNvPr id="16740282" name="ZoneTexte 1975797288"/>
           <p:cNvSpPr txBox="1"/>
           <p:nvPr/>
         </p:nvSpPr>
@@ -30717,7 +30723,7 @@
       </p:sp>
       <p:sp>
         <p:nvSpPr>
-          <p:cNvPr id="954971418" name="ZoneTexte 2064865984"/>
+          <p:cNvPr id="1402627254" name="ZoneTexte 2064865984"/>
           <p:cNvSpPr txBox="1"/>
           <p:nvPr/>
         </p:nvSpPr>
@@ -30939,7 +30945,7 @@
       </p:sp>
       <p:sp>
         <p:nvSpPr>
-          <p:cNvPr id="1380473758" name="ZoneTexte 1387173154"/>
+          <p:cNvPr id="1351452128" name="ZoneTexte 1387173154"/>
           <p:cNvSpPr txBox="1"/>
           <p:nvPr/>
         </p:nvSpPr>
@@ -31191,7 +31197,7 @@
       </p:sp>
       <p:sp>
         <p:nvSpPr>
-          <p:cNvPr id="624966799" name="ZoneTexte 523755832"/>
+          <p:cNvPr id="553804603" name="ZoneTexte 523755832"/>
           <p:cNvSpPr txBox="1"/>
           <p:nvPr/>
         </p:nvSpPr>
@@ -31451,7 +31457,7 @@
       </p:sp>
       <p:cxnSp>
         <p:nvCxnSpPr>
-          <p:cNvPr id="754440574" name="Connecteur droit 2085669542"/>
+          <p:cNvPr id="1673881241" name="Connecteur droit 2085669542"/>
           <p:cNvCxnSpPr/>
           <p:nvPr/>
         </p:nvCxnSpPr>
@@ -31494,7 +31500,7 @@
       </p:cxnSp>
       <p:sp>
         <p:nvSpPr>
-          <p:cNvPr id="1170164881" name="ZoneTexte 34398067"/>
+          <p:cNvPr id="586965177" name="ZoneTexte 34398067"/>
           <p:cNvSpPr txBox="1"/>
           <p:nvPr/>
         </p:nvSpPr>
@@ -31537,7 +31543,7 @@
       </p:sp>
       <p:sp>
         <p:nvSpPr>
-          <p:cNvPr id="716214869" name="ZoneTexte 273581705"/>
+          <p:cNvPr id="1362357947" name="ZoneTexte 273581705"/>
           <p:cNvSpPr txBox="1"/>
           <p:nvPr/>
         </p:nvSpPr>
@@ -31835,7 +31841,7 @@
       </p:sp>
       <p:sp>
         <p:nvSpPr>
-          <p:cNvPr id="443059261" name="ZoneTexte 1727393832"/>
+          <p:cNvPr id="970147706" name="ZoneTexte 1727393832"/>
           <p:cNvSpPr txBox="1"/>
           <p:nvPr/>
         </p:nvSpPr>
@@ -31877,7 +31883,7 @@
       </p:sp>
       <p:sp>
         <p:nvSpPr>
-          <p:cNvPr id="1943229574" name="ZoneTexte 504516740"/>
+          <p:cNvPr id="518872138" name="ZoneTexte 504516740"/>
           <p:cNvSpPr txBox="1"/>
           <p:nvPr/>
         </p:nvSpPr>
@@ -31919,7 +31925,7 @@
       </p:sp>
       <p:sp>
         <p:nvSpPr>
-          <p:cNvPr id="348950914" name="ZoneTexte 1"/>
+          <p:cNvPr id="379807974" name="ZoneTexte 1"/>
           <p:cNvSpPr txBox="1"/>
           <p:nvPr/>
         </p:nvSpPr>
@@ -32030,7 +32036,7 @@
       </p:sp>
       <p:sp>
         <p:nvSpPr>
-          <p:cNvPr id="329302094" name="ZoneTexte 2"/>
+          <p:cNvPr id="459593951" name="ZoneTexte 2"/>
           <p:cNvSpPr txBox="1"/>
           <p:nvPr/>
         </p:nvSpPr>
@@ -32114,7 +32120,7 @@
       </p:sp>
       <p:sp>
         <p:nvSpPr>
-          <p:cNvPr id="2001158476" name=""/>
+          <p:cNvPr id="752371547" name=""/>
           <p:cNvSpPr/>
           <p:nvPr/>
         </p:nvSpPr>
@@ -32154,7 +32160,7 @@
       </p:sp>
       <p:sp>
         <p:nvSpPr>
-          <p:cNvPr id="484174042" name="Rectangle : avec coins arrondis en haut 1151560973"/>
+          <p:cNvPr id="900999839" name="Rectangle : avec coins arrondis en haut 1151560973"/>
           <p:cNvSpPr/>
           <p:nvPr/>
         </p:nvSpPr>
@@ -32202,7 +32208,7 @@
       </p:sp>
       <p:sp>
         <p:nvSpPr>
-          <p:cNvPr id="2023007188" name=""/>
+          <p:cNvPr id="125373068" name=""/>
           <p:cNvSpPr/>
           <p:nvPr/>
         </p:nvSpPr>
@@ -32242,7 +32248,7 @@
       </p:sp>
       <p:sp>
         <p:nvSpPr>
-          <p:cNvPr id="1754759045" name="Rectangle : avec coins arrondis en haut 1151560973"/>
+          <p:cNvPr id="158729030" name="Rectangle : avec coins arrondis en haut 1151560973"/>
           <p:cNvSpPr/>
           <p:nvPr/>
         </p:nvSpPr>
@@ -32290,7 +32296,7 @@
       </p:sp>
       <p:sp>
         <p:nvSpPr>
-          <p:cNvPr id="628781658" name=""/>
+          <p:cNvPr id="968439887" name=""/>
           <p:cNvSpPr/>
           <p:nvPr/>
         </p:nvSpPr>
@@ -32330,7 +32336,7 @@
       </p:sp>
       <p:sp>
         <p:nvSpPr>
-          <p:cNvPr id="836626723" name="Rectangle : avec coins arrondis en haut 1151560973"/>
+          <p:cNvPr id="164852458" name="Rectangle : avec coins arrondis en haut 1151560973"/>
           <p:cNvSpPr/>
           <p:nvPr/>
         </p:nvSpPr>
@@ -32378,7 +32384,7 @@
       </p:sp>
       <p:sp>
         <p:nvSpPr>
-          <p:cNvPr id="40391679" name=""/>
+          <p:cNvPr id="1559983273" name=""/>
           <p:cNvSpPr txBox="1"/>
           <p:nvPr/>
         </p:nvSpPr>
@@ -32429,7 +32435,7 @@
       </p:sp>
       <p:sp>
         <p:nvSpPr>
-          <p:cNvPr id="419708160" name=""/>
+          <p:cNvPr id="1367828593" name=""/>
           <p:cNvSpPr txBox="1"/>
           <p:nvPr/>
         </p:nvSpPr>
@@ -32527,7 +32533,7 @@
       </p:sp>
       <p:sp>
         <p:nvSpPr>
-          <p:cNvPr id="1191609752" name=""/>
+          <p:cNvPr id="1218686343" name=""/>
           <p:cNvSpPr/>
           <p:nvPr/>
         </p:nvSpPr>
@@ -32598,7 +32604,7 @@
       </p:sp>
       <p:sp>
         <p:nvSpPr>
-          <p:cNvPr id="1258479643" name="Flèche : pentagone 463861063"/>
+          <p:cNvPr id="1000000456" name="Flèche : pentagone 463861063"/>
           <p:cNvSpPr/>
           <p:nvPr/>
         </p:nvSpPr>
@@ -32643,7 +32649,7 @@
       </p:sp>
       <p:sp>
         <p:nvSpPr>
-          <p:cNvPr id="1526469330" name="Flèche : pentagone 272004907"/>
+          <p:cNvPr id="1872022294" name="Flèche : pentagone 272004907"/>
           <p:cNvSpPr/>
           <p:nvPr/>
         </p:nvSpPr>
@@ -32688,7 +32694,7 @@
       </p:sp>
       <p:sp>
         <p:nvSpPr>
-          <p:cNvPr id="1304395920" name="Flèche : pentagone 28174069"/>
+          <p:cNvPr id="400623106" name="Flèche : pentagone 28174069"/>
           <p:cNvSpPr/>
           <p:nvPr/>
         </p:nvSpPr>

</xml_diff>

<commit_message>
Ajustement des fiches de personnage et preview site
</commit_message>
<xml_diff>
--- a/Fiches de personnage.pptx
+++ b/Fiches de personnage.pptx
@@ -139,7 +139,7 @@
       </p:grpSpPr>
       <p:sp>
         <p:nvSpPr>
-          <p:cNvPr id="1515761318" name="Espace réservé d'en-tête 1"/>
+          <p:cNvPr id="307224571" name="Espace réservé d'en-tête 1"/>
           <p:cNvSpPr>
             <a:spLocks noGrp="1"/>
           </p:cNvSpPr>
@@ -173,7 +173,7 @@
       </p:sp>
       <p:sp>
         <p:nvSpPr>
-          <p:cNvPr id="1348577438" name="Espace réservé pour la date 2"/>
+          <p:cNvPr id="384568661" name="Espace réservé pour la date 2"/>
           <p:cNvSpPr>
             <a:spLocks noGrp="1"/>
           </p:cNvSpPr>
@@ -211,7 +211,7 @@
       </p:sp>
       <p:sp>
         <p:nvSpPr>
-          <p:cNvPr id="1270962817" name="Espace réservé pour l'image de la diapositive 3"/>
+          <p:cNvPr id="217868565" name="Espace réservé pour l'image de la diapositive 3"/>
           <p:cNvSpPr>
             <a:spLocks noChangeAspect="1" noGrp="1" noRot="1"/>
           </p:cNvSpPr>
@@ -247,7 +247,7 @@
       </p:sp>
       <p:sp>
         <p:nvSpPr>
-          <p:cNvPr id="2064074269" name="Remarques Espace réservé 4"/>
+          <p:cNvPr id="1106613541" name="Remarques Espace réservé 4"/>
           <p:cNvSpPr>
             <a:spLocks noGrp="1"/>
           </p:cNvSpPr>
@@ -321,7 +321,7 @@
       </p:sp>
       <p:sp>
         <p:nvSpPr>
-          <p:cNvPr id="1183153066" name="Espace réservé du pied de page 5"/>
+          <p:cNvPr id="952428525" name="Espace réservé du pied de page 5"/>
           <p:cNvSpPr>
             <a:spLocks noGrp="1"/>
           </p:cNvSpPr>
@@ -355,7 +355,7 @@
       </p:sp>
       <p:sp>
         <p:nvSpPr>
-          <p:cNvPr id="2034022386" name="Espace réservé du numéro de diapositive 6"/>
+          <p:cNvPr id="1444669330" name="Espace réservé du numéro de diapositive 6"/>
           <p:cNvSpPr>
             <a:spLocks noGrp="1"/>
           </p:cNvSpPr>
@@ -508,7 +508,7 @@
       </p:grpSpPr>
       <p:sp>
         <p:nvSpPr>
-          <p:cNvPr id="1950129452" name="Espace réservé pour l'image de la diapositive 1"/>
+          <p:cNvPr id="527725713" name="Espace réservé pour l'image de la diapositive 1"/>
           <p:cNvSpPr>
             <a:spLocks noChangeAspect="1" noGrp="1" noRot="1"/>
           </p:cNvSpPr>
@@ -525,7 +525,7 @@
       </p:sp>
       <p:sp>
         <p:nvSpPr>
-          <p:cNvPr id="1434449053" name="Remarques Espace réservé 2"/>
+          <p:cNvPr id="1124721139" name="Remarques Espace réservé 2"/>
           <p:cNvSpPr>
             <a:spLocks noGrp="1"/>
           </p:cNvSpPr>
@@ -550,7 +550,7 @@
       </p:sp>
       <p:sp>
         <p:nvSpPr>
-          <p:cNvPr id="1780571901" name="Espace réservé pour le numéro de diapositive 3"/>
+          <p:cNvPr id="2036584513" name="Espace réservé pour le numéro de diapositive 3"/>
           <p:cNvSpPr>
             <a:spLocks noGrp="1"/>
           </p:cNvSpPr>
@@ -601,7 +601,7 @@
       </p:grpSpPr>
       <p:sp>
         <p:nvSpPr>
-          <p:cNvPr id="1159800262" name="Espace réservé pour l'image de la diapositive 1"/>
+          <p:cNvPr id="1900771020" name="Espace réservé pour l'image de la diapositive 1"/>
           <p:cNvSpPr>
             <a:spLocks noChangeAspect="1" noGrp="1" noRot="1"/>
           </p:cNvSpPr>
@@ -618,7 +618,7 @@
       </p:sp>
       <p:sp>
         <p:nvSpPr>
-          <p:cNvPr id="1410518527" name="Remarques Espace réservé 2"/>
+          <p:cNvPr id="645800930" name="Remarques Espace réservé 2"/>
           <p:cNvSpPr>
             <a:spLocks noGrp="1"/>
           </p:cNvSpPr>
@@ -643,7 +643,7 @@
       </p:sp>
       <p:sp>
         <p:nvSpPr>
-          <p:cNvPr id="955345656" name="Espace réservé pour le numéro de diapositive 3"/>
+          <p:cNvPr id="325759053" name="Espace réservé pour le numéro de diapositive 3"/>
           <p:cNvSpPr>
             <a:spLocks noGrp="1"/>
           </p:cNvSpPr>
@@ -694,7 +694,7 @@
       </p:grpSpPr>
       <p:sp>
         <p:nvSpPr>
-          <p:cNvPr id="1224434012" name="Espace réservé pour l'image de la diapositive 1"/>
+          <p:cNvPr id="706814360" name="Espace réservé pour l'image de la diapositive 1"/>
           <p:cNvSpPr>
             <a:spLocks noChangeAspect="1" noGrp="1" noRot="1"/>
           </p:cNvSpPr>
@@ -711,7 +711,7 @@
       </p:sp>
       <p:sp>
         <p:nvSpPr>
-          <p:cNvPr id="994603532" name="Remarques Espace réservé 2"/>
+          <p:cNvPr id="2039373860" name="Remarques Espace réservé 2"/>
           <p:cNvSpPr>
             <a:spLocks noGrp="1"/>
           </p:cNvSpPr>
@@ -736,7 +736,7 @@
       </p:sp>
       <p:sp>
         <p:nvSpPr>
-          <p:cNvPr id="1928480903" name="Espace réservé pour le numéro de diapositive 3"/>
+          <p:cNvPr id="688191389" name="Espace réservé pour le numéro de diapositive 3"/>
           <p:cNvSpPr>
             <a:spLocks noGrp="1"/>
           </p:cNvSpPr>
@@ -787,7 +787,7 @@
       </p:grpSpPr>
       <p:sp>
         <p:nvSpPr>
-          <p:cNvPr id="1891824993" name="Espace réservé pour l'image de la diapositive 1"/>
+          <p:cNvPr id="147224854" name="Espace réservé pour l'image de la diapositive 1"/>
           <p:cNvSpPr>
             <a:spLocks noChangeAspect="1" noGrp="1" noRot="1"/>
           </p:cNvSpPr>
@@ -804,7 +804,7 @@
       </p:sp>
       <p:sp>
         <p:nvSpPr>
-          <p:cNvPr id="1869465596" name="Remarques Espace réservé 2"/>
+          <p:cNvPr id="455268552" name="Remarques Espace réservé 2"/>
           <p:cNvSpPr>
             <a:spLocks noGrp="1"/>
           </p:cNvSpPr>
@@ -829,7 +829,7 @@
       </p:sp>
       <p:sp>
         <p:nvSpPr>
-          <p:cNvPr id="660112773" name="Espace réservé pour le numéro de diapositive 3"/>
+          <p:cNvPr id="200054325" name="Espace réservé pour le numéro de diapositive 3"/>
           <p:cNvSpPr>
             <a:spLocks noGrp="1"/>
           </p:cNvSpPr>
@@ -880,7 +880,7 @@
       </p:grpSpPr>
       <p:sp>
         <p:nvSpPr>
-          <p:cNvPr id="624339122" name="Espace réservé pour l'image de la diapositive 1"/>
+          <p:cNvPr id="322317679" name="Espace réservé pour l'image de la diapositive 1"/>
           <p:cNvSpPr>
             <a:spLocks noChangeAspect="1" noGrp="1" noRot="1"/>
           </p:cNvSpPr>
@@ -897,7 +897,7 @@
       </p:sp>
       <p:sp>
         <p:nvSpPr>
-          <p:cNvPr id="198617377" name="Remarques Espace réservé 2"/>
+          <p:cNvPr id="2004817509" name="Remarques Espace réservé 2"/>
           <p:cNvSpPr>
             <a:spLocks noGrp="1"/>
           </p:cNvSpPr>
@@ -922,7 +922,7 @@
       </p:sp>
       <p:sp>
         <p:nvSpPr>
-          <p:cNvPr id="1730555999" name="Espace réservé pour le numéro de diapositive 3"/>
+          <p:cNvPr id="1707944167" name="Espace réservé pour le numéro de diapositive 3"/>
           <p:cNvSpPr>
             <a:spLocks noGrp="1"/>
           </p:cNvSpPr>
@@ -973,7 +973,7 @@
       </p:grpSpPr>
       <p:sp>
         <p:nvSpPr>
-          <p:cNvPr id="141241006" name="Espace réservé pour l'image de la diapositive 1"/>
+          <p:cNvPr id="788029295" name="Espace réservé pour l'image de la diapositive 1"/>
           <p:cNvSpPr>
             <a:spLocks noChangeAspect="1" noGrp="1" noRot="1"/>
           </p:cNvSpPr>
@@ -990,7 +990,7 @@
       </p:sp>
       <p:sp>
         <p:nvSpPr>
-          <p:cNvPr id="988596705" name="Remarques Espace réservé 2"/>
+          <p:cNvPr id="1955391172" name="Remarques Espace réservé 2"/>
           <p:cNvSpPr>
             <a:spLocks noGrp="1"/>
           </p:cNvSpPr>
@@ -1015,7 +1015,7 @@
       </p:sp>
       <p:sp>
         <p:nvSpPr>
-          <p:cNvPr id="1210841575" name="Espace réservé pour le numéro de diapositive 3"/>
+          <p:cNvPr id="776518168" name="Espace réservé pour le numéro de diapositive 3"/>
           <p:cNvSpPr>
             <a:spLocks noGrp="1"/>
           </p:cNvSpPr>
@@ -1066,7 +1066,7 @@
       </p:grpSpPr>
       <p:sp>
         <p:nvSpPr>
-          <p:cNvPr id="1843193585" name="Titre 1"/>
+          <p:cNvPr id="568112933" name="Titre 1"/>
           <p:cNvSpPr>
             <a:spLocks noGrp="1"/>
           </p:cNvSpPr>
@@ -1101,7 +1101,7 @@
       </p:sp>
       <p:sp>
         <p:nvSpPr>
-          <p:cNvPr id="1013916826" name="Sous-titre 2"/>
+          <p:cNvPr id="424913495" name="Sous-titre 2"/>
           <p:cNvSpPr>
             <a:spLocks noGrp="1"/>
           </p:cNvSpPr>
@@ -1169,7 +1169,7 @@
       </p:sp>
       <p:sp>
         <p:nvSpPr>
-          <p:cNvPr id="1841382056" name="Espace réservé de la date 3"/>
+          <p:cNvPr id="1932915738" name="Espace réservé de la date 3"/>
           <p:cNvSpPr>
             <a:spLocks noGrp="1"/>
           </p:cNvSpPr>
@@ -1195,7 +1195,7 @@
       </p:sp>
       <p:sp>
         <p:nvSpPr>
-          <p:cNvPr id="1506989335" name="Espace réservé du pied de page 4"/>
+          <p:cNvPr id="14932660" name="Espace réservé du pied de page 4"/>
           <p:cNvSpPr>
             <a:spLocks noGrp="1"/>
           </p:cNvSpPr>
@@ -1217,7 +1217,7 @@
       </p:sp>
       <p:sp>
         <p:nvSpPr>
-          <p:cNvPr id="53683365" name="Espace réservé du numéro de diapositive 5"/>
+          <p:cNvPr id="1158888155" name="Espace réservé du numéro de diapositive 5"/>
           <p:cNvSpPr>
             <a:spLocks noGrp="1"/>
           </p:cNvSpPr>
@@ -1268,7 +1268,7 @@
       </p:grpSpPr>
       <p:sp>
         <p:nvSpPr>
-          <p:cNvPr id="1712552295" name="Titre 1"/>
+          <p:cNvPr id="1877646523" name="Titre 1"/>
           <p:cNvSpPr>
             <a:spLocks noGrp="1"/>
           </p:cNvSpPr>
@@ -1294,7 +1294,7 @@
       </p:sp>
       <p:sp>
         <p:nvSpPr>
-          <p:cNvPr id="418936099" name="Espace réservé du texte vertical 2"/>
+          <p:cNvPr id="399340270" name="Espace réservé du texte vertical 2"/>
           <p:cNvSpPr>
             <a:spLocks noGrp="1"/>
           </p:cNvSpPr>
@@ -1360,7 +1360,7 @@
       </p:sp>
       <p:sp>
         <p:nvSpPr>
-          <p:cNvPr id="1266723730" name="Espace réservé de la date 3"/>
+          <p:cNvPr id="513729784" name="Espace réservé de la date 3"/>
           <p:cNvSpPr>
             <a:spLocks noGrp="1"/>
           </p:cNvSpPr>
@@ -1386,7 +1386,7 @@
       </p:sp>
       <p:sp>
         <p:nvSpPr>
-          <p:cNvPr id="360705495" name="Espace réservé du pied de page 4"/>
+          <p:cNvPr id="1325854908" name="Espace réservé du pied de page 4"/>
           <p:cNvSpPr>
             <a:spLocks noGrp="1"/>
           </p:cNvSpPr>
@@ -1408,7 +1408,7 @@
       </p:sp>
       <p:sp>
         <p:nvSpPr>
-          <p:cNvPr id="1645238075" name="Espace réservé du numéro de diapositive 5"/>
+          <p:cNvPr id="1203376687" name="Espace réservé du numéro de diapositive 5"/>
           <p:cNvSpPr>
             <a:spLocks noGrp="1"/>
           </p:cNvSpPr>
@@ -1459,7 +1459,7 @@
       </p:grpSpPr>
       <p:sp>
         <p:nvSpPr>
-          <p:cNvPr id="1738919629" name="Titre vertical 1"/>
+          <p:cNvPr id="232205924" name="Titre vertical 1"/>
           <p:cNvSpPr>
             <a:spLocks noGrp="1"/>
           </p:cNvSpPr>
@@ -1490,7 +1490,7 @@
       </p:sp>
       <p:sp>
         <p:nvSpPr>
-          <p:cNvPr id="16516507" name="Espace réservé du texte vertical 2"/>
+          <p:cNvPr id="1616876430" name="Espace réservé du texte vertical 2"/>
           <p:cNvSpPr>
             <a:spLocks noGrp="1"/>
           </p:cNvSpPr>
@@ -1561,7 +1561,7 @@
       </p:sp>
       <p:sp>
         <p:nvSpPr>
-          <p:cNvPr id="1562819728" name="Espace réservé de la date 3"/>
+          <p:cNvPr id="264923520" name="Espace réservé de la date 3"/>
           <p:cNvSpPr>
             <a:spLocks noGrp="1"/>
           </p:cNvSpPr>
@@ -1587,7 +1587,7 @@
       </p:sp>
       <p:sp>
         <p:nvSpPr>
-          <p:cNvPr id="1976839807" name="Espace réservé du pied de page 4"/>
+          <p:cNvPr id="1565876742" name="Espace réservé du pied de page 4"/>
           <p:cNvSpPr>
             <a:spLocks noGrp="1"/>
           </p:cNvSpPr>
@@ -1609,7 +1609,7 @@
       </p:sp>
       <p:sp>
         <p:nvSpPr>
-          <p:cNvPr id="344622797" name="Espace réservé du numéro de diapositive 5"/>
+          <p:cNvPr id="152915514" name="Espace réservé du numéro de diapositive 5"/>
           <p:cNvSpPr>
             <a:spLocks noGrp="1"/>
           </p:cNvSpPr>
@@ -1660,7 +1660,7 @@
       </p:grpSpPr>
       <p:sp>
         <p:nvSpPr>
-          <p:cNvPr id="245747040" name="Titre 1"/>
+          <p:cNvPr id="1259698438" name="Titre 1"/>
           <p:cNvSpPr>
             <a:spLocks noGrp="1"/>
           </p:cNvSpPr>
@@ -1686,7 +1686,7 @@
       </p:sp>
       <p:sp>
         <p:nvSpPr>
-          <p:cNvPr id="439014031" name="Espace réservé du contenu 2"/>
+          <p:cNvPr id="909668411" name="Espace réservé du contenu 2"/>
           <p:cNvSpPr>
             <a:spLocks noGrp="1"/>
           </p:cNvSpPr>
@@ -1752,7 +1752,7 @@
       </p:sp>
       <p:sp>
         <p:nvSpPr>
-          <p:cNvPr id="1163756223" name="Espace réservé de la date 3"/>
+          <p:cNvPr id="1105776935" name="Espace réservé de la date 3"/>
           <p:cNvSpPr>
             <a:spLocks noGrp="1"/>
           </p:cNvSpPr>
@@ -1778,7 +1778,7 @@
       </p:sp>
       <p:sp>
         <p:nvSpPr>
-          <p:cNvPr id="485416591" name="Espace réservé du pied de page 4"/>
+          <p:cNvPr id="437451916" name="Espace réservé du pied de page 4"/>
           <p:cNvSpPr>
             <a:spLocks noGrp="1"/>
           </p:cNvSpPr>
@@ -1800,7 +1800,7 @@
       </p:sp>
       <p:sp>
         <p:nvSpPr>
-          <p:cNvPr id="1059657500" name="Espace réservé du numéro de diapositive 5"/>
+          <p:cNvPr id="1866766740" name="Espace réservé du numéro de diapositive 5"/>
           <p:cNvSpPr>
             <a:spLocks noGrp="1"/>
           </p:cNvSpPr>
@@ -1851,7 +1851,7 @@
       </p:grpSpPr>
       <p:sp>
         <p:nvSpPr>
-          <p:cNvPr id="1301699739" name="Titre 1"/>
+          <p:cNvPr id="249838872" name="Titre 1"/>
           <p:cNvSpPr>
             <a:spLocks noGrp="1"/>
           </p:cNvSpPr>
@@ -1886,7 +1886,7 @@
       </p:sp>
       <p:sp>
         <p:nvSpPr>
-          <p:cNvPr id="1043447496" name="Espace réservé du texte 2"/>
+          <p:cNvPr id="225277860" name="Espace réservé du texte 2"/>
           <p:cNvSpPr>
             <a:spLocks noGrp="1"/>
           </p:cNvSpPr>
@@ -2008,7 +2008,7 @@
       </p:sp>
       <p:sp>
         <p:nvSpPr>
-          <p:cNvPr id="1350005619" name="Espace réservé de la date 3"/>
+          <p:cNvPr id="351168860" name="Espace réservé de la date 3"/>
           <p:cNvSpPr>
             <a:spLocks noGrp="1"/>
           </p:cNvSpPr>
@@ -2034,7 +2034,7 @@
       </p:sp>
       <p:sp>
         <p:nvSpPr>
-          <p:cNvPr id="415084961" name="Espace réservé du pied de page 4"/>
+          <p:cNvPr id="1883939087" name="Espace réservé du pied de page 4"/>
           <p:cNvSpPr>
             <a:spLocks noGrp="1"/>
           </p:cNvSpPr>
@@ -2056,7 +2056,7 @@
       </p:sp>
       <p:sp>
         <p:nvSpPr>
-          <p:cNvPr id="145359918" name="Espace réservé du numéro de diapositive 5"/>
+          <p:cNvPr id="296486752" name="Espace réservé du numéro de diapositive 5"/>
           <p:cNvSpPr>
             <a:spLocks noGrp="1"/>
           </p:cNvSpPr>
@@ -2107,7 +2107,7 @@
       </p:grpSpPr>
       <p:sp>
         <p:nvSpPr>
-          <p:cNvPr id="1675420550" name="Titre 1"/>
+          <p:cNvPr id="2002090465" name="Titre 1"/>
           <p:cNvSpPr>
             <a:spLocks noGrp="1"/>
           </p:cNvSpPr>
@@ -2133,7 +2133,7 @@
       </p:sp>
       <p:sp>
         <p:nvSpPr>
-          <p:cNvPr id="2052632131" name="Espace réservé du contenu 2"/>
+          <p:cNvPr id="1094545470" name="Espace réservé du contenu 2"/>
           <p:cNvSpPr>
             <a:spLocks noGrp="1"/>
           </p:cNvSpPr>
@@ -2204,7 +2204,7 @@
       </p:sp>
       <p:sp>
         <p:nvSpPr>
-          <p:cNvPr id="1014881511" name="Espace réservé du contenu 3"/>
+          <p:cNvPr id="554920468" name="Espace réservé du contenu 3"/>
           <p:cNvSpPr>
             <a:spLocks noGrp="1"/>
           </p:cNvSpPr>
@@ -2275,7 +2275,7 @@
       </p:sp>
       <p:sp>
         <p:nvSpPr>
-          <p:cNvPr id="1447265105" name="Espace réservé de la date 4"/>
+          <p:cNvPr id="1766736489" name="Espace réservé de la date 4"/>
           <p:cNvSpPr>
             <a:spLocks noGrp="1"/>
           </p:cNvSpPr>
@@ -2301,7 +2301,7 @@
       </p:sp>
       <p:sp>
         <p:nvSpPr>
-          <p:cNvPr id="1960446048" name="Espace réservé du pied de page 5"/>
+          <p:cNvPr id="958480532" name="Espace réservé du pied de page 5"/>
           <p:cNvSpPr>
             <a:spLocks noGrp="1"/>
           </p:cNvSpPr>
@@ -2323,7 +2323,7 @@
       </p:sp>
       <p:sp>
         <p:nvSpPr>
-          <p:cNvPr id="1856239214" name="Espace réservé du numéro de diapositive 6"/>
+          <p:cNvPr id="1492632577" name="Espace réservé du numéro de diapositive 6"/>
           <p:cNvSpPr>
             <a:spLocks noGrp="1"/>
           </p:cNvSpPr>
@@ -2374,7 +2374,7 @@
       </p:grpSpPr>
       <p:sp>
         <p:nvSpPr>
-          <p:cNvPr id="1826159559" name="Titre 1"/>
+          <p:cNvPr id="1661619366" name="Titre 1"/>
           <p:cNvSpPr>
             <a:spLocks noGrp="1"/>
           </p:cNvSpPr>
@@ -2405,7 +2405,7 @@
       </p:sp>
       <p:sp>
         <p:nvSpPr>
-          <p:cNvPr id="426034449" name="Espace réservé du texte 2"/>
+          <p:cNvPr id="358068196" name="Espace réservé du texte 2"/>
           <p:cNvSpPr>
             <a:spLocks noGrp="1"/>
           </p:cNvSpPr>
@@ -2473,7 +2473,7 @@
       </p:sp>
       <p:sp>
         <p:nvSpPr>
-          <p:cNvPr id="1729320360" name="Espace réservé du contenu 3"/>
+          <p:cNvPr id="2006182969" name="Espace réservé du contenu 3"/>
           <p:cNvSpPr>
             <a:spLocks noGrp="1"/>
           </p:cNvSpPr>
@@ -2544,7 +2544,7 @@
       </p:sp>
       <p:sp>
         <p:nvSpPr>
-          <p:cNvPr id="906485593" name="Espace réservé du texte 4"/>
+          <p:cNvPr id="1007762728" name="Espace réservé du texte 4"/>
           <p:cNvSpPr>
             <a:spLocks noGrp="1"/>
           </p:cNvSpPr>
@@ -2612,7 +2612,7 @@
       </p:sp>
       <p:sp>
         <p:nvSpPr>
-          <p:cNvPr id="141000722" name="Espace réservé du contenu 5"/>
+          <p:cNvPr id="204160326" name="Espace réservé du contenu 5"/>
           <p:cNvSpPr>
             <a:spLocks noGrp="1"/>
           </p:cNvSpPr>
@@ -2683,7 +2683,7 @@
       </p:sp>
       <p:sp>
         <p:nvSpPr>
-          <p:cNvPr id="297160200" name="Espace réservé de la date 6"/>
+          <p:cNvPr id="418523583" name="Espace réservé de la date 6"/>
           <p:cNvSpPr>
             <a:spLocks noGrp="1"/>
           </p:cNvSpPr>
@@ -2709,7 +2709,7 @@
       </p:sp>
       <p:sp>
         <p:nvSpPr>
-          <p:cNvPr id="1109758397" name="Espace réservé du pied de page 7"/>
+          <p:cNvPr id="645677258" name="Espace réservé du pied de page 7"/>
           <p:cNvSpPr>
             <a:spLocks noGrp="1"/>
           </p:cNvSpPr>
@@ -2731,7 +2731,7 @@
       </p:sp>
       <p:sp>
         <p:nvSpPr>
-          <p:cNvPr id="1900134894" name="Espace réservé du numéro de diapositive 8"/>
+          <p:cNvPr id="1561800505" name="Espace réservé du numéro de diapositive 8"/>
           <p:cNvSpPr>
             <a:spLocks noGrp="1"/>
           </p:cNvSpPr>
@@ -2782,7 +2782,7 @@
       </p:grpSpPr>
       <p:sp>
         <p:nvSpPr>
-          <p:cNvPr id="1940141884" name="Titre 1"/>
+          <p:cNvPr id="1142642314" name="Titre 1"/>
           <p:cNvSpPr>
             <a:spLocks noGrp="1"/>
           </p:cNvSpPr>
@@ -2808,7 +2808,7 @@
       </p:sp>
       <p:sp>
         <p:nvSpPr>
-          <p:cNvPr id="1692015330" name="Espace réservé de la date 2"/>
+          <p:cNvPr id="1528534677" name="Espace réservé de la date 2"/>
           <p:cNvSpPr>
             <a:spLocks noGrp="1"/>
           </p:cNvSpPr>
@@ -2834,7 +2834,7 @@
       </p:sp>
       <p:sp>
         <p:nvSpPr>
-          <p:cNvPr id="205380036" name="Espace réservé du pied de page 3"/>
+          <p:cNvPr id="197094135" name="Espace réservé du pied de page 3"/>
           <p:cNvSpPr>
             <a:spLocks noGrp="1"/>
           </p:cNvSpPr>
@@ -2856,7 +2856,7 @@
       </p:sp>
       <p:sp>
         <p:nvSpPr>
-          <p:cNvPr id="950140006" name="Espace réservé du numéro de diapositive 4"/>
+          <p:cNvPr id="1206109690" name="Espace réservé du numéro de diapositive 4"/>
           <p:cNvSpPr>
             <a:spLocks noGrp="1"/>
           </p:cNvSpPr>
@@ -2907,7 +2907,7 @@
       </p:grpSpPr>
       <p:sp>
         <p:nvSpPr>
-          <p:cNvPr id="655591655" name="Espace réservé de la date 1"/>
+          <p:cNvPr id="1630564142" name="Espace réservé de la date 1"/>
           <p:cNvSpPr>
             <a:spLocks noGrp="1"/>
           </p:cNvSpPr>
@@ -2933,7 +2933,7 @@
       </p:sp>
       <p:sp>
         <p:nvSpPr>
-          <p:cNvPr id="249130005" name="Espace réservé du pied de page 2"/>
+          <p:cNvPr id="211839433" name="Espace réservé du pied de page 2"/>
           <p:cNvSpPr>
             <a:spLocks noGrp="1"/>
           </p:cNvSpPr>
@@ -2955,7 +2955,7 @@
       </p:sp>
       <p:sp>
         <p:nvSpPr>
-          <p:cNvPr id="1372975104" name="Espace réservé du numéro de diapositive 3"/>
+          <p:cNvPr id="263869495" name="Espace réservé du numéro de diapositive 3"/>
           <p:cNvSpPr>
             <a:spLocks noGrp="1"/>
           </p:cNvSpPr>
@@ -3006,7 +3006,7 @@
       </p:grpSpPr>
       <p:sp>
         <p:nvSpPr>
-          <p:cNvPr id="1727355599" name="Titre 1"/>
+          <p:cNvPr id="1201331477" name="Titre 1"/>
           <p:cNvSpPr>
             <a:spLocks noGrp="1"/>
           </p:cNvSpPr>
@@ -3041,7 +3041,7 @@
       </p:sp>
       <p:sp>
         <p:nvSpPr>
-          <p:cNvPr id="1992037117" name="Espace réservé du contenu 2"/>
+          <p:cNvPr id="1196811967" name="Espace réservé du contenu 2"/>
           <p:cNvSpPr>
             <a:spLocks noGrp="1"/>
           </p:cNvSpPr>
@@ -3140,7 +3140,7 @@
       </p:sp>
       <p:sp>
         <p:nvSpPr>
-          <p:cNvPr id="1127418375" name="Espace réservé du texte 3"/>
+          <p:cNvPr id="359288057" name="Espace réservé du texte 3"/>
           <p:cNvSpPr>
             <a:spLocks noGrp="1"/>
           </p:cNvSpPr>
@@ -3208,7 +3208,7 @@
       </p:sp>
       <p:sp>
         <p:nvSpPr>
-          <p:cNvPr id="808285411" name="Espace réservé de la date 4"/>
+          <p:cNvPr id="2139961260" name="Espace réservé de la date 4"/>
           <p:cNvSpPr>
             <a:spLocks noGrp="1"/>
           </p:cNvSpPr>
@@ -3234,7 +3234,7 @@
       </p:sp>
       <p:sp>
         <p:nvSpPr>
-          <p:cNvPr id="983780282" name="Espace réservé du pied de page 5"/>
+          <p:cNvPr id="682609590" name="Espace réservé du pied de page 5"/>
           <p:cNvSpPr>
             <a:spLocks noGrp="1"/>
           </p:cNvSpPr>
@@ -3256,7 +3256,7 @@
       </p:sp>
       <p:sp>
         <p:nvSpPr>
-          <p:cNvPr id="790165398" name="Espace réservé du numéro de diapositive 6"/>
+          <p:cNvPr id="480997060" name="Espace réservé du numéro de diapositive 6"/>
           <p:cNvSpPr>
             <a:spLocks noGrp="1"/>
           </p:cNvSpPr>
@@ -3307,7 +3307,7 @@
       </p:grpSpPr>
       <p:sp>
         <p:nvSpPr>
-          <p:cNvPr id="832513243" name="Titre 1"/>
+          <p:cNvPr id="325407828" name="Titre 1"/>
           <p:cNvSpPr>
             <a:spLocks noGrp="1"/>
           </p:cNvSpPr>
@@ -3342,7 +3342,7 @@
       </p:sp>
       <p:sp>
         <p:nvSpPr>
-          <p:cNvPr id="755991100" name="Espace réservé pour une image 2"/>
+          <p:cNvPr id="1570816001" name="Espace réservé pour une image 2"/>
           <p:cNvSpPr>
             <a:spLocks noChangeAspect="1" noGrp="1"/>
           </p:cNvSpPr>
@@ -3410,7 +3410,7 @@
       </p:sp>
       <p:sp>
         <p:nvSpPr>
-          <p:cNvPr id="1135850512" name="Espace réservé du texte 3"/>
+          <p:cNvPr id="1745651133" name="Espace réservé du texte 3"/>
           <p:cNvSpPr>
             <a:spLocks noGrp="1"/>
           </p:cNvSpPr>
@@ -3478,7 +3478,7 @@
       </p:sp>
       <p:sp>
         <p:nvSpPr>
-          <p:cNvPr id="978929930" name="Espace réservé de la date 4"/>
+          <p:cNvPr id="1229654096" name="Espace réservé de la date 4"/>
           <p:cNvSpPr>
             <a:spLocks noGrp="1"/>
           </p:cNvSpPr>
@@ -3504,7 +3504,7 @@
       </p:sp>
       <p:sp>
         <p:nvSpPr>
-          <p:cNvPr id="1798176278" name="Espace réservé du pied de page 5"/>
+          <p:cNvPr id="1523224916" name="Espace réservé du pied de page 5"/>
           <p:cNvSpPr>
             <a:spLocks noGrp="1"/>
           </p:cNvSpPr>
@@ -3526,7 +3526,7 @@
       </p:sp>
       <p:sp>
         <p:nvSpPr>
-          <p:cNvPr id="1036121794" name="Espace réservé du numéro de diapositive 6"/>
+          <p:cNvPr id="745043059" name="Espace réservé du numéro de diapositive 6"/>
           <p:cNvSpPr>
             <a:spLocks noGrp="1"/>
           </p:cNvSpPr>
@@ -3582,7 +3582,7 @@
       </p:grpSpPr>
       <p:sp>
         <p:nvSpPr>
-          <p:cNvPr id="2061194049" name="Espace réservé du titre 1"/>
+          <p:cNvPr id="815786878" name="Espace réservé du titre 1"/>
           <p:cNvSpPr>
             <a:spLocks noGrp="1"/>
           </p:cNvSpPr>
@@ -3618,7 +3618,7 @@
       </p:sp>
       <p:sp>
         <p:nvSpPr>
-          <p:cNvPr id="1597225632" name="Espace réservé du texte 2"/>
+          <p:cNvPr id="673205001" name="Espace réservé du texte 2"/>
           <p:cNvSpPr>
             <a:spLocks noGrp="1"/>
           </p:cNvSpPr>
@@ -3694,7 +3694,7 @@
       </p:sp>
       <p:sp>
         <p:nvSpPr>
-          <p:cNvPr id="860308965" name="Espace réservé de la date 3"/>
+          <p:cNvPr id="387627483" name="Espace réservé de la date 3"/>
           <p:cNvSpPr>
             <a:spLocks noGrp="1"/>
           </p:cNvSpPr>
@@ -3738,7 +3738,7 @@
       </p:sp>
       <p:sp>
         <p:nvSpPr>
-          <p:cNvPr id="1486532779" name="Espace réservé du pied de page 4"/>
+          <p:cNvPr id="615003185" name="Espace réservé du pied de page 4"/>
           <p:cNvSpPr>
             <a:spLocks noGrp="1"/>
           </p:cNvSpPr>
@@ -3778,7 +3778,7 @@
       </p:sp>
       <p:sp>
         <p:nvSpPr>
-          <p:cNvPr id="1915368622" name="Espace réservé du numéro de diapositive 5"/>
+          <p:cNvPr id="1085444227" name="Espace réservé du numéro de diapositive 5"/>
           <p:cNvSpPr>
             <a:spLocks noGrp="1"/>
           </p:cNvSpPr>
@@ -4138,7 +4138,7 @@
       </p:grpSpPr>
       <p:cxnSp>
         <p:nvCxnSpPr>
-          <p:cNvPr id="659764172" name="Connecteur droit 1568760680"/>
+          <p:cNvPr id="1011535862" name="Connecteur droit 1568760680"/>
           <p:cNvCxnSpPr/>
           <p:nvPr/>
         </p:nvCxnSpPr>
@@ -4180,7 +4180,7 @@
       </p:cxnSp>
       <p:sp>
         <p:nvSpPr>
-          <p:cNvPr id="719299099" name="ZoneTexte 1868728971"/>
+          <p:cNvPr id="743910822" name="ZoneTexte 1868728971"/>
           <p:cNvSpPr txBox="1"/>
           <p:nvPr/>
         </p:nvSpPr>
@@ -4220,7 +4220,7 @@
       </p:sp>
       <p:cxnSp>
         <p:nvCxnSpPr>
-          <p:cNvPr id="1926390371" name="Connecteur droit 806540798"/>
+          <p:cNvPr id="1808263830" name="Connecteur droit 806540798"/>
           <p:cNvCxnSpPr/>
           <p:nvPr/>
         </p:nvCxnSpPr>
@@ -4262,7 +4262,7 @@
       </p:cxnSp>
       <p:sp>
         <p:nvSpPr>
-          <p:cNvPr id="1467850438" name="ZoneTexte 406616703"/>
+          <p:cNvPr id="78429684" name="ZoneTexte 406616703"/>
           <p:cNvSpPr txBox="1"/>
           <p:nvPr/>
         </p:nvSpPr>
@@ -4302,13 +4302,13 @@
       </p:sp>
       <p:cxnSp>
         <p:nvCxnSpPr>
-          <p:cNvPr id="1237438328" name="Connecteur droit 858914340"/>
+          <p:cNvPr id="725984429" name="Connecteur droit 858914340"/>
           <p:cNvCxnSpPr/>
           <p:nvPr/>
         </p:nvCxnSpPr>
         <p:spPr bwMode="auto">
           <a:xfrm flipV="1">
-            <a:off x="3252189" y="6540795"/>
+            <a:off x="3252188" y="6630653"/>
             <a:ext cx="3616304" cy="0"/>
           </a:xfrm>
           <a:prstGeom prst="line">
@@ -4344,14 +4344,14 @@
       </p:cxnSp>
       <p:sp>
         <p:nvSpPr>
-          <p:cNvPr id="325129873" name="ZoneTexte 2018177722"/>
+          <p:cNvPr id="655687" name="ZoneTexte 2018177722"/>
           <p:cNvSpPr txBox="1"/>
           <p:nvPr/>
         </p:nvSpPr>
         <p:spPr bwMode="auto">
           <a:xfrm flipH="0" flipV="0">
-            <a:off x="3306144" y="6357733"/>
-            <a:ext cx="3522024" cy="366118"/>
+            <a:off x="3306143" y="6447591"/>
+            <a:ext cx="3522384" cy="366119"/>
           </a:xfrm>
           <a:prstGeom prst="rect">
             <a:avLst/>
@@ -4376,7 +4376,7 @@
                   </a:schemeClr>
                 </a:solidFill>
               </a:rPr>
-              <a:t>Résistances, Stress &amp; Trauma</a:t>
+              <a:t>Résistances</a:t>
             </a:r>
             <a:endParaRPr sz="1800" b="0">
               <a:solidFill>
@@ -4391,13 +4391,13 @@
       </p:sp>
       <p:sp>
         <p:nvSpPr>
-          <p:cNvPr id="512811105" name="ZoneTexte 519900862"/>
+          <p:cNvPr id="1302065422" name="ZoneTexte 519900862"/>
           <p:cNvSpPr txBox="1"/>
           <p:nvPr/>
         </p:nvSpPr>
         <p:spPr bwMode="auto">
           <a:xfrm>
-            <a:off x="3076543" y="6743511"/>
+            <a:off x="3076542" y="6788440"/>
             <a:ext cx="2181487" cy="616449"/>
           </a:xfrm>
           <a:prstGeom prst="rect">
@@ -4653,13 +4653,13 @@
       </p:sp>
       <p:sp>
         <p:nvSpPr>
-          <p:cNvPr id="2098956928" name="Rectangle : avec coins arrondis en haut 838565229"/>
+          <p:cNvPr id="2077066419" name="Rectangle : avec coins arrondis en haut 838565229"/>
           <p:cNvSpPr/>
           <p:nvPr/>
         </p:nvSpPr>
         <p:spPr bwMode="auto">
           <a:xfrm rot="5399976">
-            <a:off x="5203792" y="6863707"/>
+            <a:off x="5203791" y="6908636"/>
             <a:ext cx="520473" cy="400050"/>
           </a:xfrm>
           <a:prstGeom prst="round2SameRect">
@@ -4699,13 +4699,13 @@
       </p:sp>
       <p:sp>
         <p:nvSpPr>
-          <p:cNvPr id="1839666904" name="ZoneTexte 448541368"/>
+          <p:cNvPr id="445672518" name="ZoneTexte 448541368"/>
           <p:cNvSpPr txBox="1"/>
           <p:nvPr/>
         </p:nvSpPr>
         <p:spPr bwMode="auto">
           <a:xfrm>
-            <a:off x="3085691" y="7383949"/>
+            <a:off x="3085690" y="7428877"/>
             <a:ext cx="2170176" cy="643788"/>
           </a:xfrm>
           <a:prstGeom prst="rect">
@@ -4780,13 +4780,13 @@
       </p:sp>
       <p:sp>
         <p:nvSpPr>
-          <p:cNvPr id="1703007119" name="Rectangle : avec coins arrondis en haut 1165584529"/>
+          <p:cNvPr id="79406005" name="Rectangle : avec coins arrondis en haut 1165584529"/>
           <p:cNvSpPr/>
           <p:nvPr/>
         </p:nvSpPr>
         <p:spPr bwMode="auto">
           <a:xfrm rot="5399976">
-            <a:off x="5195512" y="7504146"/>
+            <a:off x="5195511" y="7549075"/>
             <a:ext cx="520473" cy="400050"/>
           </a:xfrm>
           <a:prstGeom prst="round2SameRect">
@@ -4826,13 +4826,13 @@
       </p:sp>
       <p:sp>
         <p:nvSpPr>
-          <p:cNvPr id="902810861" name="Flèche : pentagone 1880610112"/>
+          <p:cNvPr id="626906343" name="Flèche : pentagone 1880610112"/>
           <p:cNvSpPr/>
           <p:nvPr/>
         </p:nvSpPr>
         <p:spPr bwMode="auto">
           <a:xfrm flipH="0" flipV="0">
-            <a:off x="5798788" y="6916887"/>
+            <a:off x="5798787" y="6961816"/>
             <a:ext cx="143169" cy="140445"/>
           </a:xfrm>
           <a:prstGeom prst="homePlate">
@@ -4871,13 +4871,13 @@
       </p:sp>
       <p:sp>
         <p:nvSpPr>
-          <p:cNvPr id="10132194" name="Flèche : pentagone 446859139"/>
+          <p:cNvPr id="54414047" name="Flèche : pentagone 446859139"/>
           <p:cNvSpPr/>
           <p:nvPr/>
         </p:nvSpPr>
         <p:spPr bwMode="auto">
           <a:xfrm flipH="0" flipV="0">
-            <a:off x="5949463" y="6916887"/>
+            <a:off x="5949462" y="6961816"/>
             <a:ext cx="143169" cy="140443"/>
           </a:xfrm>
           <a:prstGeom prst="homePlate">
@@ -4916,13 +4916,13 @@
       </p:sp>
       <p:sp>
         <p:nvSpPr>
-          <p:cNvPr id="167852545" name="Flèche : pentagone 2055848356"/>
+          <p:cNvPr id="535286051" name="Flèche : pentagone 2055848356"/>
           <p:cNvSpPr/>
           <p:nvPr/>
         </p:nvSpPr>
         <p:spPr bwMode="auto">
           <a:xfrm flipH="0" flipV="0">
-            <a:off x="6100142" y="6916887"/>
+            <a:off x="6100141" y="6961816"/>
             <a:ext cx="143169" cy="140443"/>
           </a:xfrm>
           <a:prstGeom prst="homePlate">
@@ -4961,13 +4961,13 @@
       </p:sp>
       <p:sp>
         <p:nvSpPr>
-          <p:cNvPr id="813242163" name="Flèche : pentagone 1980093981"/>
+          <p:cNvPr id="1865730616" name="Flèche : pentagone 1980093981"/>
           <p:cNvSpPr/>
           <p:nvPr/>
         </p:nvSpPr>
         <p:spPr bwMode="auto">
           <a:xfrm flipH="0" flipV="0">
-            <a:off x="6250817" y="6916887"/>
+            <a:off x="6250816" y="6961816"/>
             <a:ext cx="143169" cy="140443"/>
           </a:xfrm>
           <a:prstGeom prst="homePlate">
@@ -5006,13 +5006,13 @@
       </p:sp>
       <p:sp>
         <p:nvSpPr>
-          <p:cNvPr id="425300617" name="Flèche : pentagone 905284374"/>
+          <p:cNvPr id="745685095" name="Flèche : pentagone 905284374"/>
           <p:cNvSpPr/>
           <p:nvPr/>
         </p:nvSpPr>
         <p:spPr bwMode="auto">
           <a:xfrm flipH="0" flipV="0">
-            <a:off x="6401493" y="6916887"/>
+            <a:off x="6401493" y="6961816"/>
             <a:ext cx="143169" cy="140443"/>
           </a:xfrm>
           <a:prstGeom prst="homePlate">
@@ -5051,14 +5051,14 @@
       </p:sp>
       <p:sp>
         <p:nvSpPr>
-          <p:cNvPr id="1220770323" name="ZoneTexte 880464430"/>
+          <p:cNvPr id="1902503090" name="ZoneTexte 880464430"/>
           <p:cNvSpPr txBox="1"/>
           <p:nvPr/>
         </p:nvSpPr>
         <p:spPr bwMode="auto">
           <a:xfrm flipH="0" flipV="0">
-            <a:off x="3170221" y="8017652"/>
-            <a:ext cx="3685708" cy="579478"/>
+            <a:off x="3170220" y="8107510"/>
+            <a:ext cx="3687147" cy="823319"/>
           </a:xfrm>
           <a:prstGeom prst="rect">
             <a:avLst/>
@@ -5116,6 +5116,32 @@
               </a:rPr>
               <a:t> à la résistance concernée. </a:t>
             </a:r>
+            <a:br>
+              <a:rPr lang="fr-FR" sz="800" b="0" i="0" u="none" strike="noStrike" cap="none" spc="0">
+                <a:solidFill>
+                  <a:schemeClr val="tx1">
+                    <a:lumMod val="50000"/>
+                    <a:lumOff val="50000"/>
+                  </a:schemeClr>
+                </a:solidFill>
+                <a:latin typeface="Arial"/>
+                <a:ea typeface="Arial"/>
+                <a:cs typeface="Arial"/>
+              </a:rPr>
+            </a:br>
+            <a:br>
+              <a:rPr lang="fr-FR" sz="800" b="0" i="0" u="none" strike="noStrike" cap="none" spc="0">
+                <a:solidFill>
+                  <a:schemeClr val="tx1">
+                    <a:lumMod val="50000"/>
+                    <a:lumOff val="50000"/>
+                  </a:schemeClr>
+                </a:solidFill>
+                <a:latin typeface="Arial"/>
+                <a:ea typeface="Arial"/>
+                <a:cs typeface="Arial"/>
+              </a:rPr>
+            </a:br>
             <a:r>
               <a:rPr lang="fr-FR" sz="800">
                 <a:solidFill>
@@ -5147,7 +5173,28 @@
                   </a:schemeClr>
                 </a:solidFill>
               </a:rPr>
-              <a:t>, cochez une case de stress. Si vous réussissez à un test de </a:t>
+              <a:t>, cochez une case de stress. </a:t>
+            </a:r>
+            <a:br>
+              <a:rPr lang="fr-FR" sz="800">
+                <a:solidFill>
+                  <a:schemeClr val="tx1">
+                    <a:lumMod val="50000"/>
+                    <a:lumOff val="50000"/>
+                  </a:schemeClr>
+                </a:solidFill>
+              </a:rPr>
+            </a:br>
+            <a:r>
+              <a:rPr lang="fr-FR" sz="800">
+                <a:solidFill>
+                  <a:schemeClr val="tx1">
+                    <a:lumMod val="50000"/>
+                    <a:lumOff val="50000"/>
+                  </a:schemeClr>
+                </a:solidFill>
+              </a:rPr>
+              <a:t>Si vous réussissez à un test de </a:t>
             </a:r>
             <a:r>
               <a:rPr lang="fr-FR" sz="800" b="1">
@@ -5210,7 +5257,7 @@
       </p:sp>
       <p:sp>
         <p:nvSpPr>
-          <p:cNvPr id="1212945650" name="ZoneTexte 1302587497"/>
+          <p:cNvPr id="653181082" name="ZoneTexte 1302587497"/>
           <p:cNvSpPr txBox="1"/>
           <p:nvPr/>
         </p:nvSpPr>
@@ -5508,13 +5555,13 @@
       </p:sp>
       <p:cxnSp>
         <p:nvCxnSpPr>
-          <p:cNvPr id="186275386" name="Connecteur droit 342798987"/>
+          <p:cNvPr id="193026919" name="Connecteur droit 342798987"/>
           <p:cNvCxnSpPr/>
           <p:nvPr/>
         </p:nvCxnSpPr>
         <p:spPr bwMode="auto">
           <a:xfrm flipV="1">
-            <a:off x="3259026" y="8683857"/>
+            <a:off x="3259026" y="9133149"/>
             <a:ext cx="3609464" cy="0"/>
           </a:xfrm>
           <a:prstGeom prst="line">
@@ -5550,13 +5597,13 @@
       </p:cxnSp>
       <p:sp>
         <p:nvSpPr>
-          <p:cNvPr id="2099811014" name="ZoneTexte 966486802"/>
+          <p:cNvPr id="460564154" name="ZoneTexte 966486802"/>
           <p:cNvSpPr txBox="1"/>
           <p:nvPr/>
         </p:nvSpPr>
         <p:spPr bwMode="auto">
           <a:xfrm>
-            <a:off x="3303459" y="8500797"/>
+            <a:off x="3303459" y="8950089"/>
             <a:ext cx="2270304" cy="366118"/>
           </a:xfrm>
           <a:prstGeom prst="rect">
@@ -5590,7 +5637,7 @@
       </p:sp>
       <p:sp>
         <p:nvSpPr>
-          <p:cNvPr id="2031518102" name="Rectangle 38344096"/>
+          <p:cNvPr id="571043282" name="Rectangle 38344096"/>
           <p:cNvSpPr/>
           <p:nvPr/>
         </p:nvSpPr>
@@ -5630,7 +5677,7 @@
       </p:sp>
       <p:sp>
         <p:nvSpPr>
-          <p:cNvPr id="1159720982" name="Rectangle 954364527"/>
+          <p:cNvPr id="1923208512" name="Rectangle 954364527"/>
           <p:cNvSpPr/>
           <p:nvPr/>
         </p:nvSpPr>
@@ -5670,7 +5717,7 @@
       </p:sp>
       <p:sp>
         <p:nvSpPr>
-          <p:cNvPr id="1086455721" name="ZoneTexte 1527388901"/>
+          <p:cNvPr id="1886974297" name="ZoneTexte 1527388901"/>
           <p:cNvSpPr txBox="1"/>
           <p:nvPr/>
         </p:nvSpPr>
@@ -5892,13 +5939,13 @@
       </p:sp>
       <p:sp>
         <p:nvSpPr>
-          <p:cNvPr id="1939947376" name="ZoneTexte 1440859034"/>
+          <p:cNvPr id="1367163426" name="ZoneTexte 1440859034"/>
           <p:cNvSpPr txBox="1"/>
           <p:nvPr/>
         </p:nvSpPr>
         <p:spPr bwMode="auto">
           <a:xfrm>
-            <a:off x="5710630" y="6695110"/>
+            <a:off x="5710629" y="6740039"/>
             <a:ext cx="894969" cy="305158"/>
           </a:xfrm>
           <a:prstGeom prst="rect">
@@ -5943,13 +5990,13 @@
       </p:sp>
       <p:cxnSp>
         <p:nvCxnSpPr>
-          <p:cNvPr id="1742025520" name="Connecteur droit 858914340"/>
+          <p:cNvPr id="385179359" name="Connecteur droit 858914340"/>
           <p:cNvCxnSpPr/>
           <p:nvPr/>
         </p:nvCxnSpPr>
         <p:spPr bwMode="auto">
           <a:xfrm flipH="0" flipV="1">
-            <a:off x="-66688" y="6540795"/>
+            <a:off x="-66687" y="6630653"/>
             <a:ext cx="3068035" cy="0"/>
           </a:xfrm>
           <a:prstGeom prst="line">
@@ -5985,13 +6032,13 @@
       </p:cxnSp>
       <p:sp>
         <p:nvSpPr>
-          <p:cNvPr id="1649277529" name="ZoneTexte 2018177722"/>
+          <p:cNvPr id="396243764" name="ZoneTexte 2018177722"/>
           <p:cNvSpPr txBox="1"/>
           <p:nvPr/>
         </p:nvSpPr>
         <p:spPr bwMode="auto">
           <a:xfrm flipH="0" flipV="0">
-            <a:off x="32193" y="6357735"/>
+            <a:off x="32193" y="6447593"/>
             <a:ext cx="1815876" cy="366117"/>
           </a:xfrm>
           <a:prstGeom prst="rect">
@@ -6032,13 +6079,13 @@
       </p:sp>
       <p:sp>
         <p:nvSpPr>
-          <p:cNvPr id="1959316975" name=""/>
+          <p:cNvPr id="1340444636" name=""/>
           <p:cNvSpPr txBox="1"/>
           <p:nvPr/>
         </p:nvSpPr>
         <p:spPr bwMode="auto">
           <a:xfrm rot="0" flipH="0" flipV="0">
-            <a:off x="11160" y="6674321"/>
+            <a:off x="11160" y="6764179"/>
             <a:ext cx="3007973" cy="3376018"/>
           </a:xfrm>
           <a:prstGeom prst="rect">
@@ -6134,13 +6181,13 @@
       </p:sp>
       <p:cxnSp>
         <p:nvCxnSpPr>
-          <p:cNvPr id="2130853905" name="Connecteur droit 858914340"/>
+          <p:cNvPr id="20696715" name="Connecteur droit 858914340"/>
           <p:cNvCxnSpPr/>
           <p:nvPr/>
         </p:nvCxnSpPr>
         <p:spPr bwMode="auto">
           <a:xfrm flipH="0" flipV="1">
-            <a:off x="4547592" y="4940256"/>
+            <a:off x="4547592" y="4985184"/>
             <a:ext cx="2320902" cy="0"/>
           </a:xfrm>
           <a:prstGeom prst="line">
@@ -6176,13 +6223,13 @@
       </p:cxnSp>
       <p:sp>
         <p:nvSpPr>
-          <p:cNvPr id="1741988812" name="ZoneTexte 2018177722"/>
+          <p:cNvPr id="2144023034" name="ZoneTexte 2018177722"/>
           <p:cNvSpPr txBox="1"/>
           <p:nvPr/>
         </p:nvSpPr>
         <p:spPr bwMode="auto">
           <a:xfrm flipH="0" flipV="0">
-            <a:off x="4601547" y="4757193"/>
+            <a:off x="4601547" y="4802122"/>
             <a:ext cx="1831713" cy="366118"/>
           </a:xfrm>
           <a:prstGeom prst="rect">
@@ -6234,14 +6281,14 @@
       </p:sp>
       <p:sp>
         <p:nvSpPr>
-          <p:cNvPr id="356306380" name=""/>
+          <p:cNvPr id="1410526633" name=""/>
           <p:cNvSpPr txBox="1"/>
           <p:nvPr/>
         </p:nvSpPr>
         <p:spPr bwMode="auto">
           <a:xfrm rot="0" flipH="0" flipV="0">
-            <a:off x="4547592" y="5033169"/>
-            <a:ext cx="2343978" cy="1539598"/>
+            <a:off x="4547592" y="5123027"/>
+            <a:ext cx="2344698" cy="1417680"/>
           </a:xfrm>
           <a:prstGeom prst="rect">
             <a:avLst/>
@@ -6390,90 +6437,6 @@
                 <a:cs typeface="Arial"/>
               </a:rPr>
               <a:t> toujours un échec.</a:t>
-            </a:r>
-            <a:r>
-              <a:rPr lang="fr-FR" sz="800" b="0" i="0" u="none" strike="noStrike" cap="none" spc="0">
-                <a:solidFill>
-                  <a:schemeClr val="tx1">
-                    <a:lumMod val="50000"/>
-                    <a:lumOff val="50000"/>
-                  </a:schemeClr>
-                </a:solidFill>
-                <a:latin typeface="Arial"/>
-                <a:ea typeface="Arial"/>
-                <a:cs typeface="Arial"/>
-              </a:rPr>
-              <a:t> </a:t>
-            </a:r>
-            <a:r>
-              <a:rPr lang="fr-FR" sz="800" b="0" i="0" u="none" strike="noStrike" cap="none" spc="0">
-                <a:solidFill>
-                  <a:schemeClr val="tx1">
-                    <a:lumMod val="50000"/>
-                    <a:lumOff val="50000"/>
-                  </a:schemeClr>
-                </a:solidFill>
-                <a:latin typeface="Arial"/>
-                <a:ea typeface="Arial"/>
-                <a:cs typeface="Arial"/>
-              </a:rPr>
-              <a:t>Un </a:t>
-            </a:r>
-            <a:r>
-              <a:rPr lang="fr-FR" sz="800" b="1" i="0" u="none" strike="noStrike" cap="none" spc="0">
-                <a:solidFill>
-                  <a:schemeClr val="tx1">
-                    <a:lumMod val="50000"/>
-                    <a:lumOff val="50000"/>
-                  </a:schemeClr>
-                </a:solidFill>
-                <a:latin typeface="Arial"/>
-                <a:ea typeface="Arial"/>
-                <a:cs typeface="Arial"/>
-              </a:rPr>
-              <a:t>double</a:t>
-            </a:r>
-            <a:r>
-              <a:rPr lang="fr-FR" sz="800" b="0" i="0" u="none" strike="noStrike" cap="none" spc="0">
-                <a:solidFill>
-                  <a:schemeClr val="tx1">
-                    <a:lumMod val="50000"/>
-                    <a:lumOff val="50000"/>
-                  </a:schemeClr>
-                </a:solidFill>
-                <a:latin typeface="Arial"/>
-                <a:ea typeface="Arial"/>
-                <a:cs typeface="Arial"/>
-              </a:rPr>
-              <a:t> naturel est un </a:t>
-            </a:r>
-            <a:r>
-              <a:rPr lang="fr-FR" sz="800" b="1" i="0" u="none" strike="noStrike" cap="none" spc="0">
-                <a:solidFill>
-                  <a:schemeClr val="tx1">
-                    <a:lumMod val="50000"/>
-                    <a:lumOff val="50000"/>
-                  </a:schemeClr>
-                </a:solidFill>
-                <a:latin typeface="Arial"/>
-                <a:ea typeface="Arial"/>
-                <a:cs typeface="Arial"/>
-              </a:rPr>
-              <a:t>résultat critique</a:t>
-            </a:r>
-            <a:r>
-              <a:rPr lang="fr-FR" sz="800" b="0" i="0" u="none" strike="noStrike" cap="none" spc="0">
-                <a:solidFill>
-                  <a:schemeClr val="tx1">
-                    <a:lumMod val="50000"/>
-                    <a:lumOff val="50000"/>
-                  </a:schemeClr>
-                </a:solidFill>
-                <a:latin typeface="Arial"/>
-                <a:ea typeface="Arial"/>
-                <a:cs typeface="Arial"/>
-              </a:rPr>
-              <a:t>. </a:t>
             </a:r>
             <a:br>
               <a:rPr lang="fr-FR" sz="800" b="0" i="0" u="none" strike="noStrike" cap="none" spc="0">
@@ -6685,7 +6648,7 @@
       </p:sp>
       <p:sp>
         <p:nvSpPr>
-          <p:cNvPr id="818235611" name="ZoneTexte 2021443538"/>
+          <p:cNvPr id="1553755908" name="ZoneTexte 2021443538"/>
           <p:cNvSpPr txBox="1"/>
           <p:nvPr/>
         </p:nvSpPr>
@@ -6769,7 +6732,7 @@
       </p:sp>
       <p:sp>
         <p:nvSpPr>
-          <p:cNvPr id="298451672" name="ZoneTexte 1075280509"/>
+          <p:cNvPr id="1720971382" name="ZoneTexte 1075280509"/>
           <p:cNvSpPr txBox="1"/>
           <p:nvPr/>
         </p:nvSpPr>
@@ -6853,7 +6816,7 @@
       </p:sp>
       <p:sp>
         <p:nvSpPr>
-          <p:cNvPr id="492275633" name="ZoneTexte 824413856"/>
+          <p:cNvPr id="2096058637" name="ZoneTexte 824413856"/>
           <p:cNvSpPr txBox="1"/>
           <p:nvPr/>
         </p:nvSpPr>
@@ -6937,7 +6900,7 @@
       </p:sp>
       <p:sp>
         <p:nvSpPr>
-          <p:cNvPr id="1349244422" name="ZoneTexte 1036656844"/>
+          <p:cNvPr id="911996527" name="ZoneTexte 1036656844"/>
           <p:cNvSpPr txBox="1"/>
           <p:nvPr/>
         </p:nvSpPr>
@@ -7021,7 +6984,7 @@
       </p:sp>
       <p:sp>
         <p:nvSpPr>
-          <p:cNvPr id="2073843041" name="ZoneTexte 226284734"/>
+          <p:cNvPr id="1833577436" name="ZoneTexte 226284734"/>
           <p:cNvSpPr txBox="1"/>
           <p:nvPr/>
         </p:nvSpPr>
@@ -7105,7 +7068,7 @@
       </p:sp>
       <p:sp>
         <p:nvSpPr>
-          <p:cNvPr id="635734666" name="ZoneTexte 162158187"/>
+          <p:cNvPr id="1396047921" name="ZoneTexte 162158187"/>
           <p:cNvSpPr txBox="1"/>
           <p:nvPr/>
         </p:nvSpPr>
@@ -7169,7 +7132,7 @@
       </p:sp>
       <p:sp>
         <p:nvSpPr>
-          <p:cNvPr id="702366423" name="ZoneTexte 1063440096"/>
+          <p:cNvPr id="146040611" name="ZoneTexte 1063440096"/>
           <p:cNvSpPr txBox="1"/>
           <p:nvPr/>
         </p:nvSpPr>
@@ -7253,7 +7216,7 @@
       </p:sp>
       <p:sp>
         <p:nvSpPr>
-          <p:cNvPr id="1382966603" name="ZoneTexte 1564072661"/>
+          <p:cNvPr id="216133220" name="ZoneTexte 1564072661"/>
           <p:cNvSpPr txBox="1"/>
           <p:nvPr/>
         </p:nvSpPr>
@@ -7337,7 +7300,7 @@
       </p:sp>
       <p:sp>
         <p:nvSpPr>
-          <p:cNvPr id="419190701" name="ZoneTexte 2102805411"/>
+          <p:cNvPr id="510122020" name="ZoneTexte 2102805411"/>
           <p:cNvSpPr txBox="1"/>
           <p:nvPr/>
         </p:nvSpPr>
@@ -7421,7 +7384,7 @@
       </p:sp>
       <p:sp>
         <p:nvSpPr>
-          <p:cNvPr id="1060791606" name="ZoneTexte 1094420572"/>
+          <p:cNvPr id="298112756" name="ZoneTexte 1094420572"/>
           <p:cNvSpPr txBox="1"/>
           <p:nvPr/>
         </p:nvSpPr>
@@ -7505,7 +7468,7 @@
       </p:sp>
       <p:sp>
         <p:nvSpPr>
-          <p:cNvPr id="777848412" name="ZoneTexte 1337742717"/>
+          <p:cNvPr id="185828047" name="ZoneTexte 1337742717"/>
           <p:cNvSpPr txBox="1"/>
           <p:nvPr/>
         </p:nvSpPr>
@@ -7569,7 +7532,7 @@
       </p:sp>
       <p:sp>
         <p:nvSpPr>
-          <p:cNvPr id="401142313" name="ZoneTexte 1188730172"/>
+          <p:cNvPr id="1760089565" name="ZoneTexte 1188730172"/>
           <p:cNvSpPr txBox="1"/>
           <p:nvPr/>
         </p:nvSpPr>
@@ -7633,7 +7596,7 @@
       </p:sp>
       <p:sp>
         <p:nvSpPr>
-          <p:cNvPr id="818019235" name="Rectangle : avec coins arrondis en haut 1452601499"/>
+          <p:cNvPr id="754802527" name="Rectangle : avec coins arrondis en haut 1452601499"/>
           <p:cNvSpPr/>
           <p:nvPr/>
         </p:nvSpPr>
@@ -7679,7 +7642,7 @@
       </p:sp>
       <p:sp>
         <p:nvSpPr>
-          <p:cNvPr id="922301880" name="Rectangle : avec coins arrondis en haut 1782110635"/>
+          <p:cNvPr id="1757666287" name="Rectangle : avec coins arrondis en haut 1782110635"/>
           <p:cNvSpPr/>
           <p:nvPr/>
         </p:nvSpPr>
@@ -7725,7 +7688,7 @@
       </p:sp>
       <p:sp>
         <p:nvSpPr>
-          <p:cNvPr id="398138142" name="Rectangle : avec coins arrondis en haut 945118596"/>
+          <p:cNvPr id="2102014763" name="Rectangle : avec coins arrondis en haut 945118596"/>
           <p:cNvSpPr/>
           <p:nvPr/>
         </p:nvSpPr>
@@ -7771,7 +7734,7 @@
       </p:sp>
       <p:sp>
         <p:nvSpPr>
-          <p:cNvPr id="1000524102" name="Rectangle : avec coins arrondis en haut 500951796"/>
+          <p:cNvPr id="855610182" name="Rectangle : avec coins arrondis en haut 500951796"/>
           <p:cNvSpPr/>
           <p:nvPr/>
         </p:nvSpPr>
@@ -7817,7 +7780,7 @@
       </p:sp>
       <p:sp>
         <p:nvSpPr>
-          <p:cNvPr id="296097166" name="Rectangle : avec coins arrondis en haut 203047490"/>
+          <p:cNvPr id="136989505" name="Rectangle : avec coins arrondis en haut 203047490"/>
           <p:cNvSpPr/>
           <p:nvPr/>
         </p:nvSpPr>
@@ -7863,7 +7826,7 @@
       </p:sp>
       <p:sp>
         <p:nvSpPr>
-          <p:cNvPr id="1439991712" name="Rectangle : avec coins arrondis en haut 818083012"/>
+          <p:cNvPr id="1112041954" name="Rectangle : avec coins arrondis en haut 818083012"/>
           <p:cNvSpPr/>
           <p:nvPr/>
         </p:nvSpPr>
@@ -7909,7 +7872,7 @@
       </p:sp>
       <p:sp>
         <p:nvSpPr>
-          <p:cNvPr id="103752486" name="Rectangle : avec coins arrondis en haut 310539005"/>
+          <p:cNvPr id="53887571" name="Rectangle : avec coins arrondis en haut 310539005"/>
           <p:cNvSpPr/>
           <p:nvPr/>
         </p:nvSpPr>
@@ -7955,7 +7918,7 @@
       </p:sp>
       <p:sp>
         <p:nvSpPr>
-          <p:cNvPr id="1117179137" name="Rectangle : avec coins arrondis en haut 844307487"/>
+          <p:cNvPr id="1551010333" name="Rectangle : avec coins arrondis en haut 844307487"/>
           <p:cNvSpPr/>
           <p:nvPr/>
         </p:nvSpPr>
@@ -8001,7 +7964,7 @@
       </p:sp>
       <p:sp>
         <p:nvSpPr>
-          <p:cNvPr id="158994311" name="Rectangle : avec coins arrondis en haut 1616510051"/>
+          <p:cNvPr id="534466157" name="Rectangle : avec coins arrondis en haut 1616510051"/>
           <p:cNvSpPr/>
           <p:nvPr/>
         </p:nvSpPr>
@@ -8047,7 +8010,7 @@
       </p:sp>
       <p:sp>
         <p:nvSpPr>
-          <p:cNvPr id="2111738458" name="Rectangle : avec coins arrondis en haut 1451691637"/>
+          <p:cNvPr id="286711538" name="Rectangle : avec coins arrondis en haut 1451691637"/>
           <p:cNvSpPr/>
           <p:nvPr/>
         </p:nvSpPr>
@@ -8093,7 +8056,7 @@
       </p:sp>
       <p:sp>
         <p:nvSpPr>
-          <p:cNvPr id="224815873" name="Rectangle : avec coins arrondis en haut 260383743"/>
+          <p:cNvPr id="1078155515" name="Rectangle : avec coins arrondis en haut 260383743"/>
           <p:cNvSpPr/>
           <p:nvPr/>
         </p:nvSpPr>
@@ -8139,7 +8102,7 @@
       </p:sp>
       <p:sp>
         <p:nvSpPr>
-          <p:cNvPr id="760500082" name="Rectangle : avec coins arrondis en haut 1280344391"/>
+          <p:cNvPr id="1250594812" name="Rectangle : avec coins arrondis en haut 1280344391"/>
           <p:cNvSpPr/>
           <p:nvPr/>
         </p:nvSpPr>
@@ -8185,14 +8148,14 @@
       </p:sp>
       <p:sp>
         <p:nvSpPr>
-          <p:cNvPr id="1269437730" name=""/>
+          <p:cNvPr id="1475985731" name=""/>
           <p:cNvSpPr txBox="1"/>
           <p:nvPr/>
         </p:nvSpPr>
         <p:spPr bwMode="auto">
           <a:xfrm rot="0" flipH="0" flipV="0">
-            <a:off x="3207796" y="8821297"/>
-            <a:ext cx="3727653" cy="548998"/>
+            <a:off x="3207795" y="9270589"/>
+            <a:ext cx="3741332" cy="548999"/>
           </a:xfrm>
           <a:prstGeom prst="rect">
             <a:avLst/>
@@ -8309,331 +8272,7 @@
       </p:sp>
       <p:sp>
         <p:nvSpPr>
-          <p:cNvPr id="58774705" name="ZoneTexte 1440859034"/>
-          <p:cNvSpPr txBox="1"/>
-          <p:nvPr/>
-        </p:nvSpPr>
-        <p:spPr bwMode="auto">
-          <a:xfrm>
-            <a:off x="3555765" y="9620489"/>
-            <a:ext cx="1115026" cy="274678"/>
-          </a:xfrm>
-          <a:prstGeom prst="rect">
-            <a:avLst/>
-          </a:prstGeom>
-          <a:noFill/>
-        </p:spPr>
-        <p:txBody>
-          <a:bodyPr vertOverflow="overflow" horzOverflow="overflow" vert="horz" wrap="none" lIns="91440" tIns="45720" rIns="91440" bIns="45720" numCol="1" spcCol="0" rtlCol="0" fromWordArt="0" anchor="t" anchorCtr="0" forceAA="0" compatLnSpc="0">
-            <a:spAutoFit/>
-          </a:bodyPr>
-          <a:lstStyle/>
-          <a:p>
-            <a:pPr>
-              <a:defRPr/>
-            </a:pPr>
-            <a:r>
-              <a:rPr lang="fr-FR" sz="1200" b="1" i="0" u="none" strike="noStrike" cap="none" spc="0">
-                <a:solidFill>
-                  <a:schemeClr val="bg1">
-                    <a:lumMod val="65000"/>
-                  </a:schemeClr>
-                </a:solidFill>
-                <a:latin typeface="Arial"/>
-                <a:ea typeface="Arial"/>
-                <a:cs typeface="Arial"/>
-              </a:rPr>
-              <a:t>ÉCONOMIES</a:t>
-            </a:r>
-            <a:endParaRPr/>
-          </a:p>
-        </p:txBody>
-      </p:sp>
-      <p:sp>
-        <p:nvSpPr>
-          <p:cNvPr id="730549030" name="ZoneTexte 1440859034"/>
-          <p:cNvSpPr txBox="1"/>
-          <p:nvPr/>
-        </p:nvSpPr>
-        <p:spPr bwMode="auto">
-          <a:xfrm>
-            <a:off x="5572019" y="9620490"/>
-            <a:ext cx="784780" cy="274678"/>
-          </a:xfrm>
-          <a:prstGeom prst="rect">
-            <a:avLst/>
-          </a:prstGeom>
-          <a:noFill/>
-        </p:spPr>
-        <p:txBody>
-          <a:bodyPr vertOverflow="overflow" horzOverflow="overflow" vert="horz" wrap="none" lIns="91440" tIns="45720" rIns="91440" bIns="45720" numCol="1" spcCol="0" rtlCol="0" fromWordArt="0" anchor="t" anchorCtr="0" forceAA="0" compatLnSpc="0">
-            <a:spAutoFit/>
-          </a:bodyPr>
-          <a:lstStyle/>
-          <a:p>
-            <a:pPr>
-              <a:defRPr/>
-            </a:pPr>
-            <a:r>
-              <a:rPr sz="1200" b="1">
-                <a:solidFill>
-                  <a:schemeClr val="bg1">
-                    <a:lumMod val="65000"/>
-                  </a:schemeClr>
-                </a:solidFill>
-              </a:rPr>
-              <a:t>DETTES</a:t>
-            </a:r>
-            <a:endParaRPr/>
-          </a:p>
-        </p:txBody>
-      </p:sp>
-      <p:cxnSp>
-        <p:nvCxnSpPr>
-          <p:cNvPr id="271994648" name=""/>
-          <p:cNvCxnSpPr/>
-          <p:nvPr/>
-        </p:nvCxnSpPr>
-        <p:spPr bwMode="auto">
-          <a:xfrm flipH="0" flipV="1">
-            <a:off x="5062576" y="9338886"/>
-            <a:ext cx="0" cy="530163"/>
-          </a:xfrm>
-          <a:prstGeom prst="line">
-            <a:avLst/>
-          </a:prstGeom>
-          <a:ln w="12700" cap="flat" cmpd="sng" algn="ctr">
-            <a:solidFill>
-              <a:srgbClr val="A6A6A6"/>
-            </a:solidFill>
-            <a:prstDash val="dash"/>
-            <a:miter lim="800000"/>
-          </a:ln>
-        </p:spPr>
-        <p:style>
-          <a:lnRef idx="1">
-            <a:schemeClr val="accent1">
-              <a:shade val="50000"/>
-            </a:schemeClr>
-          </a:lnRef>
-          <a:fillRef idx="0">
-            <a:schemeClr val="accent1"/>
-          </a:fillRef>
-          <a:effectRef idx="0">
-            <a:schemeClr val="accent1"/>
-          </a:effectRef>
-          <a:fontRef idx="minor">
-            <a:schemeClr val="tx1"/>
-          </a:fontRef>
-        </p:style>
-      </p:cxnSp>
-      <p:sp>
-        <p:nvSpPr>
-          <p:cNvPr id="1873067258" name=""/>
-          <p:cNvSpPr txBox="1"/>
-          <p:nvPr/>
-        </p:nvSpPr>
-        <p:spPr bwMode="auto">
-          <a:xfrm rot="0" flipH="0" flipV="0">
-            <a:off x="3426223" y="9186382"/>
-            <a:ext cx="1546056" cy="385902"/>
-          </a:xfrm>
-          <a:prstGeom prst="rect">
-            <a:avLst/>
-          </a:prstGeom>
-          <a:noFill/>
-        </p:spPr>
-        <p:txBody>
-          <a:bodyPr vertOverflow="overflow" horzOverflow="overflow" vert="horz" wrap="square" lIns="91440" tIns="45720" rIns="91440" bIns="45720" numCol="1" spcCol="0" rtlCol="0" fromWordArt="0" anchor="t" anchorCtr="0" forceAA="0" upright="0" compatLnSpc="0">
-            <a:spAutoFit/>
-          </a:bodyPr>
-          <a:p>
-            <a:pPr>
-              <a:defRPr/>
-            </a:pPr>
-            <a:r>
-              <a:rPr sz="1800" b="1">
-                <a:solidFill>
-                  <a:schemeClr val="bg1">
-                    <a:lumMod val="65000"/>
-                  </a:schemeClr>
-                </a:solidFill>
-                <a:latin typeface="Arial"/>
-                <a:ea typeface="Arial"/>
-                <a:cs typeface="Arial"/>
-              </a:rPr>
-              <a:t>▢</a:t>
-            </a:r>
-            <a:r>
-              <a:rPr lang="fr-FR" sz="1800" b="1" i="0" u="none" strike="noStrike" cap="none" spc="0">
-                <a:solidFill>
-                  <a:schemeClr val="bg1">
-                    <a:lumMod val="65000"/>
-                  </a:schemeClr>
-                </a:solidFill>
-                <a:latin typeface="Arial"/>
-                <a:ea typeface="Arial"/>
-                <a:cs typeface="Arial"/>
-              </a:rPr>
-              <a:t>▢</a:t>
-            </a:r>
-            <a:r>
-              <a:rPr lang="fr-FR" sz="1800" b="1" i="0" u="none" strike="noStrike" cap="none" spc="0">
-                <a:solidFill>
-                  <a:schemeClr val="bg1">
-                    <a:lumMod val="65000"/>
-                  </a:schemeClr>
-                </a:solidFill>
-                <a:latin typeface="Arial"/>
-                <a:ea typeface="Arial"/>
-                <a:cs typeface="Arial"/>
-              </a:rPr>
-              <a:t>▢</a:t>
-            </a:r>
-            <a:r>
-              <a:rPr lang="fr-FR" sz="1800" b="1" i="0" u="none" strike="noStrike" cap="none" spc="0">
-                <a:solidFill>
-                  <a:schemeClr val="bg1">
-                    <a:lumMod val="65000"/>
-                  </a:schemeClr>
-                </a:solidFill>
-                <a:latin typeface="Arial"/>
-                <a:ea typeface="Arial"/>
-                <a:cs typeface="Arial"/>
-              </a:rPr>
-              <a:t>▢</a:t>
-            </a:r>
-            <a:r>
-              <a:rPr lang="fr-FR" sz="1800" b="1" i="0" u="none" strike="noStrike" cap="none" spc="0">
-                <a:solidFill>
-                  <a:schemeClr val="bg1">
-                    <a:lumMod val="65000"/>
-                  </a:schemeClr>
-                </a:solidFill>
-                <a:latin typeface="Arial"/>
-                <a:ea typeface="Arial"/>
-                <a:cs typeface="Arial"/>
-              </a:rPr>
-              <a:t>▢ </a:t>
-            </a:r>
-            <a:r>
-              <a:rPr lang="fr-FR" sz="1800" b="1" i="0" u="none" strike="noStrike" cap="none" spc="0">
-                <a:solidFill>
-                  <a:schemeClr val="bg1">
-                    <a:lumMod val="65000"/>
-                  </a:schemeClr>
-                </a:solidFill>
-                <a:latin typeface="Arial"/>
-                <a:ea typeface="Arial"/>
-                <a:cs typeface="Arial"/>
-              </a:rPr>
-              <a:t>▢</a:t>
-            </a:r>
-            <a:r>
-              <a:rPr lang="fr-FR" sz="1800" b="1" i="0" u="none" strike="noStrike" cap="none" spc="0">
-                <a:solidFill>
-                  <a:schemeClr val="bg1">
-                    <a:lumMod val="65000"/>
-                  </a:schemeClr>
-                </a:solidFill>
-                <a:latin typeface="Arial"/>
-                <a:ea typeface="Arial"/>
-                <a:cs typeface="Arial"/>
-              </a:rPr>
-              <a:t>▢</a:t>
-            </a:r>
-            <a:r>
-              <a:rPr lang="fr-FR" sz="1800" b="1" i="0" u="none" strike="noStrike" cap="none" spc="0">
-                <a:solidFill>
-                  <a:schemeClr val="bg1">
-                    <a:lumMod val="65000"/>
-                  </a:schemeClr>
-                </a:solidFill>
-                <a:latin typeface="Arial"/>
-                <a:ea typeface="Arial"/>
-                <a:cs typeface="Arial"/>
-              </a:rPr>
-              <a:t>▢</a:t>
-            </a:r>
-            <a:r>
-              <a:rPr lang="fr-FR" sz="1800" b="1" i="0" u="none" strike="noStrike" cap="none" spc="0">
-                <a:solidFill>
-                  <a:schemeClr val="bg1">
-                    <a:lumMod val="65000"/>
-                  </a:schemeClr>
-                </a:solidFill>
-                <a:latin typeface="Arial"/>
-                <a:ea typeface="Arial"/>
-                <a:cs typeface="Arial"/>
-              </a:rPr>
-              <a:t>▢</a:t>
-            </a:r>
-            <a:r>
-              <a:rPr lang="fr-FR" sz="1800" b="1" i="0" u="none" strike="noStrike" cap="none" spc="0">
-                <a:solidFill>
-                  <a:schemeClr val="bg1">
-                    <a:lumMod val="65000"/>
-                  </a:schemeClr>
-                </a:solidFill>
-                <a:latin typeface="Arial"/>
-                <a:ea typeface="Arial"/>
-                <a:cs typeface="Arial"/>
-              </a:rPr>
-              <a:t>▢</a:t>
-            </a:r>
-            <a:endParaRPr sz="2200" b="1">
-              <a:solidFill>
-                <a:schemeClr val="bg1">
-                  <a:lumMod val="65000"/>
-                </a:schemeClr>
-              </a:solidFill>
-            </a:endParaRPr>
-          </a:p>
-        </p:txBody>
-      </p:sp>
-      <p:sp>
-        <p:nvSpPr>
-          <p:cNvPr id="2027161406" name="Rectangle 954364527"/>
-          <p:cNvSpPr/>
-          <p:nvPr/>
-        </p:nvSpPr>
-        <p:spPr bwMode="auto">
-          <a:xfrm flipH="0" flipV="0">
-            <a:off x="6664874" y="8821297"/>
-            <a:ext cx="162576" cy="1047754"/>
-          </a:xfrm>
-          <a:prstGeom prst="rect">
-            <a:avLst/>
-          </a:prstGeom>
-          <a:solidFill>
-            <a:schemeClr val="bg1"/>
-          </a:solidFill>
-          <a:ln w="12700" cap="flat" cmpd="sng" algn="ctr">
-            <a:noFill/>
-            <a:prstDash val="solid"/>
-            <a:miter lim="800000"/>
-          </a:ln>
-        </p:spPr>
-        <p:style>
-          <a:lnRef idx="2">
-            <a:schemeClr val="accent1">
-              <a:shade val="50000"/>
-            </a:schemeClr>
-          </a:lnRef>
-          <a:fillRef idx="1">
-            <a:schemeClr val="accent1"/>
-          </a:fillRef>
-          <a:effectRef idx="0">
-            <a:schemeClr val="accent1"/>
-          </a:effectRef>
-          <a:fontRef idx="minor">
-            <a:schemeClr val="lt1"/>
-          </a:fontRef>
-        </p:style>
-      </p:sp>
-      <p:sp>
-        <p:nvSpPr>
-          <p:cNvPr id="1134888723" name="ZoneTexte 1527388901"/>
+          <p:cNvPr id="1618229276" name="ZoneTexte 1527388901"/>
           <p:cNvSpPr txBox="1"/>
           <p:nvPr/>
         </p:nvSpPr>
@@ -8793,7 +8432,7 @@
       </p:sp>
       <p:sp>
         <p:nvSpPr>
-          <p:cNvPr id="778363155" name="Rectangle 38344096"/>
+          <p:cNvPr id="1410954801" name="Rectangle 38344096"/>
           <p:cNvSpPr/>
           <p:nvPr/>
         </p:nvSpPr>
@@ -8833,7 +8472,7 @@
       </p:sp>
       <p:sp>
         <p:nvSpPr>
-          <p:cNvPr id="1856197595" name=""/>
+          <p:cNvPr id="1761491966" name=""/>
           <p:cNvSpPr/>
           <p:nvPr/>
         </p:nvSpPr>
@@ -8904,13 +8543,13 @@
       </p:sp>
       <p:sp>
         <p:nvSpPr>
-          <p:cNvPr id="313615499" name="Flèche : pentagone 2055848356"/>
+          <p:cNvPr id="1546415770" name="Flèche : pentagone 2055848356"/>
           <p:cNvSpPr/>
           <p:nvPr/>
         </p:nvSpPr>
         <p:spPr bwMode="auto">
           <a:xfrm flipH="0" flipV="0">
-            <a:off x="5949463" y="7085077"/>
+            <a:off x="5949462" y="7130005"/>
             <a:ext cx="143169" cy="140443"/>
           </a:xfrm>
           <a:prstGeom prst="homePlate">
@@ -8949,13 +8588,13 @@
       </p:sp>
       <p:sp>
         <p:nvSpPr>
-          <p:cNvPr id="28686391" name="Flèche : pentagone 1980093981"/>
+          <p:cNvPr id="532725278" name="Flèche : pentagone 1980093981"/>
           <p:cNvSpPr/>
           <p:nvPr/>
         </p:nvSpPr>
         <p:spPr bwMode="auto">
           <a:xfrm flipH="0" flipV="0">
-            <a:off x="6100138" y="7085077"/>
+            <a:off x="6100137" y="7130005"/>
             <a:ext cx="143169" cy="140443"/>
           </a:xfrm>
           <a:prstGeom prst="homePlate">
@@ -8994,13 +8633,13 @@
       </p:sp>
       <p:sp>
         <p:nvSpPr>
-          <p:cNvPr id="1631435291" name="Flèche : pentagone 905284374"/>
+          <p:cNvPr id="1518242702" name="Flèche : pentagone 905284374"/>
           <p:cNvSpPr/>
           <p:nvPr/>
         </p:nvSpPr>
         <p:spPr bwMode="auto">
           <a:xfrm flipH="0" flipV="0">
-            <a:off x="6250817" y="7085077"/>
+            <a:off x="6250816" y="7130005"/>
             <a:ext cx="143169" cy="140443"/>
           </a:xfrm>
           <a:prstGeom prst="homePlate">
@@ -9039,13 +8678,13 @@
       </p:sp>
       <p:sp>
         <p:nvSpPr>
-          <p:cNvPr id="1841455217" name="ZoneTexte 1440859034"/>
+          <p:cNvPr id="2113391228" name="ZoneTexte 1440859034"/>
           <p:cNvSpPr txBox="1"/>
           <p:nvPr/>
         </p:nvSpPr>
         <p:spPr bwMode="auto">
           <a:xfrm>
-            <a:off x="5708701" y="7138872"/>
+            <a:off x="5708700" y="7183801"/>
             <a:ext cx="953910" cy="305158"/>
           </a:xfrm>
           <a:prstGeom prst="rect">
@@ -9078,13 +8717,13 @@
       </p:sp>
       <p:sp>
         <p:nvSpPr>
-          <p:cNvPr id="493919413" name="Flèche : pentagone 1880610112"/>
+          <p:cNvPr id="457022198" name="Flèche : pentagone 1880610112"/>
           <p:cNvSpPr/>
           <p:nvPr/>
         </p:nvSpPr>
         <p:spPr bwMode="auto">
           <a:xfrm flipH="0" flipV="0">
-            <a:off x="5798788" y="7549778"/>
+            <a:off x="5798787" y="7594707"/>
             <a:ext cx="143168" cy="140445"/>
           </a:xfrm>
           <a:prstGeom prst="homePlate">
@@ -9123,13 +8762,13 @@
       </p:sp>
       <p:sp>
         <p:nvSpPr>
-          <p:cNvPr id="926318724" name="Flèche : pentagone 446859139"/>
+          <p:cNvPr id="1718118954" name="Flèche : pentagone 446859139"/>
           <p:cNvSpPr/>
           <p:nvPr/>
         </p:nvSpPr>
         <p:spPr bwMode="auto">
           <a:xfrm flipH="0" flipV="0">
-            <a:off x="5949463" y="7549778"/>
+            <a:off x="5949462" y="7594707"/>
             <a:ext cx="143168" cy="140442"/>
           </a:xfrm>
           <a:prstGeom prst="homePlate">
@@ -9168,13 +8807,13 @@
       </p:sp>
       <p:sp>
         <p:nvSpPr>
-          <p:cNvPr id="957390982" name="Flèche : pentagone 2055848356"/>
+          <p:cNvPr id="75247757" name="Flèche : pentagone 2055848356"/>
           <p:cNvSpPr/>
           <p:nvPr/>
         </p:nvSpPr>
         <p:spPr bwMode="auto">
           <a:xfrm flipH="0" flipV="0">
-            <a:off x="6100142" y="7549778"/>
+            <a:off x="6100141" y="7594707"/>
             <a:ext cx="143168" cy="140442"/>
           </a:xfrm>
           <a:prstGeom prst="homePlate">
@@ -9213,13 +8852,13 @@
       </p:sp>
       <p:sp>
         <p:nvSpPr>
-          <p:cNvPr id="645976634" name="Flèche : pentagone 1980093981"/>
+          <p:cNvPr id="757857986" name="Flèche : pentagone 1980093981"/>
           <p:cNvSpPr/>
           <p:nvPr/>
         </p:nvSpPr>
         <p:spPr bwMode="auto">
           <a:xfrm flipH="0" flipV="0">
-            <a:off x="6250817" y="7549778"/>
+            <a:off x="6250816" y="7594707"/>
             <a:ext cx="143168" cy="140442"/>
           </a:xfrm>
           <a:prstGeom prst="homePlate">
@@ -9258,13 +8897,13 @@
       </p:sp>
       <p:sp>
         <p:nvSpPr>
-          <p:cNvPr id="1996518039" name="Flèche : pentagone 905284374"/>
+          <p:cNvPr id="886986814" name="Flèche : pentagone 905284374"/>
           <p:cNvSpPr/>
           <p:nvPr/>
         </p:nvSpPr>
         <p:spPr bwMode="auto">
           <a:xfrm flipH="0" flipV="0">
-            <a:off x="6401493" y="7549778"/>
+            <a:off x="6401493" y="7594707"/>
             <a:ext cx="143168" cy="140442"/>
           </a:xfrm>
           <a:prstGeom prst="homePlate">
@@ -9303,13 +8942,13 @@
       </p:sp>
       <p:sp>
         <p:nvSpPr>
-          <p:cNvPr id="1466860256" name="ZoneTexte 1440859034"/>
+          <p:cNvPr id="1370522460" name="ZoneTexte 1440859034"/>
           <p:cNvSpPr txBox="1"/>
           <p:nvPr/>
         </p:nvSpPr>
         <p:spPr bwMode="auto">
           <a:xfrm>
-            <a:off x="5706994" y="7334806"/>
+            <a:off x="5706993" y="7379735"/>
             <a:ext cx="894969" cy="305158"/>
           </a:xfrm>
           <a:prstGeom prst="rect">
@@ -9342,13 +8981,13 @@
       </p:sp>
       <p:sp>
         <p:nvSpPr>
-          <p:cNvPr id="1154417666" name="Flèche : pentagone 2055848356"/>
+          <p:cNvPr id="922889750" name="Flèche : pentagone 2055848356"/>
           <p:cNvSpPr/>
           <p:nvPr/>
         </p:nvSpPr>
         <p:spPr bwMode="auto">
           <a:xfrm flipH="0" flipV="0">
-            <a:off x="5949463" y="7717968"/>
+            <a:off x="5949462" y="7762897"/>
             <a:ext cx="143168" cy="140442"/>
           </a:xfrm>
           <a:prstGeom prst="homePlate">
@@ -9387,13 +9026,13 @@
       </p:sp>
       <p:sp>
         <p:nvSpPr>
-          <p:cNvPr id="1049054438" name="Flèche : pentagone 1980093981"/>
+          <p:cNvPr id="468910065" name="Flèche : pentagone 1980093981"/>
           <p:cNvSpPr/>
           <p:nvPr/>
         </p:nvSpPr>
         <p:spPr bwMode="auto">
           <a:xfrm flipH="0" flipV="0">
-            <a:off x="6100138" y="7717968"/>
+            <a:off x="6100137" y="7762897"/>
             <a:ext cx="143168" cy="140442"/>
           </a:xfrm>
           <a:prstGeom prst="homePlate">
@@ -9432,13 +9071,13 @@
       </p:sp>
       <p:sp>
         <p:nvSpPr>
-          <p:cNvPr id="1640577591" name="Flèche : pentagone 905284374"/>
+          <p:cNvPr id="441293241" name="Flèche : pentagone 905284374"/>
           <p:cNvSpPr/>
           <p:nvPr/>
         </p:nvSpPr>
         <p:spPr bwMode="auto">
           <a:xfrm flipH="0" flipV="0">
-            <a:off x="6250817" y="7717968"/>
+            <a:off x="6250816" y="7762897"/>
             <a:ext cx="143168" cy="140442"/>
           </a:xfrm>
           <a:prstGeom prst="homePlate">
@@ -9477,13 +9116,13 @@
       </p:sp>
       <p:sp>
         <p:nvSpPr>
-          <p:cNvPr id="1235941007" name="ZoneTexte 1440859034"/>
+          <p:cNvPr id="270225134" name="ZoneTexte 1440859034"/>
           <p:cNvSpPr txBox="1"/>
           <p:nvPr/>
         </p:nvSpPr>
         <p:spPr bwMode="auto">
           <a:xfrm>
-            <a:off x="5708881" y="7777053"/>
+            <a:off x="5708880" y="7821982"/>
             <a:ext cx="953910" cy="305158"/>
           </a:xfrm>
           <a:prstGeom prst="rect">
@@ -9511,498 +9150,6 @@
               <a:t>TRAUMA</a:t>
             </a:r>
             <a:endParaRPr sz="1600"/>
-          </a:p>
-        </p:txBody>
-      </p:sp>
-      <p:sp>
-        <p:nvSpPr>
-          <p:cNvPr id="40452898" name=""/>
-          <p:cNvSpPr txBox="1"/>
-          <p:nvPr/>
-        </p:nvSpPr>
-        <p:spPr bwMode="auto">
-          <a:xfrm rot="0" flipH="0" flipV="0">
-            <a:off x="3426223" y="9345173"/>
-            <a:ext cx="1546416" cy="385902"/>
-          </a:xfrm>
-          <a:prstGeom prst="rect">
-            <a:avLst/>
-          </a:prstGeom>
-          <a:noFill/>
-        </p:spPr>
-        <p:txBody>
-          <a:bodyPr vertOverflow="overflow" horzOverflow="overflow" vert="horz" wrap="square" lIns="91440" tIns="45720" rIns="91440" bIns="45720" numCol="1" spcCol="0" rtlCol="0" fromWordArt="0" anchor="t" anchorCtr="0" forceAA="0" upright="0" compatLnSpc="0">
-            <a:spAutoFit/>
-          </a:bodyPr>
-          <a:p>
-            <a:pPr>
-              <a:defRPr/>
-            </a:pPr>
-            <a:r>
-              <a:rPr sz="1800" b="1">
-                <a:solidFill>
-                  <a:schemeClr val="bg1">
-                    <a:lumMod val="65000"/>
-                  </a:schemeClr>
-                </a:solidFill>
-                <a:latin typeface="Arial"/>
-                <a:ea typeface="Arial"/>
-                <a:cs typeface="Arial"/>
-              </a:rPr>
-              <a:t>▢</a:t>
-            </a:r>
-            <a:r>
-              <a:rPr lang="fr-FR" sz="1800" b="1" i="0" u="none" strike="noStrike" cap="none" spc="0">
-                <a:solidFill>
-                  <a:schemeClr val="bg1">
-                    <a:lumMod val="65000"/>
-                  </a:schemeClr>
-                </a:solidFill>
-                <a:latin typeface="Arial"/>
-                <a:ea typeface="Arial"/>
-                <a:cs typeface="Arial"/>
-              </a:rPr>
-              <a:t>▢</a:t>
-            </a:r>
-            <a:r>
-              <a:rPr lang="fr-FR" sz="1800" b="1" i="0" u="none" strike="noStrike" cap="none" spc="0">
-                <a:solidFill>
-                  <a:schemeClr val="bg1">
-                    <a:lumMod val="65000"/>
-                  </a:schemeClr>
-                </a:solidFill>
-                <a:latin typeface="Arial"/>
-                <a:ea typeface="Arial"/>
-                <a:cs typeface="Arial"/>
-              </a:rPr>
-              <a:t>▢</a:t>
-            </a:r>
-            <a:r>
-              <a:rPr lang="fr-FR" sz="1800" b="1" i="0" u="none" strike="noStrike" cap="none" spc="0">
-                <a:solidFill>
-                  <a:schemeClr val="bg1">
-                    <a:lumMod val="65000"/>
-                  </a:schemeClr>
-                </a:solidFill>
-                <a:latin typeface="Arial"/>
-                <a:ea typeface="Arial"/>
-                <a:cs typeface="Arial"/>
-              </a:rPr>
-              <a:t>▢</a:t>
-            </a:r>
-            <a:r>
-              <a:rPr lang="fr-FR" sz="1800" b="1" i="0" u="none" strike="noStrike" cap="none" spc="0">
-                <a:solidFill>
-                  <a:schemeClr val="bg1">
-                    <a:lumMod val="65000"/>
-                  </a:schemeClr>
-                </a:solidFill>
-                <a:latin typeface="Arial"/>
-                <a:ea typeface="Arial"/>
-                <a:cs typeface="Arial"/>
-              </a:rPr>
-              <a:t>▢ </a:t>
-            </a:r>
-            <a:r>
-              <a:rPr lang="fr-FR" sz="1800" b="1" i="0" u="none" strike="noStrike" cap="none" spc="0">
-                <a:solidFill>
-                  <a:schemeClr val="bg1">
-                    <a:lumMod val="65000"/>
-                  </a:schemeClr>
-                </a:solidFill>
-                <a:latin typeface="Arial"/>
-                <a:ea typeface="Arial"/>
-                <a:cs typeface="Arial"/>
-              </a:rPr>
-              <a:t>▢</a:t>
-            </a:r>
-            <a:r>
-              <a:rPr lang="fr-FR" sz="1800" b="1" i="0" u="none" strike="noStrike" cap="none" spc="0">
-                <a:solidFill>
-                  <a:schemeClr val="bg1">
-                    <a:lumMod val="65000"/>
-                  </a:schemeClr>
-                </a:solidFill>
-                <a:latin typeface="Arial"/>
-                <a:ea typeface="Arial"/>
-                <a:cs typeface="Arial"/>
-              </a:rPr>
-              <a:t>▢</a:t>
-            </a:r>
-            <a:r>
-              <a:rPr lang="fr-FR" sz="1800" b="1" i="0" u="none" strike="noStrike" cap="none" spc="0">
-                <a:solidFill>
-                  <a:schemeClr val="bg1">
-                    <a:lumMod val="65000"/>
-                  </a:schemeClr>
-                </a:solidFill>
-                <a:latin typeface="Arial"/>
-                <a:ea typeface="Arial"/>
-                <a:cs typeface="Arial"/>
-              </a:rPr>
-              <a:t>▢</a:t>
-            </a:r>
-            <a:r>
-              <a:rPr lang="fr-FR" sz="1800" b="1" i="0" u="none" strike="noStrike" cap="none" spc="0">
-                <a:solidFill>
-                  <a:schemeClr val="bg1">
-                    <a:lumMod val="65000"/>
-                  </a:schemeClr>
-                </a:solidFill>
-                <a:latin typeface="Arial"/>
-                <a:ea typeface="Arial"/>
-                <a:cs typeface="Arial"/>
-              </a:rPr>
-              <a:t>▢</a:t>
-            </a:r>
-            <a:r>
-              <a:rPr lang="fr-FR" sz="1800" b="1" i="0" u="none" strike="noStrike" cap="none" spc="0">
-                <a:solidFill>
-                  <a:schemeClr val="bg1">
-                    <a:lumMod val="65000"/>
-                  </a:schemeClr>
-                </a:solidFill>
-                <a:latin typeface="Arial"/>
-                <a:ea typeface="Arial"/>
-                <a:cs typeface="Arial"/>
-              </a:rPr>
-              <a:t>▢</a:t>
-            </a:r>
-            <a:endParaRPr sz="2200" b="1">
-              <a:solidFill>
-                <a:schemeClr val="bg1">
-                  <a:lumMod val="65000"/>
-                </a:schemeClr>
-              </a:solidFill>
-            </a:endParaRPr>
-          </a:p>
-        </p:txBody>
-      </p:sp>
-      <p:sp>
-        <p:nvSpPr>
-          <p:cNvPr id="346168976" name=""/>
-          <p:cNvSpPr txBox="1"/>
-          <p:nvPr/>
-        </p:nvSpPr>
-        <p:spPr bwMode="auto">
-          <a:xfrm rot="0" flipH="0" flipV="0">
-            <a:off x="5270755" y="9186382"/>
-            <a:ext cx="1546416" cy="385902"/>
-          </a:xfrm>
-          <a:prstGeom prst="rect">
-            <a:avLst/>
-          </a:prstGeom>
-          <a:noFill/>
-        </p:spPr>
-        <p:txBody>
-          <a:bodyPr vertOverflow="overflow" horzOverflow="overflow" vert="horz" wrap="square" lIns="91440" tIns="45720" rIns="91440" bIns="45720" numCol="1" spcCol="0" rtlCol="0" fromWordArt="0" anchor="t" anchorCtr="0" forceAA="0" upright="0" compatLnSpc="0">
-            <a:spAutoFit/>
-          </a:bodyPr>
-          <a:p>
-            <a:pPr>
-              <a:defRPr/>
-            </a:pPr>
-            <a:r>
-              <a:rPr sz="1800" b="1">
-                <a:solidFill>
-                  <a:schemeClr val="bg1">
-                    <a:lumMod val="65000"/>
-                  </a:schemeClr>
-                </a:solidFill>
-                <a:latin typeface="Arial"/>
-                <a:ea typeface="Arial"/>
-                <a:cs typeface="Arial"/>
-              </a:rPr>
-              <a:t>▢</a:t>
-            </a:r>
-            <a:r>
-              <a:rPr lang="fr-FR" sz="1800" b="1" i="0" u="none" strike="noStrike" cap="none" spc="0">
-                <a:solidFill>
-                  <a:schemeClr val="bg1">
-                    <a:lumMod val="65000"/>
-                  </a:schemeClr>
-                </a:solidFill>
-                <a:latin typeface="Arial"/>
-                <a:ea typeface="Arial"/>
-                <a:cs typeface="Arial"/>
-              </a:rPr>
-              <a:t>▢</a:t>
-            </a:r>
-            <a:r>
-              <a:rPr lang="fr-FR" sz="1800" b="1" i="0" u="none" strike="noStrike" cap="none" spc="0">
-                <a:solidFill>
-                  <a:schemeClr val="bg1">
-                    <a:lumMod val="65000"/>
-                  </a:schemeClr>
-                </a:solidFill>
-                <a:latin typeface="Arial"/>
-                <a:ea typeface="Arial"/>
-                <a:cs typeface="Arial"/>
-              </a:rPr>
-              <a:t>▢</a:t>
-            </a:r>
-            <a:r>
-              <a:rPr lang="fr-FR" sz="1800" b="1" i="0" u="none" strike="noStrike" cap="none" spc="0">
-                <a:solidFill>
-                  <a:schemeClr val="bg1">
-                    <a:lumMod val="65000"/>
-                  </a:schemeClr>
-                </a:solidFill>
-                <a:latin typeface="Arial"/>
-                <a:ea typeface="Arial"/>
-                <a:cs typeface="Arial"/>
-              </a:rPr>
-              <a:t>▢</a:t>
-            </a:r>
-            <a:r>
-              <a:rPr lang="fr-FR" sz="1800" b="1" i="0" u="none" strike="noStrike" cap="none" spc="0">
-                <a:solidFill>
-                  <a:schemeClr val="bg1">
-                    <a:lumMod val="65000"/>
-                  </a:schemeClr>
-                </a:solidFill>
-                <a:latin typeface="Arial"/>
-                <a:ea typeface="Arial"/>
-                <a:cs typeface="Arial"/>
-              </a:rPr>
-              <a:t>▢ </a:t>
-            </a:r>
-            <a:r>
-              <a:rPr lang="fr-FR" sz="1800" b="1" i="0" u="none" strike="noStrike" cap="none" spc="0">
-                <a:solidFill>
-                  <a:schemeClr val="bg1">
-                    <a:lumMod val="65000"/>
-                  </a:schemeClr>
-                </a:solidFill>
-                <a:latin typeface="Arial"/>
-                <a:ea typeface="Arial"/>
-                <a:cs typeface="Arial"/>
-              </a:rPr>
-              <a:t>▢</a:t>
-            </a:r>
-            <a:r>
-              <a:rPr lang="fr-FR" sz="1800" b="1" i="0" u="none" strike="noStrike" cap="none" spc="0">
-                <a:solidFill>
-                  <a:schemeClr val="bg1">
-                    <a:lumMod val="65000"/>
-                  </a:schemeClr>
-                </a:solidFill>
-                <a:latin typeface="Arial"/>
-                <a:ea typeface="Arial"/>
-                <a:cs typeface="Arial"/>
-              </a:rPr>
-              <a:t>▢</a:t>
-            </a:r>
-            <a:r>
-              <a:rPr lang="fr-FR" sz="1800" b="1" i="0" u="none" strike="noStrike" cap="none" spc="0">
-                <a:solidFill>
-                  <a:schemeClr val="bg1">
-                    <a:lumMod val="65000"/>
-                  </a:schemeClr>
-                </a:solidFill>
-                <a:latin typeface="Arial"/>
-                <a:ea typeface="Arial"/>
-                <a:cs typeface="Arial"/>
-              </a:rPr>
-              <a:t>▢</a:t>
-            </a:r>
-            <a:r>
-              <a:rPr lang="fr-FR" sz="1800" b="1" i="0" u="none" strike="noStrike" cap="none" spc="0">
-                <a:solidFill>
-                  <a:schemeClr val="bg1">
-                    <a:lumMod val="65000"/>
-                  </a:schemeClr>
-                </a:solidFill>
-                <a:latin typeface="Arial"/>
-                <a:ea typeface="Arial"/>
-                <a:cs typeface="Arial"/>
-              </a:rPr>
-              <a:t>▢</a:t>
-            </a:r>
-            <a:r>
-              <a:rPr lang="fr-FR" sz="1800" b="1" i="0" u="none" strike="noStrike" cap="none" spc="0">
-                <a:solidFill>
-                  <a:schemeClr val="bg1">
-                    <a:lumMod val="65000"/>
-                  </a:schemeClr>
-                </a:solidFill>
-                <a:latin typeface="Arial"/>
-                <a:ea typeface="Arial"/>
-                <a:cs typeface="Arial"/>
-              </a:rPr>
-              <a:t>▢</a:t>
-            </a:r>
-            <a:endParaRPr sz="2200" b="1">
-              <a:solidFill>
-                <a:schemeClr val="bg1">
-                  <a:lumMod val="65000"/>
-                </a:schemeClr>
-              </a:solidFill>
-            </a:endParaRPr>
-          </a:p>
-        </p:txBody>
-      </p:sp>
-      <p:sp>
-        <p:nvSpPr>
-          <p:cNvPr id="316838929" name=""/>
-          <p:cNvSpPr txBox="1"/>
-          <p:nvPr/>
-        </p:nvSpPr>
-        <p:spPr bwMode="auto">
-          <a:xfrm rot="0" flipH="0" flipV="0">
-            <a:off x="5270755" y="9345173"/>
-            <a:ext cx="1546776" cy="385902"/>
-          </a:xfrm>
-          <a:prstGeom prst="rect">
-            <a:avLst/>
-          </a:prstGeom>
-          <a:noFill/>
-        </p:spPr>
-        <p:txBody>
-          <a:bodyPr vertOverflow="overflow" horzOverflow="overflow" vert="horz" wrap="square" lIns="91440" tIns="45720" rIns="91440" bIns="45720" numCol="1" spcCol="0" rtlCol="0" fromWordArt="0" anchor="t" anchorCtr="0" forceAA="0" upright="0" compatLnSpc="0">
-            <a:spAutoFit/>
-          </a:bodyPr>
-          <a:p>
-            <a:pPr>
-              <a:defRPr/>
-            </a:pPr>
-            <a:r>
-              <a:rPr sz="1800" b="1">
-                <a:solidFill>
-                  <a:schemeClr val="bg1">
-                    <a:lumMod val="65000"/>
-                  </a:schemeClr>
-                </a:solidFill>
-                <a:latin typeface="Arial"/>
-                <a:ea typeface="Arial"/>
-                <a:cs typeface="Arial"/>
-              </a:rPr>
-              <a:t>▢</a:t>
-            </a:r>
-            <a:r>
-              <a:rPr lang="fr-FR" sz="1800" b="1" i="0" u="none" strike="noStrike" cap="none" spc="0">
-                <a:solidFill>
-                  <a:schemeClr val="bg1">
-                    <a:lumMod val="65000"/>
-                  </a:schemeClr>
-                </a:solidFill>
-                <a:latin typeface="Arial"/>
-                <a:ea typeface="Arial"/>
-                <a:cs typeface="Arial"/>
-              </a:rPr>
-              <a:t>▢</a:t>
-            </a:r>
-            <a:r>
-              <a:rPr lang="fr-FR" sz="1800" b="1" i="0" u="none" strike="noStrike" cap="none" spc="0">
-                <a:solidFill>
-                  <a:schemeClr val="bg1">
-                    <a:lumMod val="65000"/>
-                  </a:schemeClr>
-                </a:solidFill>
-                <a:latin typeface="Arial"/>
-                <a:ea typeface="Arial"/>
-                <a:cs typeface="Arial"/>
-              </a:rPr>
-              <a:t>▢</a:t>
-            </a:r>
-            <a:r>
-              <a:rPr lang="fr-FR" sz="1800" b="1" i="0" u="none" strike="noStrike" cap="none" spc="0">
-                <a:solidFill>
-                  <a:schemeClr val="bg1">
-                    <a:lumMod val="65000"/>
-                  </a:schemeClr>
-                </a:solidFill>
-                <a:latin typeface="Arial"/>
-                <a:ea typeface="Arial"/>
-                <a:cs typeface="Arial"/>
-              </a:rPr>
-              <a:t>▢</a:t>
-            </a:r>
-            <a:r>
-              <a:rPr lang="fr-FR" sz="1800" b="1" i="0" u="none" strike="noStrike" cap="none" spc="0">
-                <a:solidFill>
-                  <a:schemeClr val="bg1">
-                    <a:lumMod val="65000"/>
-                  </a:schemeClr>
-                </a:solidFill>
-                <a:latin typeface="Arial"/>
-                <a:ea typeface="Arial"/>
-                <a:cs typeface="Arial"/>
-              </a:rPr>
-              <a:t>▢ </a:t>
-            </a:r>
-            <a:r>
-              <a:rPr lang="fr-FR" sz="1800" b="1" i="0" u="none" strike="noStrike" cap="none" spc="0">
-                <a:solidFill>
-                  <a:schemeClr val="bg1">
-                    <a:lumMod val="65000"/>
-                  </a:schemeClr>
-                </a:solidFill>
-                <a:latin typeface="Arial"/>
-                <a:ea typeface="Arial"/>
-                <a:cs typeface="Arial"/>
-              </a:rPr>
-              <a:t>▢</a:t>
-            </a:r>
-            <a:r>
-              <a:rPr lang="fr-FR" sz="1800" b="1" i="0" u="none" strike="noStrike" cap="none" spc="0">
-                <a:solidFill>
-                  <a:schemeClr val="bg1">
-                    <a:lumMod val="65000"/>
-                  </a:schemeClr>
-                </a:solidFill>
-                <a:latin typeface="Arial"/>
-                <a:ea typeface="Arial"/>
-                <a:cs typeface="Arial"/>
-              </a:rPr>
-              <a:t>▢</a:t>
-            </a:r>
-            <a:r>
-              <a:rPr lang="fr-FR" sz="1800" b="1" i="0" u="none" strike="noStrike" cap="none" spc="0">
-                <a:solidFill>
-                  <a:schemeClr val="bg1">
-                    <a:lumMod val="65000"/>
-                  </a:schemeClr>
-                </a:solidFill>
-                <a:latin typeface="Arial"/>
-                <a:ea typeface="Arial"/>
-                <a:cs typeface="Arial"/>
-              </a:rPr>
-              <a:t>▢</a:t>
-            </a:r>
-            <a:r>
-              <a:rPr lang="fr-FR" sz="1800" b="1" i="0" u="none" strike="noStrike" cap="none" spc="0">
-                <a:solidFill>
-                  <a:schemeClr val="bg1">
-                    <a:lumMod val="65000"/>
-                  </a:schemeClr>
-                </a:solidFill>
-                <a:latin typeface="Arial"/>
-                <a:ea typeface="Arial"/>
-                <a:cs typeface="Arial"/>
-              </a:rPr>
-              <a:t>▢</a:t>
-            </a:r>
-            <a:r>
-              <a:rPr lang="fr-FR" sz="1800" b="1" i="0" u="none" strike="noStrike" cap="none" spc="0">
-                <a:solidFill>
-                  <a:schemeClr val="bg1">
-                    <a:lumMod val="65000"/>
-                  </a:schemeClr>
-                </a:solidFill>
-                <a:latin typeface="Arial"/>
-                <a:ea typeface="Arial"/>
-                <a:cs typeface="Arial"/>
-              </a:rPr>
-              <a:t>▢</a:t>
-            </a:r>
-            <a:endParaRPr sz="2200" b="1">
-              <a:solidFill>
-                <a:schemeClr val="bg1">
-                  <a:lumMod val="65000"/>
-                </a:schemeClr>
-              </a:solidFill>
-            </a:endParaRPr>
           </a:p>
         </p:txBody>
       </p:sp>
@@ -10041,7 +9188,7 @@
       </p:grpSpPr>
       <p:sp>
         <p:nvSpPr>
-          <p:cNvPr id="485337054" name=""/>
+          <p:cNvPr id="342584325" name=""/>
           <p:cNvSpPr/>
           <p:nvPr/>
         </p:nvSpPr>
@@ -10084,7 +9231,7 @@
       </p:sp>
       <p:sp>
         <p:nvSpPr>
-          <p:cNvPr id="1749974021" name=""/>
+          <p:cNvPr id="1667762641" name=""/>
           <p:cNvSpPr txBox="1"/>
           <p:nvPr/>
         </p:nvSpPr>
@@ -10150,7 +9297,7 @@
       </p:sp>
       <p:cxnSp>
         <p:nvCxnSpPr>
-          <p:cNvPr id="630201107" name="Connecteur droit 1568760680"/>
+          <p:cNvPr id="1701554271" name="Connecteur droit 1568760680"/>
           <p:cNvCxnSpPr/>
           <p:nvPr/>
         </p:nvCxnSpPr>
@@ -10192,7 +9339,7 @@
       </p:cxnSp>
       <p:sp>
         <p:nvSpPr>
-          <p:cNvPr id="261600234" name="ZoneTexte 1868728971"/>
+          <p:cNvPr id="1753106823" name="ZoneTexte 1868728971"/>
           <p:cNvSpPr txBox="1"/>
           <p:nvPr/>
         </p:nvSpPr>
@@ -10232,7 +9379,7 @@
       </p:sp>
       <p:cxnSp>
         <p:nvCxnSpPr>
-          <p:cNvPr id="755194337" name="Connecteur droit 806540798"/>
+          <p:cNvPr id="1874895995" name="Connecteur droit 806540798"/>
           <p:cNvCxnSpPr/>
           <p:nvPr/>
         </p:nvCxnSpPr>
@@ -10274,7 +9421,7 @@
       </p:cxnSp>
       <p:sp>
         <p:nvSpPr>
-          <p:cNvPr id="630387427" name="ZoneTexte 406616703"/>
+          <p:cNvPr id="1925409996" name="ZoneTexte 406616703"/>
           <p:cNvSpPr txBox="1"/>
           <p:nvPr/>
         </p:nvSpPr>
@@ -10314,7 +9461,7 @@
       </p:sp>
       <p:sp>
         <p:nvSpPr>
-          <p:cNvPr id="1628357421" name="ZoneTexte 1302587497"/>
+          <p:cNvPr id="1432542250" name="ZoneTexte 1302587497"/>
           <p:cNvSpPr txBox="1"/>
           <p:nvPr/>
         </p:nvSpPr>
@@ -10518,7 +9665,7 @@
       </p:sp>
       <p:sp>
         <p:nvSpPr>
-          <p:cNvPr id="1308805756" name="Rectangle 38344096"/>
+          <p:cNvPr id="984545829" name="Rectangle 38344096"/>
           <p:cNvSpPr/>
           <p:nvPr/>
         </p:nvSpPr>
@@ -10558,7 +9705,7 @@
       </p:sp>
       <p:sp>
         <p:nvSpPr>
-          <p:cNvPr id="172557796" name="ZoneTexte 1075280509"/>
+          <p:cNvPr id="1598178677" name="ZoneTexte 1075280509"/>
           <p:cNvSpPr txBox="1"/>
           <p:nvPr/>
         </p:nvSpPr>
@@ -10631,7 +9778,7 @@
       </p:sp>
       <p:sp>
         <p:nvSpPr>
-          <p:cNvPr id="727795876" name="ZoneTexte 226284734"/>
+          <p:cNvPr id="2007586354" name="ZoneTexte 226284734"/>
           <p:cNvSpPr txBox="1"/>
           <p:nvPr/>
         </p:nvSpPr>
@@ -10704,7 +9851,7 @@
       </p:sp>
       <p:sp>
         <p:nvSpPr>
-          <p:cNvPr id="1670902098" name="ZoneTexte 162158187"/>
+          <p:cNvPr id="992153186" name="ZoneTexte 162158187"/>
           <p:cNvSpPr txBox="1"/>
           <p:nvPr/>
         </p:nvSpPr>
@@ -10754,7 +9901,7 @@
       </p:sp>
       <p:sp>
         <p:nvSpPr>
-          <p:cNvPr id="269449638" name="Rectangle : avec coins arrondis en haut 1452601499"/>
+          <p:cNvPr id="117519585" name="Rectangle : avec coins arrondis en haut 1452601499"/>
           <p:cNvSpPr/>
           <p:nvPr/>
         </p:nvSpPr>
@@ -10797,7 +9944,7 @@
       </p:sp>
       <p:sp>
         <p:nvSpPr>
-          <p:cNvPr id="1264614689" name="Rectangle : avec coins arrondis en haut 1782110635"/>
+          <p:cNvPr id="919757012" name="Rectangle : avec coins arrondis en haut 1782110635"/>
           <p:cNvSpPr/>
           <p:nvPr/>
         </p:nvSpPr>
@@ -10843,7 +9990,7 @@
       </p:sp>
       <p:sp>
         <p:nvSpPr>
-          <p:cNvPr id="1995197173" name="Rectangle : avec coins arrondis en haut 945118596"/>
+          <p:cNvPr id="86947435" name="Rectangle : avec coins arrondis en haut 945118596"/>
           <p:cNvSpPr/>
           <p:nvPr/>
         </p:nvSpPr>
@@ -10889,7 +10036,7 @@
       </p:sp>
       <p:sp>
         <p:nvSpPr>
-          <p:cNvPr id="918961277" name=""/>
+          <p:cNvPr id="569631684" name=""/>
           <p:cNvSpPr/>
           <p:nvPr/>
         </p:nvSpPr>
@@ -10931,7 +10078,7 @@
       </p:sp>
       <p:sp>
         <p:nvSpPr>
-          <p:cNvPr id="433376560" name=""/>
+          <p:cNvPr id="785821794" name=""/>
           <p:cNvSpPr txBox="1"/>
           <p:nvPr/>
         </p:nvSpPr>
@@ -10971,7 +10118,7 @@
       </p:sp>
       <p:sp>
         <p:nvSpPr>
-          <p:cNvPr id="344712811" name=""/>
+          <p:cNvPr id="1269411888" name=""/>
           <p:cNvSpPr/>
           <p:nvPr/>
         </p:nvSpPr>
@@ -11042,7 +10189,7 @@
       </p:sp>
       <p:sp>
         <p:nvSpPr>
-          <p:cNvPr id="822562660" name=""/>
+          <p:cNvPr id="1918023211" name=""/>
           <p:cNvSpPr txBox="1"/>
           <p:nvPr/>
         </p:nvSpPr>
@@ -11079,7 +10226,7 @@
       </p:sp>
       <p:sp>
         <p:nvSpPr>
-          <p:cNvPr id="1869324117" name=""/>
+          <p:cNvPr id="1874579217" name=""/>
           <p:cNvSpPr txBox="1"/>
           <p:nvPr/>
         </p:nvSpPr>
@@ -11313,14 +10460,14 @@
       </p:sp>
       <p:sp>
         <p:nvSpPr>
-          <p:cNvPr id="852086003" name=""/>
+          <p:cNvPr id="517276006" name=""/>
           <p:cNvSpPr txBox="1"/>
           <p:nvPr/>
         </p:nvSpPr>
         <p:spPr bwMode="auto">
           <a:xfrm rot="0" flipH="0" flipV="0">
-            <a:off x="142539" y="1901376"/>
-            <a:ext cx="4304277" cy="945239"/>
+            <a:off x="142538" y="1901376"/>
+            <a:ext cx="4313277" cy="945239"/>
           </a:xfrm>
           <a:prstGeom prst="rect">
             <a:avLst/>
@@ -11375,7 +10522,7 @@
                 <a:ea typeface="Arial"/>
                 <a:cs typeface="Arial"/>
               </a:rPr>
-              <a:t> et gagnez 1d6 ou 2d6 en fonction du temps passé entre les épisodes (au MJ de décider). Là où vous n’avez pas mis d’efforts vous pouvez perdre en valeur. </a:t>
+              <a:t> et gagnez 1d6 ou 2d6 en fonction du temps passé entre les épisodes (au MJ de décider). Là où vous n’avez pas mis d’efforts votre score peut baisser. </a:t>
             </a:r>
             <a:r>
               <a:rPr lang="fr-FR" sz="800" b="1" i="0" u="none" strike="noStrike" cap="none" spc="0">
@@ -11592,7 +10739,7 @@
       </p:sp>
       <p:sp>
         <p:nvSpPr>
-          <p:cNvPr id="550848842" name=""/>
+          <p:cNvPr id="1708288660" name=""/>
           <p:cNvSpPr txBox="1"/>
           <p:nvPr/>
         </p:nvSpPr>
@@ -11983,7 +11130,7 @@
       </p:sp>
       <p:sp>
         <p:nvSpPr>
-          <p:cNvPr id="397996081" name=""/>
+          <p:cNvPr id="526166082" name=""/>
           <p:cNvSpPr txBox="1"/>
           <p:nvPr/>
         </p:nvSpPr>
@@ -12374,7 +11521,7 @@
       </p:sp>
       <p:sp>
         <p:nvSpPr>
-          <p:cNvPr id="1980439228" name=""/>
+          <p:cNvPr id="1777298565" name=""/>
           <p:cNvSpPr txBox="1"/>
           <p:nvPr/>
         </p:nvSpPr>
@@ -12765,7 +11912,7 @@
       </p:sp>
       <p:sp>
         <p:nvSpPr>
-          <p:cNvPr id="2111992988" name=""/>
+          <p:cNvPr id="1150680621" name=""/>
           <p:cNvSpPr txBox="1"/>
           <p:nvPr/>
         </p:nvSpPr>
@@ -13156,7 +12303,7 @@
       </p:sp>
       <p:sp>
         <p:nvSpPr>
-          <p:cNvPr id="771286076" name=""/>
+          <p:cNvPr id="90600726" name=""/>
           <p:cNvSpPr txBox="1"/>
           <p:nvPr/>
         </p:nvSpPr>
@@ -13547,7 +12694,7 @@
       </p:sp>
       <p:sp>
         <p:nvSpPr>
-          <p:cNvPr id="1564893991" name=""/>
+          <p:cNvPr id="1874014360" name=""/>
           <p:cNvSpPr txBox="1"/>
           <p:nvPr/>
         </p:nvSpPr>
@@ -13938,7 +13085,7 @@
       </p:sp>
       <p:sp>
         <p:nvSpPr>
-          <p:cNvPr id="24132190" name=""/>
+          <p:cNvPr id="762184310" name=""/>
           <p:cNvSpPr txBox="1"/>
           <p:nvPr/>
         </p:nvSpPr>
@@ -14329,7 +13476,7 @@
       </p:sp>
       <p:sp>
         <p:nvSpPr>
-          <p:cNvPr id="232991173" name=""/>
+          <p:cNvPr id="1105098064" name=""/>
           <p:cNvSpPr txBox="1"/>
           <p:nvPr/>
         </p:nvSpPr>
@@ -14720,7 +13867,7 @@
       </p:sp>
       <p:sp>
         <p:nvSpPr>
-          <p:cNvPr id="141361794" name=""/>
+          <p:cNvPr id="1923716044" name=""/>
           <p:cNvSpPr txBox="1"/>
           <p:nvPr/>
         </p:nvSpPr>
@@ -15111,7 +14258,7 @@
       </p:sp>
       <p:sp>
         <p:nvSpPr>
-          <p:cNvPr id="1765869880" name=""/>
+          <p:cNvPr id="925140641" name=""/>
           <p:cNvSpPr txBox="1"/>
           <p:nvPr/>
         </p:nvSpPr>
@@ -15502,7 +14649,7 @@
       </p:sp>
       <p:sp>
         <p:nvSpPr>
-          <p:cNvPr id="1224842233" name=""/>
+          <p:cNvPr id="1414487026" name=""/>
           <p:cNvSpPr txBox="1"/>
           <p:nvPr/>
         </p:nvSpPr>
@@ -15893,7 +15040,7 @@
       </p:sp>
       <p:sp>
         <p:nvSpPr>
-          <p:cNvPr id="527852477" name=""/>
+          <p:cNvPr id="373578126" name=""/>
           <p:cNvSpPr txBox="1"/>
           <p:nvPr/>
         </p:nvSpPr>
@@ -16284,7 +15431,7 @@
       </p:sp>
       <p:sp>
         <p:nvSpPr>
-          <p:cNvPr id="1990450279" name=""/>
+          <p:cNvPr id="1131354221" name=""/>
           <p:cNvSpPr txBox="1"/>
           <p:nvPr/>
         </p:nvSpPr>
@@ -16675,7 +15822,7 @@
       </p:sp>
       <p:sp>
         <p:nvSpPr>
-          <p:cNvPr id="902056354" name=""/>
+          <p:cNvPr id="1167344577" name=""/>
           <p:cNvSpPr txBox="1"/>
           <p:nvPr/>
         </p:nvSpPr>
@@ -17066,7 +16213,7 @@
       </p:sp>
       <p:sp>
         <p:nvSpPr>
-          <p:cNvPr id="684594148" name=""/>
+          <p:cNvPr id="1814871297" name=""/>
           <p:cNvSpPr txBox="1"/>
           <p:nvPr/>
         </p:nvSpPr>
@@ -17274,7 +16421,7 @@
       </p:sp>
       <p:cxnSp>
         <p:nvCxnSpPr>
-          <p:cNvPr id="1346224713" name="Connecteur droit 806540798"/>
+          <p:cNvPr id="210417914" name="Connecteur droit 806540798"/>
           <p:cNvCxnSpPr/>
           <p:nvPr/>
         </p:nvCxnSpPr>
@@ -17316,7 +16463,7 @@
       </p:cxnSp>
       <p:sp>
         <p:nvSpPr>
-          <p:cNvPr id="441476318" name="ZoneTexte 406616703"/>
+          <p:cNvPr id="64960315" name="ZoneTexte 406616703"/>
           <p:cNvSpPr txBox="1"/>
           <p:nvPr/>
         </p:nvSpPr>
@@ -17356,14 +16503,14 @@
       </p:sp>
       <p:sp>
         <p:nvSpPr>
-          <p:cNvPr id="1521223584" name=""/>
+          <p:cNvPr id="465978417" name="ZoneTexte 1302587497"/>
           <p:cNvSpPr txBox="1"/>
           <p:nvPr/>
         </p:nvSpPr>
         <p:spPr bwMode="auto">
-          <a:xfrm rot="0" flipH="0" flipV="0">
-            <a:off x="58495" y="8374473"/>
-            <a:ext cx="6719196" cy="1463400"/>
+          <a:xfrm flipH="0" flipV="0">
+            <a:off x="45897" y="8391722"/>
+            <a:ext cx="6861396" cy="1463400"/>
           </a:xfrm>
           <a:prstGeom prst="rect">
             <a:avLst/>
@@ -17371,18 +16518,23 @@
           <a:noFill/>
         </p:spPr>
         <p:txBody>
-          <a:bodyPr vertOverflow="overflow" horzOverflow="overflow" vert="horz" wrap="square" lIns="91440" tIns="45720" rIns="91440" bIns="45720" numCol="1" spcCol="0" rtlCol="0" fromWordArt="0" anchor="t" anchorCtr="0" forceAA="0" upright="0" compatLnSpc="0">
+          <a:bodyPr vertOverflow="overflow" horzOverflow="overflow" vert="horz" wrap="square" lIns="91440" tIns="45720" rIns="91440" bIns="45720" numCol="1" spcCol="0" rtlCol="0" fromWordArt="0" anchor="t" anchorCtr="0" forceAA="0" compatLnSpc="0">
             <a:spAutoFit/>
           </a:bodyPr>
-          <a:p>
-            <a:pPr algn="l">
+          <a:lstStyle/>
+          <a:p>
+            <a:pPr>
               <a:lnSpc>
                 <a:spcPct val="150000"/>
               </a:lnSpc>
               <a:defRPr/>
             </a:pPr>
             <a:r>
-              <a:rPr lang="fr-FR" sz="1200" b="0" i="0" u="none" strike="noStrike" cap="none" spc="0">
+              <a:rPr sz="1000"/>
+              <a:t>Milieu et activité familiale : </a:t>
+            </a:r>
+            <a:r>
+              <a:rPr lang="fr-FR" sz="1000" b="0" i="0" u="none" strike="noStrike" cap="none" spc="0">
                 <a:solidFill>
                   <a:schemeClr val="bg2">
                     <a:lumMod val="90000"/>
@@ -17392,33 +16544,206 @@
                 <a:ea typeface="Arial"/>
                 <a:cs typeface="Arial"/>
               </a:rPr>
-              <a:t>_____________________________________________________________</a:t>
-            </a:r>
-            <a:r>
-              <a:rPr lang="fr-FR" sz="1200" b="0" i="0" u="none" strike="noStrike" cap="none" spc="0">
+              <a:t>________________________________________________________________________</a:t>
+            </a:r>
+            <a:br>
+              <a:rPr sz="1000"/>
+            </a:br>
+            <a:r>
+              <a:rPr sz="1000"/>
+              <a:t>Frères et sœurs :</a:t>
+            </a:r>
+            <a:r>
+              <a:rPr sz="1000">
                 <a:solidFill>
                   <a:schemeClr val="bg2">
                     <a:lumMod val="90000"/>
                   </a:schemeClr>
                 </a:solidFill>
-                <a:latin typeface="Arial"/>
-                <a:ea typeface="Arial"/>
-                <a:cs typeface="Arial"/>
-              </a:rPr>
-              <a:t>____________________________________________________________________________________________________________________________________________________________________________________________________________________________________________________________________________________________________________________________________</a:t>
-            </a:r>
-            <a:endParaRPr sz="1200" b="0" i="0" u="none" strike="noStrike" cap="none" spc="0">
+              </a:rPr>
+              <a:t> ________________________________________________________________________________</a:t>
+            </a:r>
+            <a:endParaRPr/>
+          </a:p>
+          <a:p>
+            <a:pPr>
+              <a:lnSpc>
+                <a:spcPct val="150000"/>
+              </a:lnSpc>
+              <a:defRPr/>
+            </a:pPr>
+            <a:r>
+              <a:rPr sz="1000"/>
+              <a:t>Lien d’enfance</a:t>
+            </a:r>
+            <a:r>
+              <a:rPr sz="1000"/>
+              <a:t> : </a:t>
+            </a:r>
+            <a:r>
+              <a:rPr sz="1000">
+                <a:solidFill>
+                  <a:schemeClr val="bg2">
+                    <a:lumMod val="90000"/>
+                  </a:schemeClr>
+                </a:solidFill>
+              </a:rPr>
+              <a:t>________________________________________________________________________________</a:t>
+            </a:r>
+            <a:endParaRPr/>
+          </a:p>
+          <a:p>
+            <a:pPr>
+              <a:lnSpc>
+                <a:spcPct val="150000"/>
+              </a:lnSpc>
+              <a:defRPr/>
+            </a:pPr>
+            <a:r>
+              <a:rPr sz="1000"/>
+              <a:t>Difficultés familiales </a:t>
+            </a:r>
+            <a:r>
+              <a:rPr sz="1000"/>
+              <a:t>: </a:t>
+            </a:r>
+            <a:r>
+              <a:rPr sz="1000">
+                <a:solidFill>
+                  <a:schemeClr val="bg2">
+                    <a:lumMod val="90000"/>
+                  </a:schemeClr>
+                </a:solidFill>
+              </a:rPr>
+              <a:t>____________________________________________________________________________</a:t>
+            </a:r>
+            <a:r>
+              <a:rPr lang="fr-FR" sz="1000" b="0" i="0" u="none" strike="noStrike" cap="none" spc="0">
+                <a:solidFill>
+                  <a:schemeClr val="tx1"/>
+                </a:solidFill>
+                <a:latin typeface="Arial"/>
+                <a:ea typeface="Arial"/>
+                <a:cs typeface="Arial"/>
+              </a:rPr>
+              <a:t>	</a:t>
+            </a:r>
+            <a:endParaRPr/>
+          </a:p>
+          <a:p>
+            <a:pPr>
+              <a:lnSpc>
+                <a:spcPct val="150000"/>
+              </a:lnSpc>
+              <a:defRPr/>
+            </a:pPr>
+            <a:r>
+              <a:rPr lang="fr-FR" sz="1000" b="0" i="0" u="none" strike="noStrike" cap="none" spc="0">
+                <a:latin typeface="Arial"/>
+                <a:ea typeface="Arial"/>
+                <a:cs typeface="Arial"/>
+              </a:rPr>
+              <a:t>Lien de préadolescence:</a:t>
+            </a:r>
+            <a:r>
+              <a:rPr sz="1000"/>
+              <a:t> </a:t>
+            </a:r>
+            <a:r>
+              <a:rPr sz="1000">
+                <a:solidFill>
+                  <a:schemeClr val="bg2">
+                    <a:lumMod val="90000"/>
+                  </a:schemeClr>
+                </a:solidFill>
+              </a:rPr>
+              <a:t>_________________________________________________________________________</a:t>
+            </a:r>
+            <a:endParaRPr sz="1000">
               <a:solidFill>
                 <a:schemeClr val="bg2">
                   <a:lumMod val="90000"/>
                 </a:schemeClr>
               </a:solidFill>
-              <a:latin typeface="Arial"/>
-              <a:ea typeface="Arial"/>
-              <a:cs typeface="Arial"/>
             </a:endParaRPr>
           </a:p>
+          <a:p>
+            <a:pPr>
+              <a:lnSpc>
+                <a:spcPct val="150000"/>
+              </a:lnSpc>
+              <a:defRPr/>
+            </a:pPr>
+            <a:r>
+              <a:rPr lang="fr-FR" sz="1000" b="0" i="0" u="none" strike="noStrike" cap="none" spc="0">
+                <a:solidFill>
+                  <a:schemeClr val="tx1"/>
+                </a:solidFill>
+                <a:latin typeface="Arial"/>
+                <a:ea typeface="Arial"/>
+                <a:cs typeface="Arial"/>
+              </a:rPr>
+              <a:t>Difficultés personnelles : </a:t>
+            </a:r>
+            <a:r>
+              <a:rPr sz="1000">
+                <a:solidFill>
+                  <a:schemeClr val="bg2">
+                    <a:lumMod val="90000"/>
+                  </a:schemeClr>
+                </a:solidFill>
+              </a:rPr>
+              <a:t>_________________________________________________________________________</a:t>
+            </a:r>
+            <a:endParaRPr>
+              <a:solidFill>
+                <a:schemeClr val="bg2">
+                  <a:lumMod val="90000"/>
+                </a:schemeClr>
+              </a:solidFill>
+            </a:endParaRPr>
+          </a:p>
         </p:txBody>
+      </p:sp>
+      <p:sp>
+        <p:nvSpPr>
+          <p:cNvPr id="999805971" name="Rectangle 38344096"/>
+          <p:cNvSpPr/>
+          <p:nvPr/>
+        </p:nvSpPr>
+        <p:spPr bwMode="auto">
+          <a:xfrm flipH="0" flipV="0">
+            <a:off x="6695377" y="8321298"/>
+            <a:ext cx="151434" cy="1474463"/>
+          </a:xfrm>
+          <a:prstGeom prst="rect">
+            <a:avLst/>
+          </a:prstGeom>
+          <a:solidFill>
+            <a:schemeClr val="bg1"/>
+          </a:solidFill>
+          <a:ln w="12700" cap="flat" cmpd="sng" algn="ctr">
+            <a:noFill/>
+            <a:prstDash val="solid"/>
+            <a:miter lim="800000"/>
+          </a:ln>
+        </p:spPr>
+        <p:style>
+          <a:lnRef idx="2">
+            <a:schemeClr val="accent1">
+              <a:shade val="50000"/>
+            </a:schemeClr>
+          </a:lnRef>
+          <a:fillRef idx="1">
+            <a:schemeClr val="accent1"/>
+          </a:fillRef>
+          <a:effectRef idx="0">
+            <a:schemeClr val="accent1"/>
+          </a:effectRef>
+          <a:fontRef idx="minor">
+            <a:schemeClr val="lt1"/>
+          </a:fontRef>
+        </p:style>
       </p:sp>
     </p:spTree>
   </p:cSld>
@@ -17455,7 +16780,7 @@
       </p:grpSpPr>
       <p:cxnSp>
         <p:nvCxnSpPr>
-          <p:cNvPr id="51370687" name="Connecteur droit 266926011"/>
+          <p:cNvPr id="244361793" name="Connecteur droit 266926011"/>
           <p:cNvCxnSpPr/>
           <p:nvPr/>
         </p:nvCxnSpPr>
@@ -17497,7 +16822,7 @@
       </p:cxnSp>
       <p:sp>
         <p:nvSpPr>
-          <p:cNvPr id="2030155601" name="ZoneTexte 1043763612"/>
+          <p:cNvPr id="1213423260" name="ZoneTexte 1043763612"/>
           <p:cNvSpPr txBox="1"/>
           <p:nvPr/>
         </p:nvSpPr>
@@ -17537,7 +16862,7 @@
       </p:sp>
       <p:cxnSp>
         <p:nvCxnSpPr>
-          <p:cNvPr id="655990818" name="Connecteur droit 1586327141"/>
+          <p:cNvPr id="1401344536" name="Connecteur droit 1586327141"/>
           <p:cNvCxnSpPr/>
           <p:nvPr/>
         </p:nvCxnSpPr>
@@ -17580,7 +16905,7 @@
       </p:cxnSp>
       <p:sp>
         <p:nvSpPr>
-          <p:cNvPr id="761148832" name="ZoneTexte 1691387439"/>
+          <p:cNvPr id="1745400006" name="ZoneTexte 1691387439"/>
           <p:cNvSpPr txBox="1"/>
           <p:nvPr/>
         </p:nvSpPr>
@@ -17620,7 +16945,7 @@
       </p:sp>
       <p:cxnSp>
         <p:nvCxnSpPr>
-          <p:cNvPr id="1927788260" name="Connecteur droit 1743707585"/>
+          <p:cNvPr id="2006797067" name="Connecteur droit 1743707585"/>
           <p:cNvCxnSpPr/>
           <p:nvPr/>
         </p:nvCxnSpPr>
@@ -17663,7 +16988,7 @@
       </p:cxnSp>
       <p:sp>
         <p:nvSpPr>
-          <p:cNvPr id="854937027" name="ZoneTexte 1503300725"/>
+          <p:cNvPr id="243615291" name="ZoneTexte 1503300725"/>
           <p:cNvSpPr txBox="1"/>
           <p:nvPr/>
         </p:nvSpPr>
@@ -17745,7 +17070,7 @@
       </p:sp>
       <p:sp>
         <p:nvSpPr>
-          <p:cNvPr id="1394441093" name="Rectangle : avec coins arrondis en haut 1151560973"/>
+          <p:cNvPr id="161109575" name="Rectangle : avec coins arrondis en haut 1151560973"/>
           <p:cNvSpPr/>
           <p:nvPr/>
         </p:nvSpPr>
@@ -17791,7 +17116,7 @@
       </p:sp>
       <p:sp>
         <p:nvSpPr>
-          <p:cNvPr id="1323594208" name="Flèche : pentagone 1610574377"/>
+          <p:cNvPr id="435526717" name="Flèche : pentagone 1610574377"/>
           <p:cNvSpPr/>
           <p:nvPr/>
         </p:nvSpPr>
@@ -17836,7 +17161,7 @@
       </p:sp>
       <p:sp>
         <p:nvSpPr>
-          <p:cNvPr id="700293164" name="Flèche : pentagone 463861063"/>
+          <p:cNvPr id="1583454270" name="Flèche : pentagone 463861063"/>
           <p:cNvSpPr/>
           <p:nvPr/>
         </p:nvSpPr>
@@ -17881,7 +17206,7 @@
       </p:sp>
       <p:sp>
         <p:nvSpPr>
-          <p:cNvPr id="612677833" name="Flèche : pentagone 272004907"/>
+          <p:cNvPr id="347597543" name="Flèche : pentagone 272004907"/>
           <p:cNvSpPr/>
           <p:nvPr/>
         </p:nvSpPr>
@@ -17926,7 +17251,7 @@
       </p:sp>
       <p:sp>
         <p:nvSpPr>
-          <p:cNvPr id="711462972" name="Flèche : pentagone 28174069"/>
+          <p:cNvPr id="1536266135" name="Flèche : pentagone 28174069"/>
           <p:cNvSpPr/>
           <p:nvPr/>
         </p:nvSpPr>
@@ -17971,7 +17296,7 @@
       </p:sp>
       <p:sp>
         <p:nvSpPr>
-          <p:cNvPr id="1244723136" name="Flèche : pentagone 978127220"/>
+          <p:cNvPr id="516152097" name="Flèche : pentagone 978127220"/>
           <p:cNvSpPr/>
           <p:nvPr/>
         </p:nvSpPr>
@@ -18016,7 +17341,7 @@
       </p:sp>
       <p:sp>
         <p:nvSpPr>
-          <p:cNvPr id="360579640" name="ZoneTexte 1693594013"/>
+          <p:cNvPr id="798754539" name="ZoneTexte 1693594013"/>
           <p:cNvSpPr txBox="1"/>
           <p:nvPr/>
         </p:nvSpPr>
@@ -18381,7 +17706,7 @@
       </p:sp>
       <p:sp>
         <p:nvSpPr>
-          <p:cNvPr id="650677522" name="ZoneTexte 1975797288"/>
+          <p:cNvPr id="98862067" name="ZoneTexte 1975797288"/>
           <p:cNvSpPr txBox="1"/>
           <p:nvPr/>
         </p:nvSpPr>
@@ -18421,7 +17746,7 @@
       </p:sp>
       <p:sp>
         <p:nvSpPr>
-          <p:cNvPr id="774654996" name="ZoneTexte 2064865984"/>
+          <p:cNvPr id="1009145032" name="ZoneTexte 2064865984"/>
           <p:cNvSpPr txBox="1"/>
           <p:nvPr/>
         </p:nvSpPr>
@@ -18686,7 +18011,7 @@
       </p:sp>
       <p:sp>
         <p:nvSpPr>
-          <p:cNvPr id="984324018" name="ZoneTexte 1387173154"/>
+          <p:cNvPr id="1723285425" name="ZoneTexte 1387173154"/>
           <p:cNvSpPr txBox="1"/>
           <p:nvPr/>
         </p:nvSpPr>
@@ -19066,7 +18391,7 @@
       </p:sp>
       <p:sp>
         <p:nvSpPr>
-          <p:cNvPr id="1529192805" name="ZoneTexte 523755832"/>
+          <p:cNvPr id="1230780005" name="ZoneTexte 523755832"/>
           <p:cNvSpPr txBox="1"/>
           <p:nvPr/>
         </p:nvSpPr>
@@ -19562,7 +18887,7 @@
       </p:sp>
       <p:cxnSp>
         <p:nvCxnSpPr>
-          <p:cNvPr id="308049474" name="Connecteur droit 2085669542"/>
+          <p:cNvPr id="1474953873" name="Connecteur droit 2085669542"/>
           <p:cNvCxnSpPr/>
           <p:nvPr/>
         </p:nvCxnSpPr>
@@ -19605,7 +18930,7 @@
       </p:cxnSp>
       <p:sp>
         <p:nvSpPr>
-          <p:cNvPr id="1665866136" name="ZoneTexte 34398067"/>
+          <p:cNvPr id="809411242" name="ZoneTexte 34398067"/>
           <p:cNvSpPr txBox="1"/>
           <p:nvPr/>
         </p:nvSpPr>
@@ -19648,7 +18973,7 @@
       </p:sp>
       <p:sp>
         <p:nvSpPr>
-          <p:cNvPr id="861853551" name="ZoneTexte 273581705"/>
+          <p:cNvPr id="1908623244" name="ZoneTexte 273581705"/>
           <p:cNvSpPr txBox="1"/>
           <p:nvPr/>
         </p:nvSpPr>
@@ -19946,7 +19271,7 @@
       </p:sp>
       <p:sp>
         <p:nvSpPr>
-          <p:cNvPr id="940376329" name="ZoneTexte 1727393832"/>
+          <p:cNvPr id="823073506" name="ZoneTexte 1727393832"/>
           <p:cNvSpPr txBox="1"/>
           <p:nvPr/>
         </p:nvSpPr>
@@ -19988,7 +19313,7 @@
       </p:sp>
       <p:sp>
         <p:nvSpPr>
-          <p:cNvPr id="1183379562" name="ZoneTexte 504516740"/>
+          <p:cNvPr id="103051938" name="ZoneTexte 504516740"/>
           <p:cNvSpPr txBox="1"/>
           <p:nvPr/>
         </p:nvSpPr>
@@ -20030,7 +19355,7 @@
       </p:sp>
       <p:sp>
         <p:nvSpPr>
-          <p:cNvPr id="1737963380" name="ZoneTexte 1"/>
+          <p:cNvPr id="973084372" name="ZoneTexte 1"/>
           <p:cNvSpPr txBox="1"/>
           <p:nvPr/>
         </p:nvSpPr>
@@ -21493,7 +20818,7 @@
       </p:sp>
       <p:sp>
         <p:nvSpPr>
-          <p:cNvPr id="1032224572" name="ZoneTexte 2"/>
+          <p:cNvPr id="1888522687" name="ZoneTexte 2"/>
           <p:cNvSpPr txBox="1"/>
           <p:nvPr/>
         </p:nvSpPr>
@@ -22031,7 +21356,7 @@
       </p:sp>
       <p:sp>
         <p:nvSpPr>
-          <p:cNvPr id="2103378489" name=""/>
+          <p:cNvPr id="1646649983" name=""/>
           <p:cNvSpPr/>
           <p:nvPr/>
         </p:nvSpPr>
@@ -22071,7 +21396,7 @@
       </p:sp>
       <p:sp>
         <p:nvSpPr>
-          <p:cNvPr id="690231890" name="Rectangle : avec coins arrondis en haut 1151560973"/>
+          <p:cNvPr id="1304818017" name="Rectangle : avec coins arrondis en haut 1151560973"/>
           <p:cNvSpPr/>
           <p:nvPr/>
         </p:nvSpPr>
@@ -22119,7 +21444,7 @@
       </p:sp>
       <p:sp>
         <p:nvSpPr>
-          <p:cNvPr id="509524490" name=""/>
+          <p:cNvPr id="196159894" name=""/>
           <p:cNvSpPr/>
           <p:nvPr/>
         </p:nvSpPr>
@@ -22159,7 +21484,7 @@
       </p:sp>
       <p:sp>
         <p:nvSpPr>
-          <p:cNvPr id="1604471321" name="Rectangle : avec coins arrondis en haut 1151560973"/>
+          <p:cNvPr id="1490512775" name="Rectangle : avec coins arrondis en haut 1151560973"/>
           <p:cNvSpPr/>
           <p:nvPr/>
         </p:nvSpPr>
@@ -22207,7 +21532,7 @@
       </p:sp>
       <p:sp>
         <p:nvSpPr>
-          <p:cNvPr id="1304013939" name=""/>
+          <p:cNvPr id="1216649628" name=""/>
           <p:cNvSpPr/>
           <p:nvPr/>
         </p:nvSpPr>
@@ -22247,7 +21572,7 @@
       </p:sp>
       <p:sp>
         <p:nvSpPr>
-          <p:cNvPr id="957267439" name="Rectangle : avec coins arrondis en haut 1151560973"/>
+          <p:cNvPr id="36892449" name="Rectangle : avec coins arrondis en haut 1151560973"/>
           <p:cNvSpPr/>
           <p:nvPr/>
         </p:nvSpPr>
@@ -22295,7 +21620,7 @@
       </p:sp>
       <p:sp>
         <p:nvSpPr>
-          <p:cNvPr id="1044241669" name=""/>
+          <p:cNvPr id="1856512423" name=""/>
           <p:cNvSpPr txBox="1"/>
           <p:nvPr/>
         </p:nvSpPr>
@@ -22360,7 +21685,7 @@
       </p:sp>
       <p:sp>
         <p:nvSpPr>
-          <p:cNvPr id="1468565400" name=""/>
+          <p:cNvPr id="1498809153" name=""/>
           <p:cNvSpPr txBox="1"/>
           <p:nvPr/>
         </p:nvSpPr>
@@ -22489,7 +21814,7 @@
       </p:sp>
       <p:sp>
         <p:nvSpPr>
-          <p:cNvPr id="1581871426" name=""/>
+          <p:cNvPr id="801235540" name=""/>
           <p:cNvSpPr/>
           <p:nvPr/>
         </p:nvSpPr>
@@ -22560,7 +21885,7 @@
       </p:sp>
       <p:sp>
         <p:nvSpPr>
-          <p:cNvPr id="697783622" name="Flèche : pentagone 1610574377"/>
+          <p:cNvPr id="2009595527" name="Flèche : pentagone 1610574377"/>
           <p:cNvSpPr/>
           <p:nvPr/>
         </p:nvSpPr>
@@ -22605,7 +21930,7 @@
       </p:sp>
       <p:sp>
         <p:nvSpPr>
-          <p:cNvPr id="1310695694" name="Flèche : pentagone 463861063"/>
+          <p:cNvPr id="838437822" name="Flèche : pentagone 463861063"/>
           <p:cNvSpPr/>
           <p:nvPr/>
         </p:nvSpPr>
@@ -22650,7 +21975,7 @@
       </p:sp>
       <p:sp>
         <p:nvSpPr>
-          <p:cNvPr id="1947802982" name="Flèche : pentagone 272004907"/>
+          <p:cNvPr id="70271975" name="Flèche : pentagone 272004907"/>
           <p:cNvSpPr/>
           <p:nvPr/>
         </p:nvSpPr>
@@ -22728,7 +22053,7 @@
       </p:grpSpPr>
       <p:cxnSp>
         <p:nvCxnSpPr>
-          <p:cNvPr id="1773844373" name="Connecteur droit 1942366049"/>
+          <p:cNvPr id="430382027" name="Connecteur droit 1942366049"/>
           <p:cNvCxnSpPr/>
           <p:nvPr/>
         </p:nvCxnSpPr>
@@ -22771,7 +22096,7 @@
       </p:cxnSp>
       <p:sp>
         <p:nvSpPr>
-          <p:cNvPr id="2069180838" name="ZoneTexte 483029020"/>
+          <p:cNvPr id="174979813" name="ZoneTexte 483029020"/>
           <p:cNvSpPr txBox="1"/>
           <p:nvPr/>
         </p:nvSpPr>
@@ -22811,7 +22136,7 @@
       </p:sp>
       <p:cxnSp>
         <p:nvCxnSpPr>
-          <p:cNvPr id="695932085" name="Connecteur droit 626166318"/>
+          <p:cNvPr id="82712784" name="Connecteur droit 626166318"/>
           <p:cNvCxnSpPr/>
           <p:nvPr/>
         </p:nvCxnSpPr>
@@ -22854,7 +22179,7 @@
       </p:cxnSp>
       <p:sp>
         <p:nvSpPr>
-          <p:cNvPr id="2116808874" name="ZoneTexte 2021489157"/>
+          <p:cNvPr id="799372527" name="ZoneTexte 2021489157"/>
           <p:cNvSpPr txBox="1"/>
           <p:nvPr/>
         </p:nvSpPr>
@@ -22894,7 +22219,7 @@
       </p:sp>
       <p:cxnSp>
         <p:nvCxnSpPr>
-          <p:cNvPr id="729209437" name="Connecteur droit 1991074862"/>
+          <p:cNvPr id="2004872439" name="Connecteur droit 1991074862"/>
           <p:cNvCxnSpPr/>
           <p:nvPr/>
         </p:nvCxnSpPr>
@@ -22937,7 +22262,7 @@
       </p:cxnSp>
       <p:sp>
         <p:nvSpPr>
-          <p:cNvPr id="1438266110" name="ZoneTexte 1094835336"/>
+          <p:cNvPr id="1924485992" name="ZoneTexte 1094835336"/>
           <p:cNvSpPr txBox="1"/>
           <p:nvPr/>
         </p:nvSpPr>
@@ -23019,7 +22344,7 @@
       </p:sp>
       <p:sp>
         <p:nvSpPr>
-          <p:cNvPr id="182263078" name="Rectangle : avec coins arrondis en haut 1574209032"/>
+          <p:cNvPr id="1913014898" name="Rectangle : avec coins arrondis en haut 1574209032"/>
           <p:cNvSpPr/>
           <p:nvPr/>
         </p:nvSpPr>
@@ -23065,7 +22390,7 @@
       </p:sp>
       <p:sp>
         <p:nvSpPr>
-          <p:cNvPr id="1854213721" name="Flèche : pentagone 521086653"/>
+          <p:cNvPr id="673804834" name="Flèche : pentagone 521086653"/>
           <p:cNvSpPr/>
           <p:nvPr/>
         </p:nvSpPr>
@@ -23110,7 +22435,7 @@
       </p:sp>
       <p:sp>
         <p:nvSpPr>
-          <p:cNvPr id="755762214" name="Flèche : pentagone 1507310733"/>
+          <p:cNvPr id="183230507" name="Flèche : pentagone 1507310733"/>
           <p:cNvSpPr/>
           <p:nvPr/>
         </p:nvSpPr>
@@ -23155,7 +22480,7 @@
       </p:sp>
       <p:sp>
         <p:nvSpPr>
-          <p:cNvPr id="980688293" name="Flèche : pentagone 732388424"/>
+          <p:cNvPr id="1800432709" name="Flèche : pentagone 732388424"/>
           <p:cNvSpPr/>
           <p:nvPr/>
         </p:nvSpPr>
@@ -23200,7 +22525,7 @@
       </p:sp>
       <p:sp>
         <p:nvSpPr>
-          <p:cNvPr id="252107384" name="Flèche : pentagone 326874465"/>
+          <p:cNvPr id="272964049" name="Flèche : pentagone 326874465"/>
           <p:cNvSpPr/>
           <p:nvPr/>
         </p:nvSpPr>
@@ -23245,7 +22570,7 @@
       </p:sp>
       <p:sp>
         <p:nvSpPr>
-          <p:cNvPr id="1302093649" name="Flèche : pentagone 2090650957"/>
+          <p:cNvPr id="1259108058" name="Flèche : pentagone 2090650957"/>
           <p:cNvSpPr/>
           <p:nvPr/>
         </p:nvSpPr>
@@ -23290,7 +22615,7 @@
       </p:sp>
       <p:sp>
         <p:nvSpPr>
-          <p:cNvPr id="1015838131" name="ZoneTexte 1374103996"/>
+          <p:cNvPr id="1300586960" name="ZoneTexte 1374103996"/>
           <p:cNvSpPr txBox="1"/>
           <p:nvPr/>
         </p:nvSpPr>
@@ -23577,7 +22902,7 @@
       </p:sp>
       <p:sp>
         <p:nvSpPr>
-          <p:cNvPr id="976290110" name="ZoneTexte 1748705365"/>
+          <p:cNvPr id="416788771" name="ZoneTexte 1748705365"/>
           <p:cNvSpPr txBox="1"/>
           <p:nvPr/>
         </p:nvSpPr>
@@ -23617,7 +22942,7 @@
       </p:sp>
       <p:cxnSp>
         <p:nvCxnSpPr>
-          <p:cNvPr id="274641750" name="Connecteur droit 1556830908"/>
+          <p:cNvPr id="1437050363" name="Connecteur droit 1556830908"/>
           <p:cNvCxnSpPr/>
           <p:nvPr/>
         </p:nvCxnSpPr>
@@ -23660,7 +22985,7 @@
       </p:cxnSp>
       <p:sp>
         <p:nvSpPr>
-          <p:cNvPr id="1149681127" name="ZoneTexte 409639257"/>
+          <p:cNvPr id="1964739457" name="ZoneTexte 409639257"/>
           <p:cNvSpPr txBox="1"/>
           <p:nvPr/>
         </p:nvSpPr>
@@ -23710,7 +23035,7 @@
       </p:sp>
       <p:sp>
         <p:nvSpPr>
-          <p:cNvPr id="1811491143" name="ZoneTexte 1168472887"/>
+          <p:cNvPr id="876834938" name="ZoneTexte 1168472887"/>
           <p:cNvSpPr txBox="1"/>
           <p:nvPr/>
         </p:nvSpPr>
@@ -23995,7 +23320,7 @@
       </p:sp>
       <p:sp>
         <p:nvSpPr>
-          <p:cNvPr id="1942764787" name="ZoneTexte 114796530"/>
+          <p:cNvPr id="1082310704" name="ZoneTexte 114796530"/>
           <p:cNvSpPr txBox="1"/>
           <p:nvPr/>
         </p:nvSpPr>
@@ -24373,7 +23698,7 @@
       </p:sp>
       <p:sp>
         <p:nvSpPr>
-          <p:cNvPr id="504347762" name="ZoneTexte 1085068195"/>
+          <p:cNvPr id="14217906" name="ZoneTexte 1085068195"/>
           <p:cNvSpPr txBox="1"/>
           <p:nvPr/>
         </p:nvSpPr>
@@ -25499,7 +24824,7 @@
       </p:sp>
       <p:sp>
         <p:nvSpPr>
-          <p:cNvPr id="1631813686" name="Étoile : 5 branches 278736380"/>
+          <p:cNvPr id="1671970107" name="Étoile : 5 branches 278736380"/>
           <p:cNvSpPr/>
           <p:nvPr/>
         </p:nvSpPr>
@@ -25546,7 +24871,7 @@
       </p:sp>
       <p:sp>
         <p:nvSpPr>
-          <p:cNvPr id="734927332" name="Étoile : 5 branches 1495350449"/>
+          <p:cNvPr id="528090074" name="Étoile : 5 branches 1495350449"/>
           <p:cNvSpPr/>
           <p:nvPr/>
         </p:nvSpPr>
@@ -25593,7 +24918,7 @@
       </p:sp>
       <p:sp>
         <p:nvSpPr>
-          <p:cNvPr id="156000808" name="Étoile : 5 branches 79046386"/>
+          <p:cNvPr id="345677672" name="Étoile : 5 branches 79046386"/>
           <p:cNvSpPr/>
           <p:nvPr/>
         </p:nvSpPr>
@@ -25640,7 +24965,7 @@
       </p:sp>
       <p:sp>
         <p:nvSpPr>
-          <p:cNvPr id="1327280840" name="Étoile : 5 branches 749256076"/>
+          <p:cNvPr id="1924727752" name="Étoile : 5 branches 749256076"/>
           <p:cNvSpPr/>
           <p:nvPr/>
         </p:nvSpPr>
@@ -25687,7 +25012,7 @@
       </p:sp>
       <p:sp>
         <p:nvSpPr>
-          <p:cNvPr id="706099500" name="Étoile : 5 branches 411245083"/>
+          <p:cNvPr id="1596036746" name="Étoile : 5 branches 411245083"/>
           <p:cNvSpPr/>
           <p:nvPr/>
         </p:nvSpPr>
@@ -25734,7 +25059,7 @@
       </p:sp>
       <p:sp>
         <p:nvSpPr>
-          <p:cNvPr id="313409989" name="ZoneTexte 496444952"/>
+          <p:cNvPr id="897198545" name="ZoneTexte 496444952"/>
           <p:cNvSpPr txBox="1"/>
           <p:nvPr/>
         </p:nvSpPr>
@@ -25776,7 +25101,7 @@
       </p:sp>
       <p:sp>
         <p:nvSpPr>
-          <p:cNvPr id="2073580061" name="ZoneTexte 474433989"/>
+          <p:cNvPr id="1196009927" name="ZoneTexte 474433989"/>
           <p:cNvSpPr txBox="1"/>
           <p:nvPr/>
         </p:nvSpPr>
@@ -25818,14 +25143,14 @@
       </p:sp>
       <p:sp>
         <p:nvSpPr>
-          <p:cNvPr id="1115033643" name="ZoneTexte 1"/>
+          <p:cNvPr id="156511569" name="ZoneTexte 1"/>
           <p:cNvSpPr txBox="1"/>
           <p:nvPr/>
         </p:nvSpPr>
         <p:spPr bwMode="auto">
           <a:xfrm flipH="0" flipV="0">
-            <a:off x="1213" y="480139"/>
-            <a:ext cx="3428865" cy="1600559"/>
+            <a:off x="1212" y="480138"/>
+            <a:ext cx="3429225" cy="1585319"/>
           </a:xfrm>
           <a:prstGeom prst="rect">
             <a:avLst/>
@@ -25883,7 +25208,7 @@
             <a:pPr>
               <a:defRPr/>
             </a:pPr>
-            <a:endParaRPr sz="900" b="0" i="1" u="none" strike="noStrike" cap="none" spc="0">
+            <a:endParaRPr sz="800" b="0" i="1" u="none" strike="noStrike" cap="none" spc="0">
               <a:solidFill>
                 <a:schemeClr val="tx1">
                   <a:lumMod val="50000"/>
@@ -25919,14 +25244,14 @@
       </p:sp>
       <p:sp>
         <p:nvSpPr>
-          <p:cNvPr id="2051111808" name="ZoneTexte 2"/>
+          <p:cNvPr id="730734905" name="ZoneTexte 2"/>
           <p:cNvSpPr txBox="1"/>
           <p:nvPr/>
         </p:nvSpPr>
         <p:spPr bwMode="auto">
           <a:xfrm flipH="0" flipV="0">
-            <a:off x="3374466" y="471205"/>
-            <a:ext cx="3514428" cy="1737719"/>
+            <a:off x="3374465" y="471204"/>
+            <a:ext cx="3515148" cy="1707239"/>
           </a:xfrm>
           <a:prstGeom prst="rect">
             <a:avLst/>
@@ -25970,7 +25295,7 @@
             <a:pPr>
               <a:defRPr/>
             </a:pPr>
-            <a:endParaRPr sz="900" i="1">
+            <a:endParaRPr sz="800" i="1">
               <a:solidFill>
                 <a:schemeClr val="tx1">
                   <a:lumMod val="50000"/>
@@ -26007,7 +25332,7 @@
                 </a:solidFill>
               </a:rPr>
             </a:br>
-            <a:endParaRPr sz="900" i="1">
+            <a:endParaRPr sz="800" i="1">
               <a:solidFill>
                 <a:schemeClr val="tx1">
                   <a:lumMod val="50000"/>
@@ -26037,7 +25362,7 @@
       </p:sp>
       <p:sp>
         <p:nvSpPr>
-          <p:cNvPr id="894147815" name=""/>
+          <p:cNvPr id="104550723" name=""/>
           <p:cNvSpPr/>
           <p:nvPr/>
         </p:nvSpPr>
@@ -26108,7 +25433,7 @@
       </p:sp>
       <p:sp>
         <p:nvSpPr>
-          <p:cNvPr id="57479847" name="Flèche : pentagone 1507310733"/>
+          <p:cNvPr id="363585800" name="Flèche : pentagone 1507310733"/>
           <p:cNvSpPr/>
           <p:nvPr/>
         </p:nvSpPr>
@@ -26153,7 +25478,7 @@
       </p:sp>
       <p:sp>
         <p:nvSpPr>
-          <p:cNvPr id="278150328" name="Flèche : pentagone 732388424"/>
+          <p:cNvPr id="1679626018" name="Flèche : pentagone 732388424"/>
           <p:cNvSpPr/>
           <p:nvPr/>
         </p:nvSpPr>
@@ -26198,7 +25523,7 @@
       </p:sp>
       <p:sp>
         <p:nvSpPr>
-          <p:cNvPr id="2094357770" name="Flèche : pentagone 326874465"/>
+          <p:cNvPr id="2056903797" name="Flèche : pentagone 326874465"/>
           <p:cNvSpPr/>
           <p:nvPr/>
         </p:nvSpPr>
@@ -26276,7 +25601,7 @@
       </p:grpSpPr>
       <p:sp>
         <p:nvSpPr>
-          <p:cNvPr id="2015792959" name="ZoneTexte 273581705"/>
+          <p:cNvPr id="1619566952" name="ZoneTexte 273581705"/>
           <p:cNvSpPr txBox="1"/>
           <p:nvPr/>
         </p:nvSpPr>
@@ -26574,7 +25899,7 @@
       </p:sp>
       <p:cxnSp>
         <p:nvCxnSpPr>
-          <p:cNvPr id="267726942" name="Connecteur droit 1094832104"/>
+          <p:cNvPr id="1755368285" name="Connecteur droit 1094832104"/>
           <p:cNvCxnSpPr/>
           <p:nvPr/>
         </p:nvCxnSpPr>
@@ -26617,7 +25942,7 @@
       </p:cxnSp>
       <p:sp>
         <p:nvSpPr>
-          <p:cNvPr id="456480968" name="ZoneTexte 2078543737"/>
+          <p:cNvPr id="1063117998" name="ZoneTexte 2078543737"/>
           <p:cNvSpPr txBox="1"/>
           <p:nvPr/>
         </p:nvSpPr>
@@ -26657,7 +25982,7 @@
       </p:sp>
       <p:cxnSp>
         <p:nvCxnSpPr>
-          <p:cNvPr id="571152001" name="Connecteur droit 853743145"/>
+          <p:cNvPr id="405169791" name="Connecteur droit 853743145"/>
           <p:cNvCxnSpPr/>
           <p:nvPr/>
         </p:nvCxnSpPr>
@@ -26700,7 +26025,7 @@
       </p:cxnSp>
       <p:sp>
         <p:nvSpPr>
-          <p:cNvPr id="1676109489" name="ZoneTexte 1473119298"/>
+          <p:cNvPr id="598318417" name="ZoneTexte 1473119298"/>
           <p:cNvSpPr txBox="1"/>
           <p:nvPr/>
         </p:nvSpPr>
@@ -26740,7 +26065,7 @@
       </p:sp>
       <p:cxnSp>
         <p:nvCxnSpPr>
-          <p:cNvPr id="1135663496" name="Connecteur droit 1727809509"/>
+          <p:cNvPr id="1966894046" name="Connecteur droit 1727809509"/>
           <p:cNvCxnSpPr/>
           <p:nvPr/>
         </p:nvCxnSpPr>
@@ -26783,7 +26108,7 @@
       </p:cxnSp>
       <p:sp>
         <p:nvSpPr>
-          <p:cNvPr id="219715414" name="ZoneTexte 759238070"/>
+          <p:cNvPr id="1624677059" name="ZoneTexte 759238070"/>
           <p:cNvSpPr txBox="1"/>
           <p:nvPr/>
         </p:nvSpPr>
@@ -26858,7 +26183,7 @@
       </p:sp>
       <p:sp>
         <p:nvSpPr>
-          <p:cNvPr id="929421305" name="Rectangle : avec coins arrondis en haut 965147191"/>
+          <p:cNvPr id="99692570" name="Rectangle : avec coins arrondis en haut 965147191"/>
           <p:cNvSpPr/>
           <p:nvPr/>
         </p:nvSpPr>
@@ -26904,7 +26229,7 @@
       </p:sp>
       <p:sp>
         <p:nvSpPr>
-          <p:cNvPr id="1617622110" name="Flèche : pentagone 2070329900"/>
+          <p:cNvPr id="1988462519" name="Flèche : pentagone 2070329900"/>
           <p:cNvSpPr/>
           <p:nvPr/>
         </p:nvSpPr>
@@ -26949,7 +26274,7 @@
       </p:sp>
       <p:sp>
         <p:nvSpPr>
-          <p:cNvPr id="394459523" name="Flèche : pentagone 1325137089"/>
+          <p:cNvPr id="1215054089" name="Flèche : pentagone 1325137089"/>
           <p:cNvSpPr/>
           <p:nvPr/>
         </p:nvSpPr>
@@ -26994,7 +26319,7 @@
       </p:sp>
       <p:sp>
         <p:nvSpPr>
-          <p:cNvPr id="1640187790" name="Flèche : pentagone 295922856"/>
+          <p:cNvPr id="853385949" name="Flèche : pentagone 295922856"/>
           <p:cNvSpPr/>
           <p:nvPr/>
         </p:nvSpPr>
@@ -27039,7 +26364,7 @@
       </p:sp>
       <p:sp>
         <p:nvSpPr>
-          <p:cNvPr id="1442590686" name="Flèche : pentagone 1961547672"/>
+          <p:cNvPr id="592330365" name="Flèche : pentagone 1961547672"/>
           <p:cNvSpPr/>
           <p:nvPr/>
         </p:nvSpPr>
@@ -27084,7 +26409,7 @@
       </p:sp>
       <p:sp>
         <p:nvSpPr>
-          <p:cNvPr id="1759149447" name="Flèche : pentagone 1305647833"/>
+          <p:cNvPr id="2104440547" name="Flèche : pentagone 1305647833"/>
           <p:cNvSpPr/>
           <p:nvPr/>
         </p:nvSpPr>
@@ -27129,7 +26454,7 @@
       </p:sp>
       <p:sp>
         <p:nvSpPr>
-          <p:cNvPr id="1585755008" name="ZoneTexte 545814566"/>
+          <p:cNvPr id="110162883" name="ZoneTexte 545814566"/>
           <p:cNvSpPr txBox="1"/>
           <p:nvPr/>
         </p:nvSpPr>
@@ -27431,7 +26756,7 @@
       </p:sp>
       <p:sp>
         <p:nvSpPr>
-          <p:cNvPr id="1539595518" name="ZoneTexte 671978155"/>
+          <p:cNvPr id="302053484" name="ZoneTexte 671978155"/>
           <p:cNvSpPr txBox="1"/>
           <p:nvPr/>
         </p:nvSpPr>
@@ -27471,7 +26796,7 @@
       </p:sp>
       <p:cxnSp>
         <p:nvCxnSpPr>
-          <p:cNvPr id="1104828202" name="Connecteur droit 637589304"/>
+          <p:cNvPr id="440044500" name="Connecteur droit 637589304"/>
           <p:cNvCxnSpPr/>
           <p:nvPr/>
         </p:nvCxnSpPr>
@@ -27514,7 +26839,7 @@
       </p:cxnSp>
       <p:sp>
         <p:nvSpPr>
-          <p:cNvPr id="853651187" name="ZoneTexte 172075623"/>
+          <p:cNvPr id="1342353408" name="ZoneTexte 172075623"/>
           <p:cNvSpPr txBox="1"/>
           <p:nvPr/>
         </p:nvSpPr>
@@ -27564,7 +26889,7 @@
       </p:sp>
       <p:sp>
         <p:nvSpPr>
-          <p:cNvPr id="1830772038" name="ZoneTexte 1642812764"/>
+          <p:cNvPr id="627853383" name="ZoneTexte 1642812764"/>
           <p:cNvSpPr txBox="1"/>
           <p:nvPr/>
         </p:nvSpPr>
@@ -27753,7 +27078,7 @@
       </p:sp>
       <p:sp>
         <p:nvSpPr>
-          <p:cNvPr id="1837170297" name="Étoile : 7 branches 1681961038"/>
+          <p:cNvPr id="587345642" name="Étoile : 7 branches 1681961038"/>
           <p:cNvSpPr/>
           <p:nvPr/>
         </p:nvSpPr>
@@ -27800,7 +27125,7 @@
       </p:sp>
       <p:sp>
         <p:nvSpPr>
-          <p:cNvPr id="695635165" name="Étoile : 7 branches 1476951547"/>
+          <p:cNvPr id="2002461301" name="Étoile : 7 branches 1476951547"/>
           <p:cNvSpPr/>
           <p:nvPr/>
         </p:nvSpPr>
@@ -27847,7 +27172,7 @@
       </p:sp>
       <p:sp>
         <p:nvSpPr>
-          <p:cNvPr id="935213571" name="Étoile : 7 branches 1520826925"/>
+          <p:cNvPr id="347159456" name="Étoile : 7 branches 1520826925"/>
           <p:cNvSpPr/>
           <p:nvPr/>
         </p:nvSpPr>
@@ -27894,7 +27219,7 @@
       </p:sp>
       <p:sp>
         <p:nvSpPr>
-          <p:cNvPr id="31504911" name="ZoneTexte 1219899073"/>
+          <p:cNvPr id="1886438639" name="ZoneTexte 1219899073"/>
           <p:cNvSpPr txBox="1"/>
           <p:nvPr/>
         </p:nvSpPr>
@@ -27934,7 +27259,7 @@
       </p:sp>
       <p:sp>
         <p:nvSpPr>
-          <p:cNvPr id="1627549090" name="ZoneTexte 1283574123"/>
+          <p:cNvPr id="179123377" name="ZoneTexte 1283574123"/>
           <p:cNvSpPr txBox="1"/>
           <p:nvPr/>
         </p:nvSpPr>
@@ -28917,7 +28242,7 @@
       </p:sp>
       <p:sp>
         <p:nvSpPr>
-          <p:cNvPr id="1857148213" name="ZoneTexte 790352176"/>
+          <p:cNvPr id="866412808" name="ZoneTexte 790352176"/>
           <p:cNvSpPr txBox="1"/>
           <p:nvPr/>
         </p:nvSpPr>
@@ -28959,7 +28284,7 @@
       </p:sp>
       <p:sp>
         <p:nvSpPr>
-          <p:cNvPr id="1885810782" name="ZoneTexte 2025740189"/>
+          <p:cNvPr id="865375212" name="ZoneTexte 2025740189"/>
           <p:cNvSpPr txBox="1"/>
           <p:nvPr/>
         </p:nvSpPr>
@@ -29016,7 +28341,7 @@
       </p:sp>
       <p:sp>
         <p:nvSpPr>
-          <p:cNvPr id="146392361" name=""/>
+          <p:cNvPr id="1149611499" name=""/>
           <p:cNvSpPr/>
           <p:nvPr/>
         </p:nvSpPr>
@@ -29056,7 +28381,7 @@
       </p:sp>
       <p:sp>
         <p:nvSpPr>
-          <p:cNvPr id="1474734949" name="Rectangle : avec coins arrondis en haut 1151560973"/>
+          <p:cNvPr id="904018832" name="Rectangle : avec coins arrondis en haut 1151560973"/>
           <p:cNvSpPr/>
           <p:nvPr/>
         </p:nvSpPr>
@@ -29104,7 +28429,7 @@
       </p:sp>
       <p:sp>
         <p:nvSpPr>
-          <p:cNvPr id="580373130" name=""/>
+          <p:cNvPr id="196364336" name=""/>
           <p:cNvSpPr/>
           <p:nvPr/>
         </p:nvSpPr>
@@ -29144,7 +28469,7 @@
       </p:sp>
       <p:sp>
         <p:nvSpPr>
-          <p:cNvPr id="1536524895" name="Rectangle : avec coins arrondis en haut 1151560973"/>
+          <p:cNvPr id="796726063" name="Rectangle : avec coins arrondis en haut 1151560973"/>
           <p:cNvSpPr/>
           <p:nvPr/>
         </p:nvSpPr>
@@ -29192,7 +28517,7 @@
       </p:sp>
       <p:sp>
         <p:nvSpPr>
-          <p:cNvPr id="1966548861" name=""/>
+          <p:cNvPr id="375607307" name=""/>
           <p:cNvSpPr/>
           <p:nvPr/>
         </p:nvSpPr>
@@ -29232,7 +28557,7 @@
       </p:sp>
       <p:sp>
         <p:nvSpPr>
-          <p:cNvPr id="1236556843" name="Rectangle : avec coins arrondis en haut 1151560973"/>
+          <p:cNvPr id="216590693" name="Rectangle : avec coins arrondis en haut 1151560973"/>
           <p:cNvSpPr/>
           <p:nvPr/>
         </p:nvSpPr>
@@ -29280,14 +28605,14 @@
       </p:sp>
       <p:sp>
         <p:nvSpPr>
-          <p:cNvPr id="1780714246" name=""/>
+          <p:cNvPr id="892362179" name=""/>
           <p:cNvSpPr txBox="1"/>
           <p:nvPr/>
         </p:nvSpPr>
         <p:spPr bwMode="auto">
           <a:xfrm rot="0" flipH="0" flipV="0">
-            <a:off x="71832" y="545004"/>
-            <a:ext cx="3185389" cy="1768199"/>
+            <a:off x="71831" y="545004"/>
+            <a:ext cx="3186468" cy="1722479"/>
           </a:xfrm>
           <a:prstGeom prst="rect">
             <a:avLst/>
@@ -29367,7 +28692,7 @@
               </a:rPr>
             </a:br>
             <a:br>
-              <a:rPr lang="fr-FR" sz="1000" b="0" i="1" u="none" strike="noStrike" cap="none" spc="0">
+              <a:rPr lang="fr-FR" sz="700" b="0" i="1" u="none" strike="noStrike" cap="none" spc="0">
                 <a:solidFill>
                   <a:schemeClr val="tx1">
                     <a:lumMod val="50000"/>
@@ -29408,14 +28733,14 @@
       </p:sp>
       <p:sp>
         <p:nvSpPr>
-          <p:cNvPr id="1691671122" name=""/>
+          <p:cNvPr id="765230907" name=""/>
           <p:cNvSpPr txBox="1"/>
           <p:nvPr/>
         </p:nvSpPr>
         <p:spPr bwMode="auto">
           <a:xfrm rot="0" flipH="0" flipV="0">
-            <a:off x="3472501" y="545004"/>
-            <a:ext cx="3191508" cy="1768199"/>
+            <a:off x="3472500" y="545004"/>
+            <a:ext cx="3192588" cy="1722479"/>
           </a:xfrm>
           <a:prstGeom prst="rect">
             <a:avLst/>
@@ -29478,6 +28803,44 @@
               </a:spcAft>
               <a:defRPr/>
             </a:pPr>
+            <a:endParaRPr sz="700" b="0" i="1" u="none" strike="noStrike" cap="none" spc="0">
+              <a:solidFill>
+                <a:schemeClr val="tx1">
+                  <a:lumMod val="50000"/>
+                  <a:lumOff val="50000"/>
+                </a:schemeClr>
+              </a:solidFill>
+              <a:latin typeface="Arial"/>
+              <a:cs typeface="Arial"/>
+            </a:endParaRPr>
+          </a:p>
+          <a:p>
+            <a:pPr marL="0" marR="0" indent="0" algn="l">
+              <a:lnSpc>
+                <a:spcPct val="100000"/>
+              </a:lnSpc>
+              <a:spcBef>
+                <a:spcPts val="0"/>
+              </a:spcBef>
+              <a:spcAft>
+                <a:spcPts val="0"/>
+              </a:spcAft>
+              <a:defRPr/>
+            </a:pPr>
+            <a:r>
+              <a:rPr lang="fr-FR" sz="1000" b="0" i="1" u="none" strike="noStrike" cap="none" spc="0">
+                <a:solidFill>
+                  <a:schemeClr val="tx1">
+                    <a:lumMod val="50000"/>
+                    <a:lumOff val="50000"/>
+                  </a:schemeClr>
+                </a:solidFill>
+                <a:latin typeface="Arial"/>
+                <a:ea typeface="Arial"/>
+                <a:cs typeface="Arial"/>
+              </a:rPr>
+              <a:t>Vous ne vieillissez plus et votre corps régénère de ses blessures aisément. Vous éprouvez encore des sensations, des émotions, des désirs et de la douleur. La douleur de ne plus vraiment faire partie du monde des vivants. Elle est sans doute là, votre damnation : vous n’êtes pas tout à fait un monstre. Pas encore.</a:t>
+            </a:r>
             <a:endParaRPr sz="1000" b="0" i="1" u="none" strike="noStrike" cap="none" spc="0">
               <a:solidFill>
                 <a:schemeClr val="tx1">
@@ -29489,49 +28852,11 @@
               <a:cs typeface="Arial"/>
             </a:endParaRPr>
           </a:p>
-          <a:p>
-            <a:pPr marL="0" marR="0" indent="0" algn="l">
-              <a:lnSpc>
-                <a:spcPct val="100000"/>
-              </a:lnSpc>
-              <a:spcBef>
-                <a:spcPts val="0"/>
-              </a:spcBef>
-              <a:spcAft>
-                <a:spcPts val="0"/>
-              </a:spcAft>
-              <a:defRPr/>
-            </a:pPr>
-            <a:r>
-              <a:rPr lang="fr-FR" sz="1000" b="0" i="1" u="none" strike="noStrike" cap="none" spc="0">
-                <a:solidFill>
-                  <a:schemeClr val="tx1">
-                    <a:lumMod val="50000"/>
-                    <a:lumOff val="50000"/>
-                  </a:schemeClr>
-                </a:solidFill>
-                <a:latin typeface="Arial"/>
-                <a:ea typeface="Arial"/>
-                <a:cs typeface="Arial"/>
-              </a:rPr>
-              <a:t>Vous ne vieillissez plus et votre corps régénère de ses blessures aisément. Vous éprouvez encore des sensations, des émotions, des désirs et de la douleur. La douleur de ne plus vraiment faire partie du monde des vivants. Elle est sans doute là, votre damnation : vous n’êtes pas tout à fait un monstre. Pas encore.</a:t>
-            </a:r>
-            <a:endParaRPr sz="1000" b="0" i="1" u="none" strike="noStrike" cap="none" spc="0">
-              <a:solidFill>
-                <a:schemeClr val="tx1">
-                  <a:lumMod val="50000"/>
-                  <a:lumOff val="50000"/>
-                </a:schemeClr>
-              </a:solidFill>
-              <a:latin typeface="Arial"/>
-              <a:cs typeface="Arial"/>
-            </a:endParaRPr>
-          </a:p>
         </p:txBody>
       </p:sp>
       <p:sp>
         <p:nvSpPr>
-          <p:cNvPr id="921040287" name=""/>
+          <p:cNvPr id="1606317002" name=""/>
           <p:cNvSpPr/>
           <p:nvPr/>
         </p:nvSpPr>
@@ -29602,7 +28927,7 @@
       </p:sp>
       <p:sp>
         <p:nvSpPr>
-          <p:cNvPr id="2060426492" name="Flèche : pentagone 1325137089"/>
+          <p:cNvPr id="2094348811" name="Flèche : pentagone 1325137089"/>
           <p:cNvSpPr/>
           <p:nvPr/>
         </p:nvSpPr>
@@ -29647,7 +28972,7 @@
       </p:sp>
       <p:sp>
         <p:nvSpPr>
-          <p:cNvPr id="1485234592" name="Flèche : pentagone 295922856"/>
+          <p:cNvPr id="1275189834" name="Flèche : pentagone 295922856"/>
           <p:cNvSpPr/>
           <p:nvPr/>
         </p:nvSpPr>
@@ -29692,7 +29017,7 @@
       </p:sp>
       <p:sp>
         <p:nvSpPr>
-          <p:cNvPr id="391101897" name="Flèche : pentagone 1961547672"/>
+          <p:cNvPr id="1132646117" name="Flèche : pentagone 1961547672"/>
           <p:cNvSpPr/>
           <p:nvPr/>
         </p:nvSpPr>
@@ -29770,7 +29095,7 @@
       </p:grpSpPr>
       <p:cxnSp>
         <p:nvCxnSpPr>
-          <p:cNvPr id="128653533" name="Connecteur droit 266926011"/>
+          <p:cNvPr id="1462906287" name="Connecteur droit 266926011"/>
           <p:cNvCxnSpPr/>
           <p:nvPr/>
         </p:nvCxnSpPr>
@@ -29813,7 +29138,7 @@
       </p:cxnSp>
       <p:sp>
         <p:nvSpPr>
-          <p:cNvPr id="609950274" name="ZoneTexte 1043763612"/>
+          <p:cNvPr id="999414230" name="ZoneTexte 1043763612"/>
           <p:cNvSpPr txBox="1"/>
           <p:nvPr/>
         </p:nvSpPr>
@@ -29853,7 +29178,7 @@
       </p:sp>
       <p:cxnSp>
         <p:nvCxnSpPr>
-          <p:cNvPr id="1059030073" name="Connecteur droit 1586327141"/>
+          <p:cNvPr id="1320630755" name="Connecteur droit 1586327141"/>
           <p:cNvCxnSpPr/>
           <p:nvPr/>
         </p:nvCxnSpPr>
@@ -29896,7 +29221,7 @@
       </p:cxnSp>
       <p:sp>
         <p:nvSpPr>
-          <p:cNvPr id="906907939" name="ZoneTexte 1691387439"/>
+          <p:cNvPr id="505838213" name="ZoneTexte 1691387439"/>
           <p:cNvSpPr txBox="1"/>
           <p:nvPr/>
         </p:nvSpPr>
@@ -29936,7 +29261,7 @@
       </p:sp>
       <p:cxnSp>
         <p:nvCxnSpPr>
-          <p:cNvPr id="226433105" name="Connecteur droit 1743707585"/>
+          <p:cNvPr id="134331858" name="Connecteur droit 1743707585"/>
           <p:cNvCxnSpPr/>
           <p:nvPr/>
         </p:nvCxnSpPr>
@@ -29979,7 +29304,7 @@
       </p:cxnSp>
       <p:sp>
         <p:nvSpPr>
-          <p:cNvPr id="1323613220" name="ZoneTexte 1503300725"/>
+          <p:cNvPr id="1328024745" name="ZoneTexte 1503300725"/>
           <p:cNvSpPr txBox="1"/>
           <p:nvPr/>
         </p:nvSpPr>
@@ -30061,7 +29386,7 @@
       </p:sp>
       <p:sp>
         <p:nvSpPr>
-          <p:cNvPr id="2006230970" name="Rectangle : avec coins arrondis en haut 1151560973"/>
+          <p:cNvPr id="1545044518" name="Rectangle : avec coins arrondis en haut 1151560973"/>
           <p:cNvSpPr/>
           <p:nvPr/>
         </p:nvSpPr>
@@ -30107,7 +29432,7 @@
       </p:sp>
       <p:sp>
         <p:nvSpPr>
-          <p:cNvPr id="579943258" name="Flèche : pentagone 1610574377"/>
+          <p:cNvPr id="777792133" name="Flèche : pentagone 1610574377"/>
           <p:cNvSpPr/>
           <p:nvPr/>
         </p:nvSpPr>
@@ -30152,7 +29477,7 @@
       </p:sp>
       <p:sp>
         <p:nvSpPr>
-          <p:cNvPr id="1277884246" name="Flèche : pentagone 463861063"/>
+          <p:cNvPr id="1789544897" name="Flèche : pentagone 463861063"/>
           <p:cNvSpPr/>
           <p:nvPr/>
         </p:nvSpPr>
@@ -30197,7 +29522,7 @@
       </p:sp>
       <p:sp>
         <p:nvSpPr>
-          <p:cNvPr id="1730978801" name="Flèche : pentagone 272004907"/>
+          <p:cNvPr id="2061763220" name="Flèche : pentagone 272004907"/>
           <p:cNvSpPr/>
           <p:nvPr/>
         </p:nvSpPr>
@@ -30242,7 +29567,7 @@
       </p:sp>
       <p:sp>
         <p:nvSpPr>
-          <p:cNvPr id="2014325473" name="Flèche : pentagone 28174069"/>
+          <p:cNvPr id="506050948" name="Flèche : pentagone 28174069"/>
           <p:cNvSpPr/>
           <p:nvPr/>
         </p:nvSpPr>
@@ -30287,7 +29612,7 @@
       </p:sp>
       <p:sp>
         <p:nvSpPr>
-          <p:cNvPr id="507204804" name="Flèche : pentagone 978127220"/>
+          <p:cNvPr id="871098605" name="Flèche : pentagone 978127220"/>
           <p:cNvSpPr/>
           <p:nvPr/>
         </p:nvSpPr>
@@ -30332,7 +29657,7 @@
       </p:sp>
       <p:sp>
         <p:nvSpPr>
-          <p:cNvPr id="438511731" name="ZoneTexte 1693594013"/>
+          <p:cNvPr id="1362587567" name="ZoneTexte 1693594013"/>
           <p:cNvSpPr txBox="1"/>
           <p:nvPr/>
         </p:nvSpPr>
@@ -30683,7 +30008,7 @@
       </p:sp>
       <p:sp>
         <p:nvSpPr>
-          <p:cNvPr id="277853717" name="ZoneTexte 1975797288"/>
+          <p:cNvPr id="791594837" name="ZoneTexte 1975797288"/>
           <p:cNvSpPr txBox="1"/>
           <p:nvPr/>
         </p:nvSpPr>
@@ -30723,7 +30048,7 @@
       </p:sp>
       <p:sp>
         <p:nvSpPr>
-          <p:cNvPr id="1672507006" name="ZoneTexte 2064865984"/>
+          <p:cNvPr id="1785441087" name="ZoneTexte 2064865984"/>
           <p:cNvSpPr txBox="1"/>
           <p:nvPr/>
         </p:nvSpPr>
@@ -30945,7 +30270,7 @@
       </p:sp>
       <p:sp>
         <p:nvSpPr>
-          <p:cNvPr id="2056184526" name="ZoneTexte 1387173154"/>
+          <p:cNvPr id="559939833" name="ZoneTexte 1387173154"/>
           <p:cNvSpPr txBox="1"/>
           <p:nvPr/>
         </p:nvSpPr>
@@ -31197,7 +30522,7 @@
       </p:sp>
       <p:sp>
         <p:nvSpPr>
-          <p:cNvPr id="399936893" name="ZoneTexte 523755832"/>
+          <p:cNvPr id="1796623550" name="ZoneTexte 523755832"/>
           <p:cNvSpPr txBox="1"/>
           <p:nvPr/>
         </p:nvSpPr>
@@ -31457,7 +30782,7 @@
       </p:sp>
       <p:cxnSp>
         <p:nvCxnSpPr>
-          <p:cNvPr id="656146341" name="Connecteur droit 2085669542"/>
+          <p:cNvPr id="1865848553" name="Connecteur droit 2085669542"/>
           <p:cNvCxnSpPr/>
           <p:nvPr/>
         </p:nvCxnSpPr>
@@ -31500,7 +30825,7 @@
       </p:cxnSp>
       <p:sp>
         <p:nvSpPr>
-          <p:cNvPr id="776535059" name="ZoneTexte 34398067"/>
+          <p:cNvPr id="1974568478" name="ZoneTexte 34398067"/>
           <p:cNvSpPr txBox="1"/>
           <p:nvPr/>
         </p:nvSpPr>
@@ -31543,7 +30868,7 @@
       </p:sp>
       <p:sp>
         <p:nvSpPr>
-          <p:cNvPr id="886530406" name="ZoneTexte 273581705"/>
+          <p:cNvPr id="1985722282" name="ZoneTexte 273581705"/>
           <p:cNvSpPr txBox="1"/>
           <p:nvPr/>
         </p:nvSpPr>
@@ -31841,7 +31166,7 @@
       </p:sp>
       <p:sp>
         <p:nvSpPr>
-          <p:cNvPr id="1895624333" name="ZoneTexte 1727393832"/>
+          <p:cNvPr id="583906697" name="ZoneTexte 1727393832"/>
           <p:cNvSpPr txBox="1"/>
           <p:nvPr/>
         </p:nvSpPr>
@@ -31883,7 +31208,7 @@
       </p:sp>
       <p:sp>
         <p:nvSpPr>
-          <p:cNvPr id="1515469671" name="ZoneTexte 504516740"/>
+          <p:cNvPr id="756532011" name="ZoneTexte 504516740"/>
           <p:cNvSpPr txBox="1"/>
           <p:nvPr/>
         </p:nvSpPr>
@@ -31925,14 +31250,14 @@
       </p:sp>
       <p:sp>
         <p:nvSpPr>
-          <p:cNvPr id="37124658" name="ZoneTexte 1"/>
+          <p:cNvPr id="719016746" name="ZoneTexte 1"/>
           <p:cNvSpPr txBox="1"/>
           <p:nvPr/>
         </p:nvSpPr>
         <p:spPr bwMode="auto">
           <a:xfrm flipH="0" flipV="0">
-            <a:off x="3449952" y="531373"/>
-            <a:ext cx="3425020" cy="1768199"/>
+            <a:off x="3449952" y="531372"/>
+            <a:ext cx="3426099" cy="1722479"/>
           </a:xfrm>
           <a:prstGeom prst="rect">
             <a:avLst/>
@@ -31992,6 +31317,35 @@
             <a:pPr>
               <a:defRPr/>
             </a:pPr>
+            <a:endParaRPr sz="700" b="0" i="1" u="none" strike="noStrike" cap="none" spc="0">
+              <a:solidFill>
+                <a:schemeClr val="tx1">
+                  <a:lumMod val="50000"/>
+                  <a:lumOff val="50000"/>
+                </a:schemeClr>
+              </a:solidFill>
+              <a:latin typeface="Times New Roman"/>
+              <a:cs typeface="Times New Roman"/>
+            </a:endParaRPr>
+          </a:p>
+          <a:p>
+            <a:pPr>
+              <a:defRPr/>
+            </a:pPr>
+            <a:r>
+              <a:rPr lang="fr-FR" sz="1000" b="0" i="1" u="none" strike="noStrike" cap="none" spc="0">
+                <a:solidFill>
+                  <a:schemeClr val="tx1">
+                    <a:lumMod val="50000"/>
+                    <a:lumOff val="50000"/>
+                  </a:schemeClr>
+                </a:solidFill>
+                <a:latin typeface="Arial"/>
+                <a:ea typeface="Arial"/>
+                <a:cs typeface="Arial"/>
+              </a:rPr>
+              <a:t>Les animaux ne vous craignent plus et vous considèrent même comme une forme de gardien. Vous êtes cependant devenu extrêmement susceptible au feu et vous éloignez de toute flamme dès que possible.</a:t>
+            </a:r>
             <a:endParaRPr sz="1000" b="0" i="1" u="none" strike="noStrike" cap="none" spc="0">
               <a:solidFill>
                 <a:schemeClr val="tx1">
@@ -32003,47 +31357,18 @@
               <a:cs typeface="Times New Roman"/>
             </a:endParaRPr>
           </a:p>
-          <a:p>
-            <a:pPr>
-              <a:defRPr/>
-            </a:pPr>
-            <a:r>
-              <a:rPr lang="fr-FR" sz="1000" b="0" i="1" u="none" strike="noStrike" cap="none" spc="0">
-                <a:solidFill>
-                  <a:schemeClr val="tx1">
-                    <a:lumMod val="50000"/>
-                    <a:lumOff val="50000"/>
-                  </a:schemeClr>
-                </a:solidFill>
-                <a:latin typeface="Arial"/>
-                <a:ea typeface="Arial"/>
-                <a:cs typeface="Arial"/>
-              </a:rPr>
-              <a:t>Les animaux ne vous craignent plus et vous considèrent même comme une forme de gardien. Vous êtes cependant devenu extrêmement susceptible au feu et vous éloignez de toute flamme dès que possible.</a:t>
-            </a:r>
-            <a:endParaRPr sz="1000" b="0" i="1" u="none" strike="noStrike" cap="none" spc="0">
-              <a:solidFill>
-                <a:schemeClr val="tx1">
-                  <a:lumMod val="50000"/>
-                  <a:lumOff val="50000"/>
-                </a:schemeClr>
-              </a:solidFill>
-              <a:latin typeface="Times New Roman"/>
-              <a:cs typeface="Times New Roman"/>
-            </a:endParaRPr>
-          </a:p>
         </p:txBody>
       </p:sp>
       <p:sp>
         <p:nvSpPr>
-          <p:cNvPr id="39806520" name="ZoneTexte 2"/>
+          <p:cNvPr id="673794740" name="ZoneTexte 2"/>
           <p:cNvSpPr txBox="1"/>
           <p:nvPr/>
         </p:nvSpPr>
         <p:spPr bwMode="auto">
           <a:xfrm>
-            <a:off x="-5164" y="533754"/>
-            <a:ext cx="3443914" cy="1615799"/>
+            <a:off x="-5163" y="533754"/>
+            <a:ext cx="3444993" cy="1570079"/>
           </a:xfrm>
           <a:prstGeom prst="rect">
             <a:avLst/>
@@ -32088,7 +31413,7 @@
               </a:rPr>
             </a:br>
             <a:br>
-              <a:rPr lang="fr-FR" sz="1000" b="0" i="1" u="none" strike="noStrike" cap="none" spc="0">
+              <a:rPr lang="fr-FR" sz="700" b="0" i="1" u="none" strike="noStrike" cap="none" spc="0">
                 <a:solidFill>
                   <a:schemeClr val="tx1">
                     <a:lumMod val="50000"/>
@@ -32120,7 +31445,7 @@
       </p:sp>
       <p:sp>
         <p:nvSpPr>
-          <p:cNvPr id="162999035" name=""/>
+          <p:cNvPr id="1755731485" name=""/>
           <p:cNvSpPr/>
           <p:nvPr/>
         </p:nvSpPr>
@@ -32160,7 +31485,7 @@
       </p:sp>
       <p:sp>
         <p:nvSpPr>
-          <p:cNvPr id="24522179" name="Rectangle : avec coins arrondis en haut 1151560973"/>
+          <p:cNvPr id="1880733768" name="Rectangle : avec coins arrondis en haut 1151560973"/>
           <p:cNvSpPr/>
           <p:nvPr/>
         </p:nvSpPr>
@@ -32208,7 +31533,7 @@
       </p:sp>
       <p:sp>
         <p:nvSpPr>
-          <p:cNvPr id="534317182" name=""/>
+          <p:cNvPr id="1224720377" name=""/>
           <p:cNvSpPr/>
           <p:nvPr/>
         </p:nvSpPr>
@@ -32248,7 +31573,7 @@
       </p:sp>
       <p:sp>
         <p:nvSpPr>
-          <p:cNvPr id="196435173" name="Rectangle : avec coins arrondis en haut 1151560973"/>
+          <p:cNvPr id="1865570198" name="Rectangle : avec coins arrondis en haut 1151560973"/>
           <p:cNvSpPr/>
           <p:nvPr/>
         </p:nvSpPr>
@@ -32296,7 +31621,7 @@
       </p:sp>
       <p:sp>
         <p:nvSpPr>
-          <p:cNvPr id="19195748" name=""/>
+          <p:cNvPr id="1967017288" name=""/>
           <p:cNvSpPr/>
           <p:nvPr/>
         </p:nvSpPr>
@@ -32336,7 +31661,7 @@
       </p:sp>
       <p:sp>
         <p:nvSpPr>
-          <p:cNvPr id="1158107643" name="Rectangle : avec coins arrondis en haut 1151560973"/>
+          <p:cNvPr id="523888935" name="Rectangle : avec coins arrondis en haut 1151560973"/>
           <p:cNvSpPr/>
           <p:nvPr/>
         </p:nvSpPr>
@@ -32384,7 +31709,7 @@
       </p:sp>
       <p:sp>
         <p:nvSpPr>
-          <p:cNvPr id="1111378716" name=""/>
+          <p:cNvPr id="1508839608" name=""/>
           <p:cNvSpPr txBox="1"/>
           <p:nvPr/>
         </p:nvSpPr>
@@ -32435,7 +31760,7 @@
       </p:sp>
       <p:sp>
         <p:nvSpPr>
-          <p:cNvPr id="582845223" name=""/>
+          <p:cNvPr id="400021941" name=""/>
           <p:cNvSpPr txBox="1"/>
           <p:nvPr/>
         </p:nvSpPr>
@@ -32533,7 +31858,7 @@
       </p:sp>
       <p:sp>
         <p:nvSpPr>
-          <p:cNvPr id="1180824339" name=""/>
+          <p:cNvPr id="1886535516" name=""/>
           <p:cNvSpPr/>
           <p:nvPr/>
         </p:nvSpPr>
@@ -32604,7 +31929,7 @@
       </p:sp>
       <p:sp>
         <p:nvSpPr>
-          <p:cNvPr id="1616565120" name="Flèche : pentagone 463861063"/>
+          <p:cNvPr id="412315118" name="Flèche : pentagone 463861063"/>
           <p:cNvSpPr/>
           <p:nvPr/>
         </p:nvSpPr>
@@ -32649,7 +31974,7 @@
       </p:sp>
       <p:sp>
         <p:nvSpPr>
-          <p:cNvPr id="1899160042" name="Flèche : pentagone 272004907"/>
+          <p:cNvPr id="307816281" name="Flèche : pentagone 272004907"/>
           <p:cNvSpPr/>
           <p:nvPr/>
         </p:nvSpPr>
@@ -32694,7 +32019,7 @@
       </p:sp>
       <p:sp>
         <p:nvSpPr>
-          <p:cNvPr id="133210494" name="Flèche : pentagone 28174069"/>
+          <p:cNvPr id="561929146" name="Flèche : pentagone 28174069"/>
           <p:cNvSpPr/>
           <p:nvPr/>
         </p:nvSpPr>

</xml_diff>